<commit_message>
Close the reproduction in the deck: v10.0 recorded, L_con implemented and not run
Two slides join the implementation-issues deck. Slide 8 records v10.0: a
correctly signed, drift-sized displacement in style space is worth +0.0023,
with the post-hoc direction check (cosine +0.593 to the real drift, positive
for every class). The next slide records the decision on L_con: it is
implemented with a pre-registered prediction and deliberately not run,
because the invariance it asks for is to a z_bar_f that v9.0 and v10.0
showed never leaves Batch 1. The summary table and the closing slide are
updated to say the reproduction is complete: none of the paper's three
components reproduces a gain under the source-only protocol.

CLAUDE.md's status lines say the same, so a future session does not treat
L_con as pending work.

Co-Authored-By: Claude Fable 5.1 <noreply@anthropic.com>
</commit_message>
<xml_diff>
--- a/reports/cdcnn-implementation-issues.pptx
+++ b/reports/cdcnn-implementation-issues.pptx
@@ -19,6 +19,8 @@
     <p:sldId id="267" r:id="rId18"/>
     <p:sldId id="268" r:id="rId19"/>
     <p:sldId id="269" r:id="rId20"/>
+    <p:sldId id="270" r:id="rId21"/>
+    <p:sldId id="271" r:id="rId22"/>
   </p:sldIdLst>
   <p:sldSz cx="12191695" cy="6858000" type="screen4x3"/>
   <p:notesSz cx="6858000" cy="9144000"/>
@@ -4584,6 +4586,1677 @@
       <p:grpSpPr/>
       <p:sp>
         <p:nvSpPr>
+          <p:cNvPr id="2" name="Oval 1"/>
+          <p:cNvSpPr/>
+          <p:nvPr/>
+        </p:nvSpPr>
+        <p:spPr>
+          <a:xfrm>
+            <a:off x="548640" y="566928"/>
+            <a:ext cx="566928" cy="566928"/>
+          </a:xfrm>
+          <a:prstGeom prst="ellipse">
+            <a:avLst/>
+          </a:prstGeom>
+          <a:solidFill>
+            <a:srgbClr val="EB6834"/>
+          </a:solidFill>
+          <a:ln>
+            <a:noFill/>
+          </a:ln>
+          <a:effectLst/>
+        </p:spPr>
+        <p:style>
+          <a:lnRef idx="1">
+            <a:schemeClr val="accent1"/>
+          </a:lnRef>
+          <a:fillRef idx="3">
+            <a:schemeClr val="accent1"/>
+          </a:fillRef>
+          <a:effectRef idx="2">
+            <a:schemeClr val="accent1"/>
+          </a:effectRef>
+          <a:fontRef idx="minor">
+            <a:schemeClr val="lt1"/>
+          </a:fontRef>
+        </p:style>
+        <p:txBody>
+          <a:bodyPr rtlCol="0" anchor="ctr" lIns="0" rIns="0" tIns="0" bIns="0"/>
+          <a:lstStyle/>
+          <a:p>
+            <a:pPr algn="ctr"/>
+            <a:r>
+              <a:rPr sz="1500" b="1" i="0">
+                <a:solidFill>
+                  <a:srgbClr val="FFFFFF"/>
+                </a:solidFill>
+                <a:latin typeface="Cambria"/>
+                <a:ea typeface="Microsoft JhengHei"/>
+              </a:rPr>
+              <a:t>8</a:t>
+            </a:r>
+          </a:p>
+        </p:txBody>
+      </p:sp>
+      <p:sp>
+        <p:nvSpPr>
+          <p:cNvPr id="3" name="TextBox 2"/>
+          <p:cNvSpPr txBox="1"/>
+          <p:nvPr/>
+        </p:nvSpPr>
+        <p:spPr>
+          <a:xfrm>
+            <a:off x="1325880" y="457200"/>
+            <a:ext cx="10317175" cy="822960"/>
+          </a:xfrm>
+          <a:prstGeom prst="rect">
+            <a:avLst/>
+          </a:prstGeom>
+          <a:noFill/>
+        </p:spPr>
+        <p:txBody>
+          <a:bodyPr wrap="square" lIns="0" rIns="0" tIns="0" bIns="0" anchor="t">
+            <a:spAutoFit/>
+          </a:bodyPr>
+          <a:lstStyle/>
+          <a:p>
+            <a:pPr algn="l"/>
+            <a:r>
+              <a:rPr sz="3000" b="1" i="0">
+                <a:solidFill>
+                  <a:srgbClr val="2B2D42"/>
+                </a:solidFill>
+                <a:latin typeface="Cambria"/>
+                <a:ea typeface="Microsoft JhengHei"/>
+              </a:rPr>
+              <a:t>把正負號補上也沒用（v10.0）</a:t>
+            </a:r>
+          </a:p>
+          <a:p>
+            <a:pPr>
+              <a:spcBef>
+                <a:spcPts val="400"/>
+              </a:spcBef>
+            </a:pPr>
+            <a:r>
+              <a:rPr sz="1400" b="0" i="0">
+                <a:solidFill>
+                  <a:srgbClr val="66666E"/>
+                </a:solidFill>
+                <a:latin typeface="Calibri"/>
+                <a:ea typeface="Microsoft JhengHei"/>
+              </a:rPr>
+              <a:t>方向用 Batch 1 自己兩個採集區塊的偏移，在 block 3 的 style 空間估，每個 epoch 重估，不碰 target</a:t>
+            </a:r>
+          </a:p>
+        </p:txBody>
+      </p:sp>
+      <p:graphicFrame>
+        <p:nvGraphicFramePr>
+          <p:cNvPr id="4" name="Table 3"/>
+          <p:cNvGraphicFramePr>
+            <a:graphicFrameLocks noGrp="1"/>
+          </p:cNvGraphicFramePr>
+          <p:nvPr/>
+        </p:nvGraphicFramePr>
+        <p:xfrm>
+          <a:off x="548640" y="1600200"/>
+          <a:ext cx="6949438" cy="1828800"/>
+        </p:xfrm>
+        <a:graphic>
+          <a:graphicData uri="http://schemas.openxmlformats.org/drawingml/2006/table">
+            <a:tbl>
+              <a:tblPr firstRow="0" bandRow="0">
+                <a:tableStyleId>{5C22544A-7EE6-4342-B048-85BDC9FD1C3A}</a:tableStyleId>
+              </a:tblPr>
+              <a:tblGrid>
+                <a:gridCol w="1042416"/>
+                <a:gridCol w="2432304"/>
+                <a:gridCol w="972921"/>
+                <a:gridCol w="764438"/>
+                <a:gridCol w="972921"/>
+                <a:gridCol w="764438"/>
+              </a:tblGrid>
+              <a:tr h="365760">
+                <a:tc>
+                  <a:txBody>
+                    <a:bodyPr wrap="square"/>
+                    <a:lstStyle/>
+                    <a:p>
+                      <a:pPr algn="l"/>
+                      <a:r>
+                        <a:rPr sz="1100" b="1" i="0">
+                          <a:solidFill>
+                            <a:srgbClr val="FFFFFF"/>
+                          </a:solidFill>
+                          <a:latin typeface="Calibri"/>
+                          <a:ea typeface="Microsoft JhengHei"/>
+                        </a:rPr>
+                        <a:t>變體</a:t>
+                      </a:r>
+                    </a:p>
+                  </a:txBody>
+                  <a:tcPr marL="73152" marR="73152" marT="27432" marB="27432" anchor="ctr">
+                    <a:solidFill>
+                      <a:srgbClr val="2B2D42"/>
+                    </a:solidFill>
+                  </a:tcPr>
+                </a:tc>
+                <a:tc>
+                  <a:txBody>
+                    <a:bodyPr wrap="square"/>
+                    <a:lstStyle/>
+                    <a:p>
+                      <a:pPr algn="l"/>
+                      <a:r>
+                        <a:rPr sz="1100" b="1" i="0">
+                          <a:solidFill>
+                            <a:srgbClr val="FFFFFF"/>
+                          </a:solidFill>
+                          <a:latin typeface="Calibri"/>
+                          <a:ea typeface="Microsoft JhengHei"/>
+                        </a:rPr>
+                        <a:t>Eq. (14)</a:t>
+                      </a:r>
+                    </a:p>
+                  </a:txBody>
+                  <a:tcPr marL="73152" marR="73152" marT="27432" marB="27432" anchor="ctr">
+                    <a:solidFill>
+                      <a:srgbClr val="2B2D42"/>
+                    </a:solidFill>
+                  </a:tcPr>
+                </a:tc>
+                <a:tc>
+                  <a:txBody>
+                    <a:bodyPr wrap="square"/>
+                    <a:lstStyle/>
+                    <a:p>
+                      <a:pPr algn="r"/>
+                      <a:r>
+                        <a:rPr sz="1100" b="1" i="0">
+                          <a:solidFill>
+                            <a:srgbClr val="FFFFFF"/>
+                          </a:solidFill>
+                          <a:latin typeface="Calibri"/>
+                          <a:ea typeface="Microsoft JhengHei"/>
+                        </a:rPr>
+                        <a:t>target mean</a:t>
+                      </a:r>
+                    </a:p>
+                  </a:txBody>
+                  <a:tcPr marL="73152" marR="73152" marT="27432" marB="27432" anchor="ctr">
+                    <a:solidFill>
+                      <a:srgbClr val="2B2D42"/>
+                    </a:solidFill>
+                  </a:tcPr>
+                </a:tc>
+                <a:tc>
+                  <a:txBody>
+                    <a:bodyPr wrap="square"/>
+                    <a:lstStyle/>
+                    <a:p>
+                      <a:pPr algn="r"/>
+                      <a:r>
+                        <a:rPr sz="1100" b="1" i="0">
+                          <a:solidFill>
+                            <a:srgbClr val="FFFFFF"/>
+                          </a:solidFill>
+                          <a:latin typeface="Calibri"/>
+                          <a:ea typeface="Microsoft JhengHei"/>
+                        </a:rPr>
+                        <a:t>SD</a:t>
+                      </a:r>
+                    </a:p>
+                  </a:txBody>
+                  <a:tcPr marL="73152" marR="73152" marT="27432" marB="27432" anchor="ctr">
+                    <a:solidFill>
+                      <a:srgbClr val="2B2D42"/>
+                    </a:solidFill>
+                  </a:tcPr>
+                </a:tc>
+                <a:tc>
+                  <a:txBody>
+                    <a:bodyPr wrap="square"/>
+                    <a:lstStyle/>
+                    <a:p>
+                      <a:pPr algn="r"/>
+                      <a:r>
+                        <a:rPr sz="1100" b="1" i="0">
+                          <a:solidFill>
+                            <a:srgbClr val="FFFFFF"/>
+                          </a:solidFill>
+                          <a:latin typeface="Calibri"/>
+                          <a:ea typeface="Microsoft JhengHei"/>
+                        </a:rPr>
+                        <a:t>vs R-gen</a:t>
+                      </a:r>
+                    </a:p>
+                  </a:txBody>
+                  <a:tcPr marL="73152" marR="73152" marT="27432" marB="27432" anchor="ctr">
+                    <a:solidFill>
+                      <a:srgbClr val="2B2D42"/>
+                    </a:solidFill>
+                  </a:tcPr>
+                </a:tc>
+                <a:tc>
+                  <a:txBody>
+                    <a:bodyPr wrap="square"/>
+                    <a:lstStyle/>
+                    <a:p>
+                      <a:pPr algn="ctr"/>
+                      <a:r>
+                        <a:rPr sz="1100" b="1" i="0">
+                          <a:solidFill>
+                            <a:srgbClr val="FFFFFF"/>
+                          </a:solidFill>
+                          <a:latin typeface="Calibri"/>
+                          <a:ea typeface="Microsoft JhengHei"/>
+                        </a:rPr>
+                        <a:t>可分辨</a:t>
+                      </a:r>
+                    </a:p>
+                  </a:txBody>
+                  <a:tcPr marL="73152" marR="73152" marT="27432" marB="27432" anchor="ctr">
+                    <a:solidFill>
+                      <a:srgbClr val="2B2D42"/>
+                    </a:solidFill>
+                  </a:tcPr>
+                </a:tc>
+              </a:tr>
+              <a:tr h="365760">
+                <a:tc>
+                  <a:txBody>
+                    <a:bodyPr wrap="square"/>
+                    <a:lstStyle/>
+                    <a:p>
+                      <a:pPr algn="l"/>
+                      <a:r>
+                        <a:rPr sz="1100" b="1" i="0">
+                          <a:solidFill>
+                            <a:srgbClr val="1C1C1E"/>
+                          </a:solidFill>
+                          <a:latin typeface="Calibri"/>
+                          <a:ea typeface="Microsoft JhengHei"/>
+                        </a:rPr>
+                        <a:t>R-gen-shift</a:t>
+                      </a:r>
+                    </a:p>
+                  </a:txBody>
+                  <a:tcPr marL="73152" marR="73152" marT="27432" marB="27432" anchor="ctr">
+                    <a:solidFill>
+                      <a:srgbClr val="F3F4F6"/>
+                    </a:solidFill>
+                  </a:tcPr>
+                </a:tc>
+                <a:tc>
+                  <a:txBody>
+                    <a:bodyPr wrap="square"/>
+                    <a:lstStyle/>
+                    <a:p>
+                      <a:pPr algn="l"/>
+                      <a:r>
+                        <a:rPr sz="1100" b="1" i="0">
+                          <a:solidFill>
+                            <a:srgbClr val="1C1C1E"/>
+                          </a:solidFill>
+                          <a:latin typeface="Calibri"/>
+                          <a:ea typeface="Microsoft JhengHei"/>
+                        </a:rPr>
+                        <a:t>論文噪聲 + 2 個區塊偏移的定向位移</a:t>
+                      </a:r>
+                    </a:p>
+                  </a:txBody>
+                  <a:tcPr marL="73152" marR="73152" marT="27432" marB="27432" anchor="ctr">
+                    <a:solidFill>
+                      <a:srgbClr val="F3F4F6"/>
+                    </a:solidFill>
+                  </a:tcPr>
+                </a:tc>
+                <a:tc>
+                  <a:txBody>
+                    <a:bodyPr wrap="square"/>
+                    <a:lstStyle/>
+                    <a:p>
+                      <a:pPr algn="r"/>
+                      <a:r>
+                        <a:rPr sz="1100" b="1" i="0">
+                          <a:solidFill>
+                            <a:srgbClr val="1C1C1E"/>
+                          </a:solidFill>
+                          <a:latin typeface="Calibri"/>
+                          <a:ea typeface="Microsoft JhengHei"/>
+                        </a:rPr>
+                        <a:t>0.5796</a:t>
+                      </a:r>
+                    </a:p>
+                  </a:txBody>
+                  <a:tcPr marL="73152" marR="73152" marT="27432" marB="27432" anchor="ctr">
+                    <a:solidFill>
+                      <a:srgbClr val="F3F4F6"/>
+                    </a:solidFill>
+                  </a:tcPr>
+                </a:tc>
+                <a:tc>
+                  <a:txBody>
+                    <a:bodyPr wrap="square"/>
+                    <a:lstStyle/>
+                    <a:p>
+                      <a:pPr algn="r"/>
+                      <a:r>
+                        <a:rPr sz="1100" b="1" i="0">
+                          <a:solidFill>
+                            <a:srgbClr val="1C1C1E"/>
+                          </a:solidFill>
+                          <a:latin typeface="Calibri"/>
+                          <a:ea typeface="Microsoft JhengHei"/>
+                        </a:rPr>
+                        <a:t>0.0077</a:t>
+                      </a:r>
+                    </a:p>
+                  </a:txBody>
+                  <a:tcPr marL="73152" marR="73152" marT="27432" marB="27432" anchor="ctr">
+                    <a:solidFill>
+                      <a:srgbClr val="F3F4F6"/>
+                    </a:solidFill>
+                  </a:tcPr>
+                </a:tc>
+                <a:tc>
+                  <a:txBody>
+                    <a:bodyPr wrap="square"/>
+                    <a:lstStyle/>
+                    <a:p>
+                      <a:pPr algn="r"/>
+                      <a:r>
+                        <a:rPr sz="1100" b="1" i="0">
+                          <a:solidFill>
+                            <a:srgbClr val="1C1C1E"/>
+                          </a:solidFill>
+                          <a:latin typeface="Calibri"/>
+                          <a:ea typeface="Microsoft JhengHei"/>
+                        </a:rPr>
+                        <a:t>+0.0023</a:t>
+                      </a:r>
+                    </a:p>
+                  </a:txBody>
+                  <a:tcPr marL="73152" marR="73152" marT="27432" marB="27432" anchor="ctr">
+                    <a:solidFill>
+                      <a:srgbClr val="F3F4F6"/>
+                    </a:solidFill>
+                  </a:tcPr>
+                </a:tc>
+                <a:tc>
+                  <a:txBody>
+                    <a:bodyPr wrap="square"/>
+                    <a:lstStyle/>
+                    <a:p>
+                      <a:pPr algn="ctr"/>
+                      <a:r>
+                        <a:rPr sz="1100" b="1" i="0">
+                          <a:solidFill>
+                            <a:srgbClr val="1C1C1E"/>
+                          </a:solidFill>
+                          <a:latin typeface="Calibri"/>
+                          <a:ea typeface="Microsoft JhengHei"/>
+                        </a:rPr>
+                        <a:t>否</a:t>
+                      </a:r>
+                    </a:p>
+                  </a:txBody>
+                  <a:tcPr marL="73152" marR="73152" marT="27432" marB="27432" anchor="ctr">
+                    <a:solidFill>
+                      <a:srgbClr val="F3F4F6"/>
+                    </a:solidFill>
+                  </a:tcPr>
+                </a:tc>
+              </a:tr>
+              <a:tr h="365760">
+                <a:tc>
+                  <a:txBody>
+                    <a:bodyPr wrap="square"/>
+                    <a:lstStyle/>
+                    <a:p>
+                      <a:pPr algn="l"/>
+                      <a:r>
+                        <a:rPr sz="1100" b="0" i="0">
+                          <a:solidFill>
+                            <a:srgbClr val="1C1C1E"/>
+                          </a:solidFill>
+                          <a:latin typeface="Calibri"/>
+                          <a:ea typeface="Microsoft JhengHei"/>
+                        </a:rPr>
+                        <a:t>R-gen</a:t>
+                      </a:r>
+                    </a:p>
+                  </a:txBody>
+                  <a:tcPr marL="73152" marR="73152" marT="27432" marB="27432" anchor="ctr">
+                    <a:solidFill>
+                      <a:srgbClr val="FFFFFF"/>
+                    </a:solidFill>
+                  </a:tcPr>
+                </a:tc>
+                <a:tc>
+                  <a:txBody>
+                    <a:bodyPr wrap="square"/>
+                    <a:lstStyle/>
+                    <a:p>
+                      <a:pPr algn="l"/>
+                      <a:r>
+                        <a:rPr sz="1100" b="0" i="0">
+                          <a:solidFill>
+                            <a:srgbClr val="1C1C1E"/>
+                          </a:solidFill>
+                          <a:latin typeface="Calibri"/>
+                          <a:ea typeface="Microsoft JhengHei"/>
+                        </a:rPr>
+                        <a:t>論文原版，對稱高斯</a:t>
+                      </a:r>
+                    </a:p>
+                  </a:txBody>
+                  <a:tcPr marL="73152" marR="73152" marT="27432" marB="27432" anchor="ctr">
+                    <a:solidFill>
+                      <a:srgbClr val="FFFFFF"/>
+                    </a:solidFill>
+                  </a:tcPr>
+                </a:tc>
+                <a:tc>
+                  <a:txBody>
+                    <a:bodyPr wrap="square"/>
+                    <a:lstStyle/>
+                    <a:p>
+                      <a:pPr algn="r"/>
+                      <a:r>
+                        <a:rPr sz="1100" b="0" i="0">
+                          <a:solidFill>
+                            <a:srgbClr val="1C1C1E"/>
+                          </a:solidFill>
+                          <a:latin typeface="Calibri"/>
+                          <a:ea typeface="Microsoft JhengHei"/>
+                        </a:rPr>
+                        <a:t>0.5773</a:t>
+                      </a:r>
+                    </a:p>
+                  </a:txBody>
+                  <a:tcPr marL="73152" marR="73152" marT="27432" marB="27432" anchor="ctr">
+                    <a:solidFill>
+                      <a:srgbClr val="FFFFFF"/>
+                    </a:solidFill>
+                  </a:tcPr>
+                </a:tc>
+                <a:tc>
+                  <a:txBody>
+                    <a:bodyPr wrap="square"/>
+                    <a:lstStyle/>
+                    <a:p>
+                      <a:pPr algn="r"/>
+                      <a:r>
+                        <a:rPr sz="1100" b="0" i="0">
+                          <a:solidFill>
+                            <a:srgbClr val="1C1C1E"/>
+                          </a:solidFill>
+                          <a:latin typeface="Calibri"/>
+                          <a:ea typeface="Microsoft JhengHei"/>
+                        </a:rPr>
+                        <a:t>0.0069</a:t>
+                      </a:r>
+                    </a:p>
+                  </a:txBody>
+                  <a:tcPr marL="73152" marR="73152" marT="27432" marB="27432" anchor="ctr">
+                    <a:solidFill>
+                      <a:srgbClr val="FFFFFF"/>
+                    </a:solidFill>
+                  </a:tcPr>
+                </a:tc>
+                <a:tc>
+                  <a:txBody>
+                    <a:bodyPr wrap="square"/>
+                    <a:lstStyle/>
+                    <a:p>
+                      <a:pPr algn="r"/>
+                      <a:r>
+                        <a:rPr sz="1100" b="0" i="0">
+                          <a:solidFill>
+                            <a:srgbClr val="1C1C1E"/>
+                          </a:solidFill>
+                          <a:latin typeface="Calibri"/>
+                          <a:ea typeface="Microsoft JhengHei"/>
+                        </a:rPr>
+                        <a:t>—</a:t>
+                      </a:r>
+                    </a:p>
+                  </a:txBody>
+                  <a:tcPr marL="73152" marR="73152" marT="27432" marB="27432" anchor="ctr">
+                    <a:solidFill>
+                      <a:srgbClr val="FFFFFF"/>
+                    </a:solidFill>
+                  </a:tcPr>
+                </a:tc>
+                <a:tc>
+                  <a:txBody>
+                    <a:bodyPr wrap="square"/>
+                    <a:lstStyle/>
+                    <a:p>
+                      <a:pPr algn="ctr"/>
+                      <a:r>
+                        <a:rPr sz="1100" b="0" i="0">
+                          <a:solidFill>
+                            <a:srgbClr val="1C1C1E"/>
+                          </a:solidFill>
+                          <a:latin typeface="Calibri"/>
+                          <a:ea typeface="Microsoft JhengHei"/>
+                        </a:rPr>
+                        <a:t>—</a:t>
+                      </a:r>
+                    </a:p>
+                  </a:txBody>
+                  <a:tcPr marL="73152" marR="73152" marT="27432" marB="27432" anchor="ctr">
+                    <a:solidFill>
+                      <a:srgbClr val="FFFFFF"/>
+                    </a:solidFill>
+                  </a:tcPr>
+                </a:tc>
+              </a:tr>
+              <a:tr h="365760">
+                <a:tc>
+                  <a:txBody>
+                    <a:bodyPr wrap="square"/>
+                    <a:lstStyle/>
+                    <a:p>
+                      <a:pPr algn="l"/>
+                      <a:r>
+                        <a:rPr sz="1100" b="0" i="0">
+                          <a:solidFill>
+                            <a:srgbClr val="1C1C1E"/>
+                          </a:solidFill>
+                          <a:latin typeface="Calibri"/>
+                          <a:ea typeface="Microsoft JhengHei"/>
+                        </a:rPr>
+                        <a:t>R-aug-t2</a:t>
+                      </a:r>
+                    </a:p>
+                  </a:txBody>
+                  <a:tcPr marL="73152" marR="73152" marT="27432" marB="27432" anchor="ctr">
+                    <a:solidFill>
+                      <a:srgbClr val="FFFFFF"/>
+                    </a:solidFill>
+                  </a:tcPr>
+                </a:tc>
+                <a:tc>
+                  <a:txBody>
+                    <a:bodyPr wrap="square"/>
+                    <a:lstStyle/>
+                    <a:p>
+                      <a:pPr algn="l"/>
+                      <a:r>
+                        <a:rPr sz="1100" b="0" i="0">
+                          <a:solidFill>
+                            <a:srgbClr val="1C1C1E"/>
+                          </a:solidFill>
+                          <a:latin typeface="Calibri"/>
+                          <a:ea typeface="Microsoft JhengHei"/>
+                        </a:rPr>
+                        <a:t>無區塊</a:t>
+                      </a:r>
+                    </a:p>
+                  </a:txBody>
+                  <a:tcPr marL="73152" marR="73152" marT="27432" marB="27432" anchor="ctr">
+                    <a:solidFill>
+                      <a:srgbClr val="FFFFFF"/>
+                    </a:solidFill>
+                  </a:tcPr>
+                </a:tc>
+                <a:tc>
+                  <a:txBody>
+                    <a:bodyPr wrap="square"/>
+                    <a:lstStyle/>
+                    <a:p>
+                      <a:pPr algn="r"/>
+                      <a:r>
+                        <a:rPr sz="1100" b="0" i="0">
+                          <a:solidFill>
+                            <a:srgbClr val="1C1C1E"/>
+                          </a:solidFill>
+                          <a:latin typeface="Calibri"/>
+                          <a:ea typeface="Microsoft JhengHei"/>
+                        </a:rPr>
+                        <a:t>0.5770</a:t>
+                      </a:r>
+                    </a:p>
+                  </a:txBody>
+                  <a:tcPr marL="73152" marR="73152" marT="27432" marB="27432" anchor="ctr">
+                    <a:solidFill>
+                      <a:srgbClr val="FFFFFF"/>
+                    </a:solidFill>
+                  </a:tcPr>
+                </a:tc>
+                <a:tc>
+                  <a:txBody>
+                    <a:bodyPr wrap="square"/>
+                    <a:lstStyle/>
+                    <a:p>
+                      <a:pPr algn="r"/>
+                      <a:r>
+                        <a:rPr sz="1100" b="0" i="0">
+                          <a:solidFill>
+                            <a:srgbClr val="1C1C1E"/>
+                          </a:solidFill>
+                          <a:latin typeface="Calibri"/>
+                          <a:ea typeface="Microsoft JhengHei"/>
+                        </a:rPr>
+                        <a:t>0.0078</a:t>
+                      </a:r>
+                    </a:p>
+                  </a:txBody>
+                  <a:tcPr marL="73152" marR="73152" marT="27432" marB="27432" anchor="ctr">
+                    <a:solidFill>
+                      <a:srgbClr val="FFFFFF"/>
+                    </a:solidFill>
+                  </a:tcPr>
+                </a:tc>
+                <a:tc>
+                  <a:txBody>
+                    <a:bodyPr wrap="square"/>
+                    <a:lstStyle/>
+                    <a:p>
+                      <a:pPr algn="r"/>
+                      <a:r>
+                        <a:rPr sz="1100" b="0" i="0">
+                          <a:solidFill>
+                            <a:srgbClr val="1C1C1E"/>
+                          </a:solidFill>
+                          <a:latin typeface="Calibri"/>
+                          <a:ea typeface="Microsoft JhengHei"/>
+                        </a:rPr>
+                        <a:t>−0.0003</a:t>
+                      </a:r>
+                    </a:p>
+                  </a:txBody>
+                  <a:tcPr marL="73152" marR="73152" marT="27432" marB="27432" anchor="ctr">
+                    <a:solidFill>
+                      <a:srgbClr val="FFFFFF"/>
+                    </a:solidFill>
+                  </a:tcPr>
+                </a:tc>
+                <a:tc>
+                  <a:txBody>
+                    <a:bodyPr wrap="square"/>
+                    <a:lstStyle/>
+                    <a:p>
+                      <a:pPr algn="ctr"/>
+                      <a:r>
+                        <a:rPr sz="1100" b="0" i="0">
+                          <a:solidFill>
+                            <a:srgbClr val="1C1C1E"/>
+                          </a:solidFill>
+                          <a:latin typeface="Calibri"/>
+                          <a:ea typeface="Microsoft JhengHei"/>
+                        </a:rPr>
+                        <a:t>否</a:t>
+                      </a:r>
+                    </a:p>
+                  </a:txBody>
+                  <a:tcPr marL="73152" marR="73152" marT="27432" marB="27432" anchor="ctr">
+                    <a:solidFill>
+                      <a:srgbClr val="FFFFFF"/>
+                    </a:solidFill>
+                  </a:tcPr>
+                </a:tc>
+              </a:tr>
+              <a:tr h="365760">
+                <a:tc>
+                  <a:txBody>
+                    <a:bodyPr wrap="square"/>
+                    <a:lstStyle/>
+                    <a:p>
+                      <a:pPr algn="l"/>
+                      <a:r>
+                        <a:rPr sz="1100" b="0" i="0">
+                          <a:solidFill>
+                            <a:srgbClr val="1C1C1E"/>
+                          </a:solidFill>
+                          <a:latin typeface="Calibri"/>
+                          <a:ea typeface="Microsoft JhengHei"/>
+                        </a:rPr>
+                        <a:t>R-gen-sign</a:t>
+                      </a:r>
+                    </a:p>
+                  </a:txBody>
+                  <a:tcPr marL="73152" marR="73152" marT="27432" marB="27432" anchor="ctr">
+                    <a:solidFill>
+                      <a:srgbClr val="FFFFFF"/>
+                    </a:solidFill>
+                  </a:tcPr>
+                </a:tc>
+                <a:tc>
+                  <a:txBody>
+                    <a:bodyPr wrap="square"/>
+                    <a:lstStyle/>
+                    <a:p>
+                      <a:pPr algn="l"/>
+                      <a:r>
+                        <a:rPr sz="1100" b="0" i="0">
+                          <a:solidFill>
+                            <a:srgbClr val="1C1C1E"/>
+                          </a:solidFill>
+                          <a:latin typeface="Calibri"/>
+                          <a:ea typeface="Microsoft JhengHei"/>
+                        </a:rPr>
+                        <a:t>只修正負號，幅度照論文</a:t>
+                      </a:r>
+                    </a:p>
+                  </a:txBody>
+                  <a:tcPr marL="73152" marR="73152" marT="27432" marB="27432" anchor="ctr">
+                    <a:solidFill>
+                      <a:srgbClr val="FFFFFF"/>
+                    </a:solidFill>
+                  </a:tcPr>
+                </a:tc>
+                <a:tc>
+                  <a:txBody>
+                    <a:bodyPr wrap="square"/>
+                    <a:lstStyle/>
+                    <a:p>
+                      <a:pPr algn="r"/>
+                      <a:r>
+                        <a:rPr sz="1100" b="0" i="0">
+                          <a:solidFill>
+                            <a:srgbClr val="1C1C1E"/>
+                          </a:solidFill>
+                          <a:latin typeface="Calibri"/>
+                          <a:ea typeface="Microsoft JhengHei"/>
+                        </a:rPr>
+                        <a:t>0.5767</a:t>
+                      </a:r>
+                    </a:p>
+                  </a:txBody>
+                  <a:tcPr marL="73152" marR="73152" marT="27432" marB="27432" anchor="ctr">
+                    <a:solidFill>
+                      <a:srgbClr val="FFFFFF"/>
+                    </a:solidFill>
+                  </a:tcPr>
+                </a:tc>
+                <a:tc>
+                  <a:txBody>
+                    <a:bodyPr wrap="square"/>
+                    <a:lstStyle/>
+                    <a:p>
+                      <a:pPr algn="r"/>
+                      <a:r>
+                        <a:rPr sz="1100" b="0" i="0">
+                          <a:solidFill>
+                            <a:srgbClr val="1C1C1E"/>
+                          </a:solidFill>
+                          <a:latin typeface="Calibri"/>
+                          <a:ea typeface="Microsoft JhengHei"/>
+                        </a:rPr>
+                        <a:t>0.0115</a:t>
+                      </a:r>
+                    </a:p>
+                  </a:txBody>
+                  <a:tcPr marL="73152" marR="73152" marT="27432" marB="27432" anchor="ctr">
+                    <a:solidFill>
+                      <a:srgbClr val="FFFFFF"/>
+                    </a:solidFill>
+                  </a:tcPr>
+                </a:tc>
+                <a:tc>
+                  <a:txBody>
+                    <a:bodyPr wrap="square"/>
+                    <a:lstStyle/>
+                    <a:p>
+                      <a:pPr algn="r"/>
+                      <a:r>
+                        <a:rPr sz="1100" b="0" i="0">
+                          <a:solidFill>
+                            <a:srgbClr val="1C1C1E"/>
+                          </a:solidFill>
+                          <a:latin typeface="Calibri"/>
+                          <a:ea typeface="Microsoft JhengHei"/>
+                        </a:rPr>
+                        <a:t>−0.0006</a:t>
+                      </a:r>
+                    </a:p>
+                  </a:txBody>
+                  <a:tcPr marL="73152" marR="73152" marT="27432" marB="27432" anchor="ctr">
+                    <a:solidFill>
+                      <a:srgbClr val="FFFFFF"/>
+                    </a:solidFill>
+                  </a:tcPr>
+                </a:tc>
+                <a:tc>
+                  <a:txBody>
+                    <a:bodyPr wrap="square"/>
+                    <a:lstStyle/>
+                    <a:p>
+                      <a:pPr algn="ctr"/>
+                      <a:r>
+                        <a:rPr sz="1100" b="0" i="0">
+                          <a:solidFill>
+                            <a:srgbClr val="1C1C1E"/>
+                          </a:solidFill>
+                          <a:latin typeface="Calibri"/>
+                          <a:ea typeface="Microsoft JhengHei"/>
+                        </a:rPr>
+                        <a:t>否</a:t>
+                      </a:r>
+                    </a:p>
+                  </a:txBody>
+                  <a:tcPr marL="73152" marR="73152" marT="27432" marB="27432" anchor="ctr">
+                    <a:solidFill>
+                      <a:srgbClr val="FFFFFF"/>
+                    </a:solidFill>
+                  </a:tcPr>
+                </a:tc>
+              </a:tr>
+            </a:tbl>
+          </a:graphicData>
+        </a:graphic>
+      </p:graphicFrame>
+      <p:graphicFrame>
+        <p:nvGraphicFramePr>
+          <p:cNvPr id="5" name="Table 4"/>
+          <p:cNvGraphicFramePr>
+            <a:graphicFrameLocks noGrp="1"/>
+          </p:cNvGraphicFramePr>
+          <p:nvPr/>
+        </p:nvGraphicFramePr>
+        <p:xfrm>
+          <a:off x="7772400" y="1600200"/>
+          <a:ext cx="3886200" cy="2194560"/>
+        </p:xfrm>
+        <a:graphic>
+          <a:graphicData uri="http://schemas.openxmlformats.org/drawingml/2006/table">
+            <a:tbl>
+              <a:tblPr firstRow="0" bandRow="0">
+                <a:tableStyleId>{5C22544A-7EE6-4342-B048-85BDC9FD1C3A}</a:tableStyleId>
+              </a:tblPr>
+              <a:tblGrid>
+                <a:gridCol w="1554480"/>
+                <a:gridCol w="1321308"/>
+                <a:gridCol w="1010412"/>
+              </a:tblGrid>
+              <a:tr h="274320">
+                <a:tc>
+                  <a:txBody>
+                    <a:bodyPr wrap="square"/>
+                    <a:lstStyle/>
+                    <a:p>
+                      <a:pPr algn="l"/>
+                      <a:r>
+                        <a:rPr sz="1100" b="1" i="0">
+                          <a:solidFill>
+                            <a:srgbClr val="FFFFFF"/>
+                          </a:solidFill>
+                          <a:latin typeface="Calibri"/>
+                          <a:ea typeface="Microsoft JhengHei"/>
+                        </a:rPr>
+                        <a:t>類別</a:t>
+                      </a:r>
+                    </a:p>
+                  </a:txBody>
+                  <a:tcPr marL="73152" marR="73152" marT="27432" marB="27432" anchor="ctr">
+                    <a:solidFill>
+                      <a:srgbClr val="2B2D42"/>
+                    </a:solidFill>
+                  </a:tcPr>
+                </a:tc>
+                <a:tc>
+                  <a:txBody>
+                    <a:bodyPr wrap="square"/>
+                    <a:lstStyle/>
+                    <a:p>
+                      <a:pPr algn="r"/>
+                      <a:r>
+                        <a:rPr sz="1100" b="1" i="0">
+                          <a:solidFill>
+                            <a:srgbClr val="FFFFFF"/>
+                          </a:solidFill>
+                          <a:latin typeface="Calibri"/>
+                          <a:ea typeface="Microsoft JhengHei"/>
+                        </a:rPr>
+                        <a:t>cos 與真實漂移</a:t>
+                      </a:r>
+                    </a:p>
+                  </a:txBody>
+                  <a:tcPr marL="73152" marR="73152" marT="27432" marB="27432" anchor="ctr">
+                    <a:solidFill>
+                      <a:srgbClr val="2B2D42"/>
+                    </a:solidFill>
+                  </a:tcPr>
+                </a:tc>
+                <a:tc>
+                  <a:txBody>
+                    <a:bodyPr wrap="square"/>
+                    <a:lstStyle/>
+                    <a:p>
+                      <a:pPr algn="r"/>
+                      <a:r>
+                        <a:rPr sz="1100" b="1" i="0">
+                          <a:solidFill>
+                            <a:srgbClr val="FFFFFF"/>
+                          </a:solidFill>
+                          <a:latin typeface="Calibri"/>
+                          <a:ea typeface="Microsoft JhengHei"/>
+                        </a:rPr>
+                        <a:t>位移 / 漂移</a:t>
+                      </a:r>
+                    </a:p>
+                  </a:txBody>
+                  <a:tcPr marL="73152" marR="73152" marT="27432" marB="27432" anchor="ctr">
+                    <a:solidFill>
+                      <a:srgbClr val="2B2D42"/>
+                    </a:solidFill>
+                  </a:tcPr>
+                </a:tc>
+              </a:tr>
+              <a:tr h="274320">
+                <a:tc>
+                  <a:txBody>
+                    <a:bodyPr wrap="square"/>
+                    <a:lstStyle/>
+                    <a:p>
+                      <a:pPr algn="l"/>
+                      <a:r>
+                        <a:rPr sz="1100" b="0" i="0">
+                          <a:solidFill>
+                            <a:srgbClr val="1C1C1E"/>
+                          </a:solidFill>
+                          <a:latin typeface="Calibri"/>
+                          <a:ea typeface="Microsoft JhengHei"/>
+                        </a:rPr>
+                        <a:t>Ethanol</a:t>
+                      </a:r>
+                    </a:p>
+                  </a:txBody>
+                  <a:tcPr marL="73152" marR="73152" marT="27432" marB="27432" anchor="ctr">
+                    <a:solidFill>
+                      <a:srgbClr val="FFFFFF"/>
+                    </a:solidFill>
+                  </a:tcPr>
+                </a:tc>
+                <a:tc>
+                  <a:txBody>
+                    <a:bodyPr wrap="square"/>
+                    <a:lstStyle/>
+                    <a:p>
+                      <a:pPr algn="r"/>
+                      <a:r>
+                        <a:rPr sz="1100" b="0" i="0">
+                          <a:solidFill>
+                            <a:srgbClr val="1C1C1E"/>
+                          </a:solidFill>
+                          <a:latin typeface="Calibri"/>
+                          <a:ea typeface="Microsoft JhengHei"/>
+                        </a:rPr>
+                        <a:t>+0.769</a:t>
+                      </a:r>
+                    </a:p>
+                  </a:txBody>
+                  <a:tcPr marL="73152" marR="73152" marT="27432" marB="27432" anchor="ctr">
+                    <a:solidFill>
+                      <a:srgbClr val="FFFFFF"/>
+                    </a:solidFill>
+                  </a:tcPr>
+                </a:tc>
+                <a:tc>
+                  <a:txBody>
+                    <a:bodyPr wrap="square"/>
+                    <a:lstStyle/>
+                    <a:p>
+                      <a:pPr algn="r"/>
+                      <a:r>
+                        <a:rPr sz="1100" b="0" i="0">
+                          <a:solidFill>
+                            <a:srgbClr val="1C1C1E"/>
+                          </a:solidFill>
+                          <a:latin typeface="Calibri"/>
+                          <a:ea typeface="Microsoft JhengHei"/>
+                        </a:rPr>
+                        <a:t>1.05</a:t>
+                      </a:r>
+                    </a:p>
+                  </a:txBody>
+                  <a:tcPr marL="73152" marR="73152" marT="27432" marB="27432" anchor="ctr">
+                    <a:solidFill>
+                      <a:srgbClr val="FFFFFF"/>
+                    </a:solidFill>
+                  </a:tcPr>
+                </a:tc>
+              </a:tr>
+              <a:tr h="274320">
+                <a:tc>
+                  <a:txBody>
+                    <a:bodyPr wrap="square"/>
+                    <a:lstStyle/>
+                    <a:p>
+                      <a:pPr algn="l"/>
+                      <a:r>
+                        <a:rPr sz="1100" b="0" i="0">
+                          <a:solidFill>
+                            <a:srgbClr val="1C1C1E"/>
+                          </a:solidFill>
+                          <a:latin typeface="Calibri"/>
+                          <a:ea typeface="Microsoft JhengHei"/>
+                        </a:rPr>
+                        <a:t>Ammonia</a:t>
+                      </a:r>
+                    </a:p>
+                  </a:txBody>
+                  <a:tcPr marL="73152" marR="73152" marT="27432" marB="27432" anchor="ctr">
+                    <a:solidFill>
+                      <a:srgbClr val="FFFFFF"/>
+                    </a:solidFill>
+                  </a:tcPr>
+                </a:tc>
+                <a:tc>
+                  <a:txBody>
+                    <a:bodyPr wrap="square"/>
+                    <a:lstStyle/>
+                    <a:p>
+                      <a:pPr algn="r"/>
+                      <a:r>
+                        <a:rPr sz="1100" b="0" i="0">
+                          <a:solidFill>
+                            <a:srgbClr val="1C1C1E"/>
+                          </a:solidFill>
+                          <a:latin typeface="Calibri"/>
+                          <a:ea typeface="Microsoft JhengHei"/>
+                        </a:rPr>
+                        <a:t>+0.558</a:t>
+                      </a:r>
+                    </a:p>
+                  </a:txBody>
+                  <a:tcPr marL="73152" marR="73152" marT="27432" marB="27432" anchor="ctr">
+                    <a:solidFill>
+                      <a:srgbClr val="FFFFFF"/>
+                    </a:solidFill>
+                  </a:tcPr>
+                </a:tc>
+                <a:tc>
+                  <a:txBody>
+                    <a:bodyPr wrap="square"/>
+                    <a:lstStyle/>
+                    <a:p>
+                      <a:pPr algn="r"/>
+                      <a:r>
+                        <a:rPr sz="1100" b="0" i="0">
+                          <a:solidFill>
+                            <a:srgbClr val="1C1C1E"/>
+                          </a:solidFill>
+                          <a:latin typeface="Calibri"/>
+                          <a:ea typeface="Microsoft JhengHei"/>
+                        </a:rPr>
+                        <a:t>1.16</a:t>
+                      </a:r>
+                    </a:p>
+                  </a:txBody>
+                  <a:tcPr marL="73152" marR="73152" marT="27432" marB="27432" anchor="ctr">
+                    <a:solidFill>
+                      <a:srgbClr val="FFFFFF"/>
+                    </a:solidFill>
+                  </a:tcPr>
+                </a:tc>
+              </a:tr>
+              <a:tr h="274320">
+                <a:tc>
+                  <a:txBody>
+                    <a:bodyPr wrap="square"/>
+                    <a:lstStyle/>
+                    <a:p>
+                      <a:pPr algn="l"/>
+                      <a:r>
+                        <a:rPr sz="1100" b="0" i="0">
+                          <a:solidFill>
+                            <a:srgbClr val="1C1C1E"/>
+                          </a:solidFill>
+                          <a:latin typeface="Calibri"/>
+                          <a:ea typeface="Microsoft JhengHei"/>
+                        </a:rPr>
+                        <a:t>Ethylene</a:t>
+                      </a:r>
+                    </a:p>
+                  </a:txBody>
+                  <a:tcPr marL="73152" marR="73152" marT="27432" marB="27432" anchor="ctr">
+                    <a:solidFill>
+                      <a:srgbClr val="FFFFFF"/>
+                    </a:solidFill>
+                  </a:tcPr>
+                </a:tc>
+                <a:tc>
+                  <a:txBody>
+                    <a:bodyPr wrap="square"/>
+                    <a:lstStyle/>
+                    <a:p>
+                      <a:pPr algn="r"/>
+                      <a:r>
+                        <a:rPr sz="1100" b="0" i="0">
+                          <a:solidFill>
+                            <a:srgbClr val="1C1C1E"/>
+                          </a:solidFill>
+                          <a:latin typeface="Calibri"/>
+                          <a:ea typeface="Microsoft JhengHei"/>
+                        </a:rPr>
+                        <a:t>+0.305</a:t>
+                      </a:r>
+                    </a:p>
+                  </a:txBody>
+                  <a:tcPr marL="73152" marR="73152" marT="27432" marB="27432" anchor="ctr">
+                    <a:solidFill>
+                      <a:srgbClr val="FFFFFF"/>
+                    </a:solidFill>
+                  </a:tcPr>
+                </a:tc>
+                <a:tc>
+                  <a:txBody>
+                    <a:bodyPr wrap="square"/>
+                    <a:lstStyle/>
+                    <a:p>
+                      <a:pPr algn="r"/>
+                      <a:r>
+                        <a:rPr sz="1100" b="0" i="0">
+                          <a:solidFill>
+                            <a:srgbClr val="1C1C1E"/>
+                          </a:solidFill>
+                          <a:latin typeface="Calibri"/>
+                          <a:ea typeface="Microsoft JhengHei"/>
+                        </a:rPr>
+                        <a:t>1.41</a:t>
+                      </a:r>
+                    </a:p>
+                  </a:txBody>
+                  <a:tcPr marL="73152" marR="73152" marT="27432" marB="27432" anchor="ctr">
+                    <a:solidFill>
+                      <a:srgbClr val="FFFFFF"/>
+                    </a:solidFill>
+                  </a:tcPr>
+                </a:tc>
+              </a:tr>
+              <a:tr h="274320">
+                <a:tc>
+                  <a:txBody>
+                    <a:bodyPr wrap="square"/>
+                    <a:lstStyle/>
+                    <a:p>
+                      <a:pPr algn="l"/>
+                      <a:r>
+                        <a:rPr sz="1100" b="0" i="0">
+                          <a:solidFill>
+                            <a:srgbClr val="1C1C1E"/>
+                          </a:solidFill>
+                          <a:latin typeface="Calibri"/>
+                          <a:ea typeface="Microsoft JhengHei"/>
+                        </a:rPr>
+                        <a:t>Acetaldehyde</a:t>
+                      </a:r>
+                    </a:p>
+                  </a:txBody>
+                  <a:tcPr marL="73152" marR="73152" marT="27432" marB="27432" anchor="ctr">
+                    <a:solidFill>
+                      <a:srgbClr val="FFFFFF"/>
+                    </a:solidFill>
+                  </a:tcPr>
+                </a:tc>
+                <a:tc>
+                  <a:txBody>
+                    <a:bodyPr wrap="square"/>
+                    <a:lstStyle/>
+                    <a:p>
+                      <a:pPr algn="r"/>
+                      <a:r>
+                        <a:rPr sz="1100" b="0" i="0">
+                          <a:solidFill>
+                            <a:srgbClr val="1C1C1E"/>
+                          </a:solidFill>
+                          <a:latin typeface="Calibri"/>
+                          <a:ea typeface="Microsoft JhengHei"/>
+                        </a:rPr>
+                        <a:t>+0.596</a:t>
+                      </a:r>
+                    </a:p>
+                  </a:txBody>
+                  <a:tcPr marL="73152" marR="73152" marT="27432" marB="27432" anchor="ctr">
+                    <a:solidFill>
+                      <a:srgbClr val="FFFFFF"/>
+                    </a:solidFill>
+                  </a:tcPr>
+                </a:tc>
+                <a:tc>
+                  <a:txBody>
+                    <a:bodyPr wrap="square"/>
+                    <a:lstStyle/>
+                    <a:p>
+                      <a:pPr algn="r"/>
+                      <a:r>
+                        <a:rPr sz="1100" b="0" i="0">
+                          <a:solidFill>
+                            <a:srgbClr val="1C1C1E"/>
+                          </a:solidFill>
+                          <a:latin typeface="Calibri"/>
+                          <a:ea typeface="Microsoft JhengHei"/>
+                        </a:rPr>
+                        <a:t>0.83</a:t>
+                      </a:r>
+                    </a:p>
+                  </a:txBody>
+                  <a:tcPr marL="73152" marR="73152" marT="27432" marB="27432" anchor="ctr">
+                    <a:solidFill>
+                      <a:srgbClr val="FFFFFF"/>
+                    </a:solidFill>
+                  </a:tcPr>
+                </a:tc>
+              </a:tr>
+              <a:tr h="274320">
+                <a:tc>
+                  <a:txBody>
+                    <a:bodyPr wrap="square"/>
+                    <a:lstStyle/>
+                    <a:p>
+                      <a:pPr algn="l"/>
+                      <a:r>
+                        <a:rPr sz="1100" b="0" i="0">
+                          <a:solidFill>
+                            <a:srgbClr val="1C1C1E"/>
+                          </a:solidFill>
+                          <a:latin typeface="Calibri"/>
+                          <a:ea typeface="Microsoft JhengHei"/>
+                        </a:rPr>
+                        <a:t>Acetone</a:t>
+                      </a:r>
+                    </a:p>
+                  </a:txBody>
+                  <a:tcPr marL="73152" marR="73152" marT="27432" marB="27432" anchor="ctr">
+                    <a:solidFill>
+                      <a:srgbClr val="FFFFFF"/>
+                    </a:solidFill>
+                  </a:tcPr>
+                </a:tc>
+                <a:tc>
+                  <a:txBody>
+                    <a:bodyPr wrap="square"/>
+                    <a:lstStyle/>
+                    <a:p>
+                      <a:pPr algn="r"/>
+                      <a:r>
+                        <a:rPr sz="1100" b="0" i="0">
+                          <a:solidFill>
+                            <a:srgbClr val="1C1C1E"/>
+                          </a:solidFill>
+                          <a:latin typeface="Calibri"/>
+                          <a:ea typeface="Microsoft JhengHei"/>
+                        </a:rPr>
+                        <a:t>+0.693</a:t>
+                      </a:r>
+                    </a:p>
+                  </a:txBody>
+                  <a:tcPr marL="73152" marR="73152" marT="27432" marB="27432" anchor="ctr">
+                    <a:solidFill>
+                      <a:srgbClr val="FFFFFF"/>
+                    </a:solidFill>
+                  </a:tcPr>
+                </a:tc>
+                <a:tc>
+                  <a:txBody>
+                    <a:bodyPr wrap="square"/>
+                    <a:lstStyle/>
+                    <a:p>
+                      <a:pPr algn="r"/>
+                      <a:r>
+                        <a:rPr sz="1100" b="0" i="0">
+                          <a:solidFill>
+                            <a:srgbClr val="1C1C1E"/>
+                          </a:solidFill>
+                          <a:latin typeface="Calibri"/>
+                          <a:ea typeface="Microsoft JhengHei"/>
+                        </a:rPr>
+                        <a:t>0.96</a:t>
+                      </a:r>
+                    </a:p>
+                  </a:txBody>
+                  <a:tcPr marL="73152" marR="73152" marT="27432" marB="27432" anchor="ctr">
+                    <a:solidFill>
+                      <a:srgbClr val="FFFFFF"/>
+                    </a:solidFill>
+                  </a:tcPr>
+                </a:tc>
+              </a:tr>
+              <a:tr h="274320">
+                <a:tc>
+                  <a:txBody>
+                    <a:bodyPr wrap="square"/>
+                    <a:lstStyle/>
+                    <a:p>
+                      <a:pPr algn="l"/>
+                      <a:r>
+                        <a:rPr sz="1100" b="0" i="0">
+                          <a:solidFill>
+                            <a:srgbClr val="1C1C1E"/>
+                          </a:solidFill>
+                          <a:latin typeface="Calibri"/>
+                          <a:ea typeface="Microsoft JhengHei"/>
+                        </a:rPr>
+                        <a:t>Toluene</a:t>
+                      </a:r>
+                    </a:p>
+                  </a:txBody>
+                  <a:tcPr marL="73152" marR="73152" marT="27432" marB="27432" anchor="ctr">
+                    <a:solidFill>
+                      <a:srgbClr val="FFFFFF"/>
+                    </a:solidFill>
+                  </a:tcPr>
+                </a:tc>
+                <a:tc>
+                  <a:txBody>
+                    <a:bodyPr wrap="square"/>
+                    <a:lstStyle/>
+                    <a:p>
+                      <a:pPr algn="r"/>
+                      <a:r>
+                        <a:rPr sz="1100" b="0" i="0">
+                          <a:solidFill>
+                            <a:srgbClr val="1C1C1E"/>
+                          </a:solidFill>
+                          <a:latin typeface="Calibri"/>
+                          <a:ea typeface="Microsoft JhengHei"/>
+                        </a:rPr>
+                        <a:t>+0.662</a:t>
+                      </a:r>
+                    </a:p>
+                  </a:txBody>
+                  <a:tcPr marL="73152" marR="73152" marT="27432" marB="27432" anchor="ctr">
+                    <a:solidFill>
+                      <a:srgbClr val="FFFFFF"/>
+                    </a:solidFill>
+                  </a:tcPr>
+                </a:tc>
+                <a:tc>
+                  <a:txBody>
+                    <a:bodyPr wrap="square"/>
+                    <a:lstStyle/>
+                    <a:p>
+                      <a:pPr algn="r"/>
+                      <a:r>
+                        <a:rPr sz="1100" b="0" i="0">
+                          <a:solidFill>
+                            <a:srgbClr val="1C1C1E"/>
+                          </a:solidFill>
+                          <a:latin typeface="Calibri"/>
+                          <a:ea typeface="Microsoft JhengHei"/>
+                        </a:rPr>
+                        <a:t>0.73</a:t>
+                      </a:r>
+                    </a:p>
+                  </a:txBody>
+                  <a:tcPr marL="73152" marR="73152" marT="27432" marB="27432" anchor="ctr">
+                    <a:solidFill>
+                      <a:srgbClr val="FFFFFF"/>
+                    </a:solidFill>
+                  </a:tcPr>
+                </a:tc>
+              </a:tr>
+              <a:tr h="274320">
+                <a:tc>
+                  <a:txBody>
+                    <a:bodyPr wrap="square"/>
+                    <a:lstStyle/>
+                    <a:p>
+                      <a:pPr algn="l"/>
+                      <a:r>
+                        <a:rPr sz="1100" b="1" i="0">
+                          <a:solidFill>
+                            <a:srgbClr val="1C1C1E"/>
+                          </a:solidFill>
+                          <a:latin typeface="Calibri"/>
+                          <a:ea typeface="Microsoft JhengHei"/>
+                        </a:rPr>
+                        <a:t>51 格平均</a:t>
+                      </a:r>
+                    </a:p>
+                  </a:txBody>
+                  <a:tcPr marL="73152" marR="73152" marT="27432" marB="27432" anchor="ctr">
+                    <a:solidFill>
+                      <a:srgbClr val="F3F4F6"/>
+                    </a:solidFill>
+                  </a:tcPr>
+                </a:tc>
+                <a:tc>
+                  <a:txBody>
+                    <a:bodyPr wrap="square"/>
+                    <a:lstStyle/>
+                    <a:p>
+                      <a:pPr algn="r"/>
+                      <a:r>
+                        <a:rPr sz="1100" b="1" i="0">
+                          <a:solidFill>
+                            <a:srgbClr val="1C1C1E"/>
+                          </a:solidFill>
+                          <a:latin typeface="Calibri"/>
+                          <a:ea typeface="Microsoft JhengHei"/>
+                        </a:rPr>
+                        <a:t>+0.593</a:t>
+                      </a:r>
+                    </a:p>
+                  </a:txBody>
+                  <a:tcPr marL="73152" marR="73152" marT="27432" marB="27432" anchor="ctr">
+                    <a:solidFill>
+                      <a:srgbClr val="F3F4F6"/>
+                    </a:solidFill>
+                  </a:tcPr>
+                </a:tc>
+                <a:tc>
+                  <a:txBody>
+                    <a:bodyPr wrap="square"/>
+                    <a:lstStyle/>
+                    <a:p>
+                      <a:pPr algn="r"/>
+                      <a:r>
+                        <a:rPr sz="1100" b="1" i="0">
+                          <a:solidFill>
+                            <a:srgbClr val="1C1C1E"/>
+                          </a:solidFill>
+                          <a:latin typeface="Calibri"/>
+                          <a:ea typeface="Microsoft JhengHei"/>
+                        </a:rPr>
+                        <a:t>—</a:t>
+                      </a:r>
+                    </a:p>
+                  </a:txBody>
+                  <a:tcPr marL="73152" marR="73152" marT="27432" marB="27432" anchor="ctr">
+                    <a:solidFill>
+                      <a:srgbClr val="F3F4F6"/>
+                    </a:solidFill>
+                  </a:tcPr>
+                </a:tc>
+              </a:tr>
+            </a:tbl>
+          </a:graphicData>
+        </a:graphic>
+      </p:graphicFrame>
+      <p:sp>
+        <p:nvSpPr>
+          <p:cNvPr id="6" name="TextBox 5"/>
+          <p:cNvSpPr txBox="1"/>
+          <p:nvPr/>
+        </p:nvSpPr>
+        <p:spPr>
+          <a:xfrm>
+            <a:off x="7772400" y="3931920"/>
+            <a:ext cx="3886200" cy="274320"/>
+          </a:xfrm>
+          <a:prstGeom prst="rect">
+            <a:avLst/>
+          </a:prstGeom>
+          <a:noFill/>
+        </p:spPr>
+        <p:txBody>
+          <a:bodyPr wrap="square" lIns="0" rIns="0" tIns="0" bIns="0" anchor="t">
+            <a:spAutoFit/>
+          </a:bodyPr>
+          <a:lstStyle/>
+          <a:p>
+            <a:pPr algn="l"/>
+            <a:r>
+              <a:rPr sz="1050" b="0" i="1">
+                <a:solidFill>
+                  <a:srgbClr val="66666E"/>
+                </a:solidFill>
+                <a:latin typeface="Calibri"/>
+                <a:ea typeface="Microsoft JhengHei"/>
+              </a:rPr>
+              <a:t>事後在 style 空間量；隨機方向的虛無值 0.088（scripts/measure_signed_direction.py）</a:t>
+            </a:r>
+          </a:p>
+        </p:txBody>
+      </p:sp>
+      <p:sp>
+        <p:nvSpPr>
+          <p:cNvPr id="7" name="TextBox 6"/>
+          <p:cNvSpPr txBox="1"/>
+          <p:nvPr/>
+        </p:nvSpPr>
+        <p:spPr>
+          <a:xfrm>
+            <a:off x="548640" y="3703320"/>
+            <a:ext cx="6949440" cy="2926080"/>
+          </a:xfrm>
+          <a:prstGeom prst="rect">
+            <a:avLst/>
+          </a:prstGeom>
+          <a:noFill/>
+        </p:spPr>
+        <p:txBody>
+          <a:bodyPr wrap="square" lIns="0" rIns="0" tIns="0" bIns="0" anchor="t">
+            <a:spAutoFit/>
+          </a:bodyPr>
+          <a:lstStyle/>
+          <a:p>
+            <a:pPr algn="l">
+              <a:spcAft>
+                <a:spcPts val="600"/>
+              </a:spcAft>
+            </a:pPr>
+            <a:r>
+              <a:rPr sz="1250" b="1" i="0">
+                <a:solidFill>
+                  <a:srgbClr val="EB6834"/>
+                </a:solidFill>
+                <a:latin typeface="Calibri"/>
+                <a:ea typeface="Microsoft JhengHei"/>
+              </a:rPr>
+              <a:t>▍ </a:t>
+            </a:r>
+            <a:r>
+              <a:rPr sz="1250" b="1" i="0">
+                <a:solidFill>
+                  <a:srgbClr val="1C1C1E"/>
+                </a:solidFill>
+                <a:latin typeface="Calibri"/>
+                <a:ea typeface="Microsoft JhengHei"/>
+              </a:rPr>
+              <a:t>方向是對的、幅度也對：六類 cos 全為正，位移是真實漂移的 0.73 到 1.41 倍。事前記錄的「可能反向」風險沒有發生</a:t>
+            </a:r>
+          </a:p>
+          <a:p>
+            <a:pPr>
+              <a:spcAft>
+                <a:spcPts val="600"/>
+              </a:spcAft>
+            </a:pPr>
+            <a:r>
+              <a:rPr sz="1250" b="0" i="0">
+                <a:solidFill>
+                  <a:srgbClr val="EB6834"/>
+                </a:solidFill>
+                <a:latin typeface="Calibri"/>
+                <a:ea typeface="Microsoft JhengHei"/>
+              </a:rPr>
+              <a:t>•  </a:t>
+            </a:r>
+            <a:r>
+              <a:rPr sz="1250" b="0" i="0">
+                <a:solidFill>
+                  <a:srgbClr val="1C1C1E"/>
+                </a:solidFill>
+                <a:latin typeface="Calibri"/>
+                <a:ea typeface="Microsoft JhengHei"/>
+              </a:rPr>
+              <a:t>每個 batch、每個類別的差都在 0.012 內；同樣的定向位移在輸入端（v8.1）能把 Acetone、Ethylene 各搬 0.25 以上</a:t>
+            </a:r>
+          </a:p>
+          <a:p>
+            <a:pPr>
+              <a:spcAft>
+                <a:spcPts val="600"/>
+              </a:spcAft>
+            </a:pPr>
+            <a:r>
+              <a:rPr sz="1250" b="1" i="0">
+                <a:solidFill>
+                  <a:srgbClr val="EB6834"/>
+                </a:solidFill>
+                <a:latin typeface="Calibri"/>
+                <a:ea typeface="Microsoft JhengHei"/>
+              </a:rPr>
+              <a:t>▍ </a:t>
+            </a:r>
+            <a:r>
+              <a:rPr sz="1250" b="1" i="0">
+                <a:solidFill>
+                  <a:srgbClr val="1C1C1E"/>
+                </a:solidFill>
+                <a:latin typeface="Calibri"/>
+                <a:ea typeface="Microsoft JhengHei"/>
+              </a:rPr>
+              <a:t>事前否證條件觸發。特徵生成區塊作為機制關掉了，與 Eq. (14) 有沒有正負號無關：它能碰到的子空間不是決策邊界會回應的那一個</a:t>
+            </a:r>
+          </a:p>
+          <a:p>
+            <a:pPr>
+              <a:spcAft>
+                <a:spcPts val="600"/>
+              </a:spcAft>
+            </a:pPr>
+            <a:r>
+              <a:rPr sz="1250" b="0" i="0">
+                <a:solidFill>
+                  <a:srgbClr val="EB6834"/>
+                </a:solidFill>
+                <a:latin typeface="Calibri"/>
+                <a:ea typeface="Microsoft JhengHei"/>
+              </a:rPr>
+              <a:t>•  </a:t>
+            </a:r>
+            <a:r>
+              <a:rPr sz="1250" b="0" i="0">
+                <a:solidFill>
+                  <a:srgbClr val="1C1C1E"/>
+                </a:solidFill>
+                <a:latin typeface="Calibri"/>
+                <a:ea typeface="Microsoft JhengHei"/>
+              </a:rPr>
+              <a:t>混淆：四格都帶輸入端的 R-aug-t2，shift 量到的是同方向位移之上的邊際效應</a:t>
+            </a:r>
+          </a:p>
+        </p:txBody>
+      </p:sp>
+    </p:spTree>
+  </p:cSld>
+  <p:clrMapOvr>
+    <a:masterClrMapping/>
+  </p:clrMapOvr>
+</p:sld>
+</file>
+
+<file path=ppt/slides/slide13.xml><?xml version="1.0" encoding="utf-8"?>
+<p:sld xmlns:a="http://schemas.openxmlformats.org/drawingml/2006/main" xmlns:p="http://schemas.openxmlformats.org/presentationml/2006/main" xmlns:r="http://schemas.openxmlformats.org/officeDocument/2006/relationships">
+  <p:cSld>
+    <p:spTree>
+      <p:nvGrpSpPr>
+        <p:cNvPr id="1" name=""/>
+        <p:cNvGrpSpPr/>
+        <p:nvPr/>
+      </p:nvGrpSpPr>
+      <p:grpSpPr/>
+      <p:sp>
+        <p:nvSpPr>
           <p:cNvPr id="2" name="TextBox 1"/>
           <p:cNvSpPr txBox="1"/>
           <p:nvPr/>
@@ -4613,6 +6286,665 @@
                 <a:latin typeface="Cambria"/>
                 <a:ea typeface="Microsoft JhengHei"/>
               </a:rPr>
+              <a:t>最後一個元件 L_con（Eq. S5）：已實作，決定不跑</a:t>
+            </a:r>
+          </a:p>
+          <a:p>
+            <a:pPr>
+              <a:spcBef>
+                <a:spcPts val="400"/>
+              </a:spcBef>
+            </a:pPr>
+            <a:r>
+              <a:rPr sz="1400" b="0" i="0">
+                <a:solidFill>
+                  <a:srgbClr val="66666E"/>
+                </a:solidFill>
+                <a:latin typeface="Calibri"/>
+                <a:ea typeface="Microsoft JhengHei"/>
+              </a:rPr>
+              <a:t>論文三個元件裡唯一要求不變性的損失，但它要求的不變性對象已經被 v9、v10 量掉了</a:t>
+            </a:r>
+          </a:p>
+        </p:txBody>
+      </p:sp>
+      <p:sp>
+        <p:nvSpPr>
+          <p:cNvPr id="3" name="Rounded Rectangle 2"/>
+          <p:cNvSpPr/>
+          <p:nvPr/>
+        </p:nvSpPr>
+        <p:spPr>
+          <a:xfrm>
+            <a:off x="548640" y="1600200"/>
+            <a:ext cx="5486400" cy="1371600"/>
+          </a:xfrm>
+          <a:prstGeom prst="roundRect">
+            <a:avLst/>
+          </a:prstGeom>
+          <a:solidFill>
+            <a:srgbClr val="F3F4F6"/>
+          </a:solidFill>
+          <a:ln>
+            <a:noFill/>
+          </a:ln>
+          <a:effectLst/>
+        </p:spPr>
+        <p:style>
+          <a:lnRef idx="1">
+            <a:schemeClr val="accent1"/>
+          </a:lnRef>
+          <a:fillRef idx="3">
+            <a:schemeClr val="accent1"/>
+          </a:fillRef>
+          <a:effectRef idx="2">
+            <a:schemeClr val="accent1"/>
+          </a:effectRef>
+          <a:fontRef idx="minor">
+            <a:schemeClr val="lt1"/>
+          </a:fontRef>
+        </p:style>
+        <p:txBody>
+          <a:bodyPr rtlCol="0" anchor="ctr"/>
+          <a:lstStyle/>
+          <a:p>
+            <a:pPr algn="ctr"/>
+          </a:p>
+        </p:txBody>
+      </p:sp>
+      <p:sp>
+        <p:nvSpPr>
+          <p:cNvPr id="4" name="TextBox 3"/>
+          <p:cNvSpPr txBox="1"/>
+          <p:nvPr/>
+        </p:nvSpPr>
+        <p:spPr>
+          <a:xfrm>
+            <a:off x="777240" y="1737360"/>
+            <a:ext cx="5029200" cy="1188720"/>
+          </a:xfrm>
+          <a:prstGeom prst="rect">
+            <a:avLst/>
+          </a:prstGeom>
+          <a:noFill/>
+        </p:spPr>
+        <p:txBody>
+          <a:bodyPr wrap="square" lIns="0" rIns="0" tIns="0" bIns="0" anchor="ctr">
+            <a:spAutoFit/>
+          </a:bodyPr>
+          <a:lstStyle/>
+          <a:p>
+            <a:pPr algn="l"/>
+            <a:r>
+              <a:rPr sz="1300" b="0" i="0">
+                <a:solidFill>
+                  <a:srgbClr val="1C1C1E"/>
+                </a:solidFill>
+                <a:latin typeface="Cambria"/>
+                <a:ea typeface="Microsoft JhengHei"/>
+              </a:rPr>
+              <a:t>L_con = − Σᵢ (1/|P(i)|) Σₚ∈P(i) log [ exp(f(zᵢ)·f(zₚ)/τ) / Σₐ∈A(i) exp(f(zᵢ)·f(zₐ)/τ) ]</a:t>
+            </a:r>
+          </a:p>
+          <a:p>
+            <a:pPr>
+              <a:spcBef>
+                <a:spcPts val="600"/>
+              </a:spcBef>
+            </a:pPr>
+            <a:r>
+              <a:rPr sz="1150" b="0" i="0">
+                <a:solidFill>
+                  <a:srgbClr val="66666E"/>
+                </a:solidFill>
+                <a:latin typeface="Calibri"/>
+                <a:ea typeface="Microsoft JhengHei"/>
+              </a:rPr>
+              <a:t>Z = z_f ∪ z̄_f，生成特徵沿用原標籤；f 投影到單位球。τ 與 λ_con 論文都沒給。</a:t>
+            </a:r>
+          </a:p>
+        </p:txBody>
+      </p:sp>
+      <p:sp>
+        <p:nvSpPr>
+          <p:cNvPr id="5" name="TextBox 4"/>
+          <p:cNvSpPr txBox="1"/>
+          <p:nvPr/>
+        </p:nvSpPr>
+        <p:spPr>
+          <a:xfrm>
+            <a:off x="548640" y="3200400"/>
+            <a:ext cx="5486400" cy="3474720"/>
+          </a:xfrm>
+          <a:prstGeom prst="rect">
+            <a:avLst/>
+          </a:prstGeom>
+          <a:noFill/>
+        </p:spPr>
+        <p:txBody>
+          <a:bodyPr wrap="square" lIns="0" rIns="0" tIns="0" bIns="0" anchor="t">
+            <a:spAutoFit/>
+          </a:bodyPr>
+          <a:lstStyle/>
+          <a:p>
+            <a:pPr algn="l">
+              <a:spcAft>
+                <a:spcPts val="500"/>
+              </a:spcAft>
+            </a:pPr>
+            <a:r>
+              <a:rPr sz="1350" b="1" i="0">
+                <a:solidFill>
+                  <a:srgbClr val="2B2D42"/>
+                </a:solidFill>
+                <a:latin typeface="Calibri"/>
+                <a:ea typeface="Microsoft JhengHei"/>
+              </a:rPr>
+              <a:t>做好的東西</a:t>
+            </a:r>
+          </a:p>
+          <a:p>
+            <a:pPr>
+              <a:spcAft>
+                <a:spcPts val="500"/>
+              </a:spcAft>
+            </a:pPr>
+            <a:r>
+              <a:rPr sz="1250" b="0" i="0">
+                <a:solidFill>
+                  <a:srgbClr val="EB6834"/>
+                </a:solidFill>
+                <a:latin typeface="Calibri"/>
+                <a:ea typeface="Microsoft JhengHei"/>
+              </a:rPr>
+              <a:t>•  </a:t>
+            </a:r>
+            <a:r>
+              <a:rPr sz="1250" b="0" i="0">
+                <a:solidFill>
+                  <a:srgbClr val="1C1C1E"/>
+                </a:solidFill>
+                <a:latin typeface="Calibri"/>
+                <a:ea typeface="Microsoft JhengHei"/>
+              </a:rPr>
+              <a:t>src/loss.py 的 supervised_contrastive；train.py 接上 Eq. (4) 第三項；四格 config（R-con、R-con-shift、R-con-t5 對 R-gen）含事前預測；單元測試與單一 minibatch 前向通過</a:t>
+            </a:r>
+          </a:p>
+          <a:p>
+            <a:pPr>
+              <a:spcAft>
+                <a:spcPts val="500"/>
+              </a:spcAft>
+            </a:pPr>
+            <a:r>
+              <a:rPr sz="1350" b="1" i="0">
+                <a:solidFill>
+                  <a:srgbClr val="2B2D42"/>
+                </a:solidFill>
+                <a:latin typeface="Calibri"/>
+                <a:ea typeface="Microsoft JhengHei"/>
+              </a:rPr>
+              <a:t>為什麼不跑</a:t>
+            </a:r>
+          </a:p>
+          <a:p>
+            <a:pPr>
+              <a:spcAft>
+                <a:spcPts val="500"/>
+              </a:spcAft>
+            </a:pPr>
+            <a:r>
+              <a:rPr sz="1250" b="1" i="0">
+                <a:solidFill>
+                  <a:srgbClr val="EB6834"/>
+                </a:solidFill>
+                <a:latin typeface="Calibri"/>
+                <a:ea typeface="Microsoft JhengHei"/>
+              </a:rPr>
+              <a:t>▍ </a:t>
+            </a:r>
+            <a:r>
+              <a:rPr sz="1250" b="1" i="0">
+                <a:solidFill>
+                  <a:srgbClr val="1C1C1E"/>
+                </a:solidFill>
+                <a:latin typeface="Calibri"/>
+                <a:ea typeface="Microsoft JhengHei"/>
+              </a:rPr>
+              <a:t>它要求 z_f 對 z̄_f 不變。v9、v10 量過 z̄_f：從 Batch 1 生成的雲沒有離開 Batch 1（沿漂移軸重疊 0.00、寬度比 1.01）；連方向對、幅度對的 z̄_f 都只值 +0.0023。對一個沒離開 source 的擾動做不變性，不會變成對真實漂移的不變性</a:t>
+            </a:r>
+          </a:p>
+          <a:p>
+            <a:pPr>
+              <a:spcAft>
+                <a:spcPts val="500"/>
+              </a:spcAft>
+            </a:pPr>
+            <a:r>
+              <a:rPr sz="1250" b="0" i="0">
+                <a:solidFill>
+                  <a:srgbClr val="EB6834"/>
+                </a:solidFill>
+                <a:latin typeface="Calibri"/>
+                <a:ea typeface="Microsoft JhengHei"/>
+              </a:rPr>
+              <a:t>•  </a:t>
+            </a:r>
+            <a:r>
+              <a:rPr sz="1250" b="0" i="0">
+                <a:solidFill>
+                  <a:srgbClr val="1C1C1E"/>
+                </a:solidFill>
+                <a:latin typeface="Calibri"/>
+                <a:ea typeface="Microsoft JhengHei"/>
+              </a:rPr>
+              <a:t>前一分支在另一個 backbone 上量了五次：−0.005 到 +0.003</a:t>
+            </a:r>
+          </a:p>
+        </p:txBody>
+      </p:sp>
+      <p:sp>
+        <p:nvSpPr>
+          <p:cNvPr id="6" name="Rounded Rectangle 5"/>
+          <p:cNvSpPr/>
+          <p:nvPr/>
+        </p:nvSpPr>
+        <p:spPr>
+          <a:xfrm>
+            <a:off x="6400800" y="1600200"/>
+            <a:ext cx="2606040" cy="1554480"/>
+          </a:xfrm>
+          <a:prstGeom prst="roundRect">
+            <a:avLst/>
+          </a:prstGeom>
+          <a:solidFill>
+            <a:srgbClr val="F3F4F6"/>
+          </a:solidFill>
+          <a:ln>
+            <a:noFill/>
+          </a:ln>
+          <a:effectLst/>
+        </p:spPr>
+        <p:style>
+          <a:lnRef idx="1">
+            <a:schemeClr val="accent1"/>
+          </a:lnRef>
+          <a:fillRef idx="3">
+            <a:schemeClr val="accent1"/>
+          </a:fillRef>
+          <a:effectRef idx="2">
+            <a:schemeClr val="accent1"/>
+          </a:effectRef>
+          <a:fontRef idx="minor">
+            <a:schemeClr val="lt1"/>
+          </a:fontRef>
+        </p:style>
+        <p:txBody>
+          <a:bodyPr rtlCol="0" anchor="ctr"/>
+          <a:lstStyle/>
+          <a:p>
+            <a:pPr algn="ctr"/>
+          </a:p>
+        </p:txBody>
+      </p:sp>
+      <p:sp>
+        <p:nvSpPr>
+          <p:cNvPr id="7" name="TextBox 6"/>
+          <p:cNvSpPr txBox="1"/>
+          <p:nvPr/>
+        </p:nvSpPr>
+        <p:spPr>
+          <a:xfrm>
+            <a:off x="6583680" y="1709928"/>
+            <a:ext cx="2240280" cy="594360"/>
+          </a:xfrm>
+          <a:prstGeom prst="rect">
+            <a:avLst/>
+          </a:prstGeom>
+          <a:noFill/>
+        </p:spPr>
+        <p:txBody>
+          <a:bodyPr wrap="square" lIns="0" rIns="0" tIns="0" bIns="0" anchor="ctr">
+            <a:spAutoFit/>
+          </a:bodyPr>
+          <a:lstStyle/>
+          <a:p>
+            <a:pPr algn="l"/>
+            <a:r>
+              <a:rPr sz="3000" b="1" i="0">
+                <a:solidFill>
+                  <a:srgbClr val="2B2D42"/>
+                </a:solidFill>
+                <a:latin typeface="Cambria"/>
+                <a:ea typeface="Microsoft JhengHei"/>
+              </a:rPr>
+              <a:t>4.8</a:t>
+            </a:r>
+          </a:p>
+        </p:txBody>
+      </p:sp>
+      <p:sp>
+        <p:nvSpPr>
+          <p:cNvPr id="8" name="TextBox 7"/>
+          <p:cNvSpPr txBox="1"/>
+          <p:nvPr/>
+        </p:nvSpPr>
+        <p:spPr>
+          <a:xfrm>
+            <a:off x="6583680" y="2377440"/>
+            <a:ext cx="2240280" cy="731520"/>
+          </a:xfrm>
+          <a:prstGeom prst="rect">
+            <a:avLst/>
+          </a:prstGeom>
+          <a:noFill/>
+        </p:spPr>
+        <p:txBody>
+          <a:bodyPr wrap="square" lIns="0" rIns="0" tIns="0" bIns="0" anchor="t">
+            <a:spAutoFit/>
+          </a:bodyPr>
+          <a:lstStyle/>
+          <a:p>
+            <a:pPr algn="l"/>
+            <a:r>
+              <a:rPr sz="1150" b="0" i="0">
+                <a:solidFill>
+                  <a:srgbClr val="66666E"/>
+                </a:solidFill>
+                <a:latin typeface="Calibri"/>
+                <a:ea typeface="Microsoft JhengHei"/>
+              </a:rPr>
+              <a:t>L_con 的起始值 ≈ log(127)，是 L_ce 的兩倍多；乘 0.5 後主導前期梯度</a:t>
+            </a:r>
+          </a:p>
+        </p:txBody>
+      </p:sp>
+      <p:sp>
+        <p:nvSpPr>
+          <p:cNvPr id="9" name="Rounded Rectangle 8"/>
+          <p:cNvSpPr/>
+          <p:nvPr/>
+        </p:nvSpPr>
+        <p:spPr>
+          <a:xfrm>
+            <a:off x="9098280" y="1600200"/>
+            <a:ext cx="2560320" cy="1554480"/>
+          </a:xfrm>
+          <a:prstGeom prst="roundRect">
+            <a:avLst/>
+          </a:prstGeom>
+          <a:solidFill>
+            <a:srgbClr val="F3F4F6"/>
+          </a:solidFill>
+          <a:ln>
+            <a:noFill/>
+          </a:ln>
+          <a:effectLst/>
+        </p:spPr>
+        <p:style>
+          <a:lnRef idx="1">
+            <a:schemeClr val="accent1"/>
+          </a:lnRef>
+          <a:fillRef idx="3">
+            <a:schemeClr val="accent1"/>
+          </a:fillRef>
+          <a:effectRef idx="2">
+            <a:schemeClr val="accent1"/>
+          </a:effectRef>
+          <a:fontRef idx="minor">
+            <a:schemeClr val="lt1"/>
+          </a:fontRef>
+        </p:style>
+        <p:txBody>
+          <a:bodyPr rtlCol="0" anchor="ctr"/>
+          <a:lstStyle/>
+          <a:p>
+            <a:pPr algn="ctr"/>
+          </a:p>
+        </p:txBody>
+      </p:sp>
+      <p:sp>
+        <p:nvSpPr>
+          <p:cNvPr id="10" name="TextBox 9"/>
+          <p:cNvSpPr txBox="1"/>
+          <p:nvPr/>
+        </p:nvSpPr>
+        <p:spPr>
+          <a:xfrm>
+            <a:off x="9281160" y="1709928"/>
+            <a:ext cx="2194560" cy="594360"/>
+          </a:xfrm>
+          <a:prstGeom prst="rect">
+            <a:avLst/>
+          </a:prstGeom>
+          <a:noFill/>
+        </p:spPr>
+        <p:txBody>
+          <a:bodyPr wrap="square" lIns="0" rIns="0" tIns="0" bIns="0" anchor="ctr">
+            <a:spAutoFit/>
+          </a:bodyPr>
+          <a:lstStyle/>
+          <a:p>
+            <a:pPr algn="l"/>
+            <a:r>
+              <a:rPr sz="3000" b="1" i="0">
+                <a:solidFill>
+                  <a:srgbClr val="2B2D42"/>
+                </a:solidFill>
+                <a:latin typeface="Cambria"/>
+                <a:ea typeface="Microsoft JhengHei"/>
+              </a:rPr>
+              <a:t>1.5</a:t>
+            </a:r>
+          </a:p>
+        </p:txBody>
+      </p:sp>
+      <p:sp>
+        <p:nvSpPr>
+          <p:cNvPr id="11" name="TextBox 10"/>
+          <p:cNvSpPr txBox="1"/>
+          <p:nvPr/>
+        </p:nvSpPr>
+        <p:spPr>
+          <a:xfrm>
+            <a:off x="9281160" y="2377440"/>
+            <a:ext cx="2194560" cy="731520"/>
+          </a:xfrm>
+          <a:prstGeom prst="rect">
+            <a:avLst/>
+          </a:prstGeom>
+          <a:noFill/>
+        </p:spPr>
+        <p:txBody>
+          <a:bodyPr wrap="square" lIns="0" rIns="0" tIns="0" bIns="0" anchor="t">
+            <a:spAutoFit/>
+          </a:bodyPr>
+          <a:lstStyle/>
+          <a:p>
+            <a:pPr algn="l"/>
+            <a:r>
+              <a:rPr sz="1150" b="0" i="0">
+                <a:solidFill>
+                  <a:srgbClr val="66666E"/>
+                </a:solidFill>
+                <a:latin typeface="Calibri"/>
+                <a:ea typeface="Microsoft JhengHei"/>
+              </a:rPr>
+              <a:t>論文 Fig. S1(b) 裡 CDCNN 的 loss 平台，另外兩個是 0.5。與上面一致</a:t>
+            </a:r>
+          </a:p>
+        </p:txBody>
+      </p:sp>
+      <p:sp>
+        <p:nvSpPr>
+          <p:cNvPr id="12" name="TextBox 11"/>
+          <p:cNvSpPr txBox="1"/>
+          <p:nvPr/>
+        </p:nvSpPr>
+        <p:spPr>
+          <a:xfrm>
+            <a:off x="6400800" y="3383280"/>
+            <a:ext cx="5257800" cy="3291840"/>
+          </a:xfrm>
+          <a:prstGeom prst="rect">
+            <a:avLst/>
+          </a:prstGeom>
+          <a:noFill/>
+        </p:spPr>
+        <p:txBody>
+          <a:bodyPr wrap="square" lIns="0" rIns="0" tIns="0" bIns="0" anchor="t">
+            <a:spAutoFit/>
+          </a:bodyPr>
+          <a:lstStyle/>
+          <a:p>
+            <a:pPr algn="l">
+              <a:spcAft>
+                <a:spcPts val="600"/>
+              </a:spcAft>
+            </a:pPr>
+            <a:r>
+              <a:rPr sz="1350" b="1" i="0">
+                <a:solidFill>
+                  <a:srgbClr val="2B2D42"/>
+                </a:solidFill>
+                <a:latin typeface="Calibri"/>
+                <a:ea typeface="Microsoft JhengHei"/>
+              </a:rPr>
+              <a:t>結論</a:t>
+            </a:r>
+          </a:p>
+          <a:p>
+            <a:pPr>
+              <a:spcAft>
+                <a:spcPts val="600"/>
+              </a:spcAft>
+            </a:pPr>
+            <a:r>
+              <a:rPr sz="1250" b="1" i="0">
+                <a:solidFill>
+                  <a:srgbClr val="EB6834"/>
+                </a:solidFill>
+                <a:latin typeface="Calibri"/>
+                <a:ea typeface="Microsoft JhengHei"/>
+              </a:rPr>
+              <a:t>▍ </a:t>
+            </a:r>
+            <a:r>
+              <a:rPr sz="1250" b="1" i="0">
+                <a:solidFill>
+                  <a:srgbClr val="1C1C1E"/>
+                </a:solidFill>
+                <a:latin typeface="Calibri"/>
+                <a:ea typeface="Microsoft JhengHei"/>
+              </a:rPr>
+              <a:t>論文三個元件：兩個量到零，第三個的前提已被量掉。復現到此為止</a:t>
+            </a:r>
+          </a:p>
+          <a:p>
+            <a:pPr>
+              <a:spcAft>
+                <a:spcPts val="600"/>
+              </a:spcAft>
+            </a:pPr>
+            <a:r>
+              <a:rPr sz="1250" b="0" i="0">
+                <a:solidFill>
+                  <a:srgbClr val="EB6834"/>
+                </a:solidFill>
+                <a:latin typeface="Calibri"/>
+                <a:ea typeface="Microsoft JhengHei"/>
+              </a:rPr>
+              <a:t>•  </a:t>
+            </a:r>
+            <a:r>
+              <a:rPr sz="1250" b="0" i="0">
+                <a:solidFill>
+                  <a:srgbClr val="1C1C1E"/>
+                </a:solidFill>
+                <a:latin typeface="Calibri"/>
+                <a:ea typeface="Microsoft JhengHei"/>
+              </a:rPr>
+              <a:t>config 與預測留檔；要補跑是一次 gpu-smoke 加一次 launch，約 15 分鐘</a:t>
+            </a:r>
+          </a:p>
+          <a:p>
+            <a:pPr>
+              <a:spcAft>
+                <a:spcPts val="600"/>
+              </a:spcAft>
+            </a:pPr>
+            <a:r>
+              <a:rPr sz="1250" b="0" i="0">
+                <a:solidFill>
+                  <a:srgbClr val="EB6834"/>
+                </a:solidFill>
+                <a:latin typeface="Calibri"/>
+                <a:ea typeface="Microsoft JhengHei"/>
+              </a:rPr>
+              <a:t>•  </a:t>
+            </a:r>
+            <a:r>
+              <a:rPr sz="1250" b="0" i="0">
+                <a:solidFill>
+                  <a:srgbClr val="1C1C1E"/>
+                </a:solidFill>
+                <a:latin typeface="Calibri"/>
+                <a:ea typeface="Microsoft JhengHei"/>
+              </a:rPr>
+              <a:t>否證條件也寫好了：R-con 若與 R-gen 可分辨，代表前一分支的五次零是 backbone 的問題，論文的 +0.053 在 source-only 下有立足點</a:t>
+            </a:r>
+          </a:p>
+        </p:txBody>
+      </p:sp>
+    </p:spTree>
+  </p:cSld>
+  <p:clrMapOvr>
+    <a:masterClrMapping/>
+  </p:clrMapOvr>
+</p:sld>
+</file>
+
+<file path=ppt/slides/slide14.xml><?xml version="1.0" encoding="utf-8"?>
+<p:sld xmlns:a="http://schemas.openxmlformats.org/drawingml/2006/main" xmlns:p="http://schemas.openxmlformats.org/presentationml/2006/main" xmlns:r="http://schemas.openxmlformats.org/officeDocument/2006/relationships">
+  <p:cSld>
+    <p:spTree>
+      <p:nvGrpSpPr>
+        <p:cNvPr id="1" name=""/>
+        <p:cNvGrpSpPr/>
+        <p:nvPr/>
+      </p:nvGrpSpPr>
+      <p:grpSpPr/>
+      <p:sp>
+        <p:nvSpPr>
+          <p:cNvPr id="2" name="TextBox 1"/>
+          <p:cNvSpPr txBox="1"/>
+          <p:nvPr/>
+        </p:nvSpPr>
+        <p:spPr>
+          <a:xfrm>
+            <a:off x="548640" y="457200"/>
+            <a:ext cx="11094415" cy="822960"/>
+          </a:xfrm>
+          <a:prstGeom prst="rect">
+            <a:avLst/>
+          </a:prstGeom>
+          <a:noFill/>
+        </p:spPr>
+        <p:txBody>
+          <a:bodyPr wrap="square" lIns="0" rIns="0" tIns="0" bIns="0" anchor="t">
+            <a:spAutoFit/>
+          </a:bodyPr>
+          <a:lstStyle/>
+          <a:p>
+            <a:pPr algn="l"/>
+            <a:r>
+              <a:rPr sz="3000" b="1" i="0">
+                <a:solidFill>
+                  <a:srgbClr val="2B2D42"/>
+                </a:solidFill>
+                <a:latin typeface="Cambria"/>
+                <a:ea typeface="Microsoft JhengHei"/>
+              </a:rPr>
               <a:t>總結：機制都重現了，增益沒有</a:t>
             </a:r>
           </a:p>
@@ -4645,7 +6977,7 @@
         </p:nvGraphicFramePr>
         <p:xfrm>
           <a:off x="548640" y="1600200"/>
-          <a:ext cx="11094414" cy="2011680"/>
+          <a:ext cx="11094413" cy="2304288"/>
         </p:xfrm>
         <a:graphic>
           <a:graphicData uri="http://schemas.openxmlformats.org/drawingml/2006/table">
@@ -4654,12 +6986,12 @@
                 <a:tableStyleId>{5C22544A-7EE6-4342-B048-85BDC9FD1C3A}</a:tableStyleId>
               </a:tblPr>
               <a:tblGrid>
-                <a:gridCol w="3772101"/>
-                <a:gridCol w="2218883"/>
-                <a:gridCol w="2662659"/>
+                <a:gridCol w="3993989"/>
+                <a:gridCol w="1775106"/>
+                <a:gridCol w="2884547"/>
                 <a:gridCol w="2440771"/>
               </a:tblGrid>
-              <a:tr h="402336">
+              <a:tr h="384048">
                 <a:tc>
                   <a:txBody>
                     <a:bodyPr wrap="square"/>
@@ -4757,7 +7089,7 @@
                   </a:tcPr>
                 </a:tc>
               </a:tr>
-              <a:tr h="402336">
+              <a:tr h="384048">
                 <a:tc>
                   <a:txBody>
                     <a:bodyPr wrap="square"/>
@@ -4855,7 +7187,7 @@
                   </a:tcPr>
                 </a:tc>
               </a:tr>
-              <a:tr h="402336">
+              <a:tr h="384048">
                 <a:tc>
                   <a:txBody>
                     <a:bodyPr wrap="square"/>
@@ -4953,7 +7285,7 @@
                   </a:tcPr>
                 </a:tc>
               </a:tr>
-              <a:tr h="402336">
+              <a:tr h="384048">
                 <a:tc>
                   <a:txBody>
                     <a:bodyPr wrap="square"/>
@@ -4968,7 +7300,7 @@
                           <a:latin typeface="Calibri"/>
                           <a:ea typeface="Microsoft JhengHei"/>
                         </a:rPr>
-                        <a:t>特徵生成 + L_MSE</a:t>
+                        <a:t>特徵生成 + L_MSE（論文原版）</a:t>
                       </a:r>
                     </a:p>
                   </a:txBody>
@@ -5051,7 +7383,7 @@
                   </a:tcPr>
                 </a:tc>
               </a:tr>
-              <a:tr h="402336">
+              <a:tr h="384048">
                 <a:tc>
                   <a:txBody>
                     <a:bodyPr wrap="square"/>
@@ -5059,6 +7391,104 @@
                     <a:p>
                       <a:pPr algn="l"/>
                       <a:r>
+                        <a:rPr sz="1300" b="1" i="0">
+                          <a:solidFill>
+                            <a:srgbClr val="1C1C1E"/>
+                          </a:solidFill>
+                          <a:latin typeface="Calibri"/>
+                          <a:ea typeface="Microsoft JhengHei"/>
+                        </a:rPr>
+                        <a:t>特徵生成，Eq. (14) 加正負號與幅度（v10.0）</a:t>
+                      </a:r>
+                    </a:p>
+                  </a:txBody>
+                  <a:tcPr marL="73152" marR="73152" marT="27432" marB="27432" anchor="ctr">
+                    <a:solidFill>
+                      <a:srgbClr val="F3F4F6"/>
+                    </a:solidFill>
+                  </a:tcPr>
+                </a:tc>
+                <a:tc>
+                  <a:txBody>
+                    <a:bodyPr wrap="square"/>
+                    <a:lstStyle/>
+                    <a:p>
+                      <a:pPr algn="r"/>
+                      <a:r>
+                        <a:rPr sz="1300" b="1" i="0">
+                          <a:solidFill>
+                            <a:srgbClr val="1C1C1E"/>
+                          </a:solidFill>
+                          <a:latin typeface="Calibri"/>
+                          <a:ea typeface="Microsoft JhengHei"/>
+                        </a:rPr>
+                        <a:t>+0.0023</a:t>
+                      </a:r>
+                    </a:p>
+                  </a:txBody>
+                  <a:tcPr marL="73152" marR="73152" marT="27432" marB="27432" anchor="ctr">
+                    <a:solidFill>
+                      <a:srgbClr val="F3F4F6"/>
+                    </a:solidFill>
+                  </a:tcPr>
+                </a:tc>
+                <a:tc>
+                  <a:txBody>
+                    <a:bodyPr wrap="square"/>
+                    <a:lstStyle/>
+                    <a:p>
+                      <a:pPr algn="r"/>
+                      <a:r>
+                        <a:rPr sz="1300" b="1" i="0">
+                          <a:solidFill>
+                            <a:srgbClr val="1C1C1E"/>
+                          </a:solidFill>
+                          <a:latin typeface="Calibri"/>
+                          <a:ea typeface="Microsoft JhengHei"/>
+                        </a:rPr>
+                        <a:t>—</a:t>
+                      </a:r>
+                    </a:p>
+                  </a:txBody>
+                  <a:tcPr marL="73152" marR="73152" marT="27432" marB="27432" anchor="ctr">
+                    <a:solidFill>
+                      <a:srgbClr val="F3F4F6"/>
+                    </a:solidFill>
+                  </a:tcPr>
+                </a:tc>
+                <a:tc>
+                  <a:txBody>
+                    <a:bodyPr wrap="square"/>
+                    <a:lstStyle/>
+                    <a:p>
+                      <a:pPr algn="r"/>
+                      <a:r>
+                        <a:rPr sz="1300" b="1" i="0">
+                          <a:solidFill>
+                            <a:srgbClr val="1C1C1E"/>
+                          </a:solidFill>
+                          <a:latin typeface="Calibri"/>
+                          <a:ea typeface="Microsoft JhengHei"/>
+                        </a:rPr>
+                        <a:t>—</a:t>
+                      </a:r>
+                    </a:p>
+                  </a:txBody>
+                  <a:tcPr marL="73152" marR="73152" marT="27432" marB="27432" anchor="ctr">
+                    <a:solidFill>
+                      <a:srgbClr val="F3F4F6"/>
+                    </a:solidFill>
+                  </a:tcPr>
+                </a:tc>
+              </a:tr>
+              <a:tr h="384048">
+                <a:tc>
+                  <a:txBody>
+                    <a:bodyPr wrap="square"/>
+                    <a:lstStyle/>
+                    <a:p>
+                      <a:pPr algn="l"/>
+                      <a:r>
                         <a:rPr sz="1300" b="0" i="0">
                           <a:solidFill>
                             <a:srgbClr val="1C1C1E"/>
@@ -5090,7 +7520,7 @@
                           <a:latin typeface="Calibri"/>
                           <a:ea typeface="Microsoft JhengHei"/>
                         </a:rPr>
-                        <a:t>未做</a:t>
+                        <a:t>已實作，未跑</a:t>
                       </a:r>
                     </a:p>
                   </a:txBody>
@@ -5161,8 +7591,8 @@
         </p:nvSpPr>
         <p:spPr>
           <a:xfrm>
-            <a:off x="548640" y="3977639"/>
-            <a:ext cx="11094415" cy="2560320"/>
+            <a:off x="548640" y="4206240"/>
+            <a:ext cx="11094415" cy="2377440"/>
           </a:xfrm>
           <a:prstGeom prst="rect">
             <a:avLst/>
@@ -5177,11 +7607,11 @@
           <a:p>
             <a:pPr algn="l">
               <a:spcAft>
-                <a:spcPts val="900"/>
+                <a:spcPts val="700"/>
               </a:spcAft>
             </a:pPr>
             <a:r>
-              <a:rPr sz="1500" b="1" i="0">
+              <a:rPr sz="1450" b="1" i="0">
                 <a:solidFill>
                   <a:srgbClr val="2B2D42"/>
                 </a:solidFill>
@@ -5194,11 +7624,11 @@
           <a:p>
             <a:pPr>
               <a:spcAft>
-                <a:spcPts val="900"/>
+                <a:spcPts val="700"/>
               </a:spcAft>
             </a:pPr>
             <a:r>
-              <a:rPr sz="1500" b="1" i="0">
+              <a:rPr sz="1450" b="1" i="0">
                 <a:solidFill>
                   <a:srgbClr val="2B2D42"/>
                 </a:solidFill>
@@ -5211,11 +7641,11 @@
           <a:p>
             <a:pPr>
               <a:spcAft>
-                <a:spcPts val="900"/>
+                <a:spcPts val="700"/>
               </a:spcAft>
             </a:pPr>
             <a:r>
-              <a:rPr sz="1400" b="0" i="0">
+              <a:rPr sz="1350" b="0" i="0">
                 <a:solidFill>
                   <a:srgbClr val="EB6834"/>
                 </a:solidFill>
@@ -5225,7 +7655,34 @@
               <a:t>•  </a:t>
             </a:r>
             <a:r>
-              <a:rPr sz="1400" b="0" i="0">
+              <a:rPr sz="1350" b="0" i="0">
+                <a:solidFill>
+                  <a:srgbClr val="1C1C1E"/>
+                </a:solidFill>
+                <a:latin typeface="Calibri"/>
+                <a:ea typeface="Microsoft JhengHei"/>
+              </a:rPr>
+              <a:t>與論文的差距在 Acetaldehyde 之外的五類，來源不在這三個元件裡</a:t>
+            </a:r>
+          </a:p>
+          <a:p>
+            <a:pPr>
+              <a:spcAft>
+                <a:spcPts val="700"/>
+              </a:spcAft>
+            </a:pPr>
+            <a:r>
+              <a:rPr sz="1350" b="0" i="0">
+                <a:solidFill>
+                  <a:srgbClr val="EB6834"/>
+                </a:solidFill>
+                <a:latin typeface="Calibri"/>
+                <a:ea typeface="Microsoft JhengHei"/>
+              </a:rPr>
+              <a:t>•  </a:t>
+            </a:r>
+            <a:r>
+              <a:rPr sz="1350" b="0" i="0">
                 <a:solidFill>
                   <a:srgbClr val="1C1C1E"/>
                 </a:solidFill>
@@ -5245,7 +7702,7 @@
 </p:sld>
 </file>
 
-<file path=ppt/slides/slide13.xml><?xml version="1.0" encoding="utf-8"?>
+<file path=ppt/slides/slide15.xml><?xml version="1.0" encoding="utf-8"?>
 <p:sld xmlns:a="http://schemas.openxmlformats.org/drawingml/2006/main" xmlns:p="http://schemas.openxmlformats.org/presentationml/2006/main" xmlns:r="http://schemas.openxmlformats.org/officeDocument/2006/relationships">
   <p:cSld>
     <p:spTree>
@@ -5330,7 +7787,7 @@
                 <a:latin typeface="Cambria"/>
                 <a:ea typeface="Microsoft JhengHei"/>
               </a:rPr>
-              <a:t>下一步</a:t>
+              <a:t>結論與留下的東西</a:t>
             </a:r>
           </a:p>
         </p:txBody>
@@ -5394,7 +7851,7 @@
             <a:avLst/>
           </a:prstGeom>
           <a:solidFill>
-            <a:srgbClr val="EB6834"/>
+            <a:srgbClr val="2B2D42"/>
           </a:solidFill>
           <a:ln>
             <a:noFill/>
@@ -5464,7 +7921,7 @@
                 <a:latin typeface="Cambria"/>
                 <a:ea typeface="Microsoft JhengHei"/>
               </a:rPr>
-              <a:t>對比損失 L_con（S5）</a:t>
+              <a:t>復現的結論</a:t>
             </a:r>
           </a:p>
         </p:txBody>
@@ -5478,7 +7935,7 @@
         <p:spPr>
           <a:xfrm>
             <a:off x="822960" y="3566160"/>
-            <a:ext cx="2905658" cy="2011680"/>
+            <a:ext cx="2905658" cy="2103120"/>
           </a:xfrm>
           <a:prstGeom prst="rect">
             <a:avLst/>
@@ -5493,14 +7950,14 @@
           <a:p>
             <a:pPr algn="l"/>
             <a:r>
-              <a:rPr sz="1300" b="0" i="0">
+              <a:rPr sz="1250" b="0" i="0">
                 <a:solidFill>
                   <a:srgbClr val="DDE0E8"/>
                 </a:solidFill>
                 <a:latin typeface="Calibri"/>
                 <a:ea typeface="Microsoft JhengHei"/>
               </a:rPr>
-              <a:t>最後一個元件，也是三個裡唯一有不變性機制的。forward_pair 已回傳 (z_f, z̄_f)，train.py 已預留 Eq. (4) 的位置。事前預測與否證條件寫進 config 再跑。</a:t>
+              <a:t>三個元件在 source-only 協定下沒有一個重現得出增益：等向擴充 −0.0216、特徵生成 +0.0004、補上正負號 +0.0023，L_con 的前提已被量掉。與論文的 0.11 差距在其他五類，不在這三個元件。</a:t>
             </a:r>
           </a:p>
         </p:txBody>
@@ -5634,7 +8091,7 @@
                 <a:latin typeface="Cambria"/>
                 <a:ea typeface="Microsoft JhengHei"/>
               </a:rPr>
-              <a:t>給 Eq. (14) 加正負號（待決定）</a:t>
+              <a:t>留著的東西</a:t>
             </a:r>
           </a:p>
         </p:txBody>
@@ -5648,7 +8105,7 @@
         <p:spPr>
           <a:xfrm>
             <a:off x="4643018" y="3566160"/>
-            <a:ext cx="2905658" cy="2011680"/>
+            <a:ext cx="2905658" cy="2103120"/>
           </a:xfrm>
           <a:prstGeom prst="rect">
             <a:avLst/>
@@ -5663,14 +8120,14 @@
           <a:p>
             <a:pPr algn="l"/>
             <a:r>
-              <a:rPr sz="1300" b="0" i="0">
+              <a:rPr sz="1250" b="0" i="0">
                 <a:solidFill>
                   <a:srgbClr val="DDE0E8"/>
                 </a:solidFill>
                 <a:latin typeface="Calibri"/>
                 <a:ea typeface="Microsoft JhengHei"/>
               </a:rPr>
-              <a:t>方向用 Batch 1 自己的採集區塊偏移（source-only，對真實漂移 cos 0.850）。直接針對上一頁量到的失效機制，而且不看 target。</a:t>
+              <a:t>L_con 的實作、四格 config、事前預測與否證條件都在版控裡，補跑是 15 分鐘。另一個沒跑的乾淨對照：R-gen-shift 不帶輸入擴充對 R-fig-logps。</a:t>
             </a:r>
           </a:p>
         </p:txBody>
@@ -5804,7 +8261,7 @@
                 <a:latin typeface="Cambria"/>
                 <a:ea typeface="Microsoft JhengHei"/>
               </a:rPr>
-              <a:t>分開報告五類與六類</a:t>
+              <a:t>如果要往前走</a:t>
             </a:r>
           </a:p>
         </p:txBody>
@@ -5818,7 +8275,7 @@
         <p:spPr>
           <a:xfrm>
             <a:off x="8463076" y="3566160"/>
-            <a:ext cx="2905658" cy="2011680"/>
+            <a:ext cx="2905658" cy="2103120"/>
           </a:xfrm>
           <a:prstGeom prst="rect">
             <a:avLst/>
@@ -5833,14 +8290,14 @@
           <a:p>
             <a:pPr algn="l"/>
             <a:r>
-              <a:rPr sz="1300" b="0" i="0">
+              <a:rPr sz="1250" b="0" i="0">
                 <a:solidFill>
                   <a:srgbClr val="DDE0E8"/>
                 </a:solidFill>
                 <a:latin typeface="Calibri"/>
                 <a:ea typeface="Microsoft JhengHei"/>
               </a:rPr>
-              <a:t>Acetaldehyde 是所有共用方向方法的天花板，論文也沒救回它。任何後續結果都應同時給含它與不含它的 target mean。</a:t>
+              <a:t>唯一可分辨的槓桿是輸入端有方向的位移（+0.0214），而它的方向能從 Batch 1 自己估（cos 0.850）。任何後續結果都分五類與六類報告，Acetaldehyde 是共用方向方法的天花板。</a:t>
             </a:r>
           </a:p>
         </p:txBody>
@@ -5853,7 +8310,7 @@
 </p:sld>
 </file>
 
-<file path=ppt/slides/slide14.xml><?xml version="1.0" encoding="utf-8"?>
+<file path=ppt/slides/slide16.xml><?xml version="1.0" encoding="utf-8"?>
 <p:sld xmlns:a="http://schemas.openxmlformats.org/drawingml/2006/main" xmlns:p="http://schemas.openxmlformats.org/presentationml/2006/main" xmlns:r="http://schemas.openxmlformats.org/officeDocument/2006/relationships">
   <p:cSld>
     <p:spTree>
@@ -5909,7 +8366,7 @@
         </p:nvGraphicFramePr>
         <p:xfrm>
           <a:off x="548640" y="1463040"/>
-          <a:ext cx="6949439" cy="2487168"/>
+          <a:ext cx="6949439" cy="3108960"/>
         </p:xfrm>
         <a:graphic>
           <a:graphicData uri="http://schemas.openxmlformats.org/drawingml/2006/table">
@@ -6514,6 +8971,154 @@
                   </a:tcPr>
                 </a:tc>
               </a:tr>
+              <a:tr h="310896">
+                <a:tc>
+                  <a:txBody>
+                    <a:bodyPr wrap="square"/>
+                    <a:lstStyle/>
+                    <a:p>
+                      <a:pPr algn="ctr"/>
+                      <a:r>
+                        <a:rPr sz="1100" b="0" i="0">
+                          <a:solidFill>
+                            <a:srgbClr val="1C1C1E"/>
+                          </a:solidFill>
+                          <a:latin typeface="Calibri"/>
+                          <a:ea typeface="Microsoft JhengHei"/>
+                        </a:rPr>
+                        <a:t>8</a:t>
+                      </a:r>
+                    </a:p>
+                  </a:txBody>
+                  <a:tcPr marL="73152" marR="73152" marT="27432" marB="27432" anchor="ctr">
+                    <a:solidFill>
+                      <a:srgbClr val="FFFFFF"/>
+                    </a:solidFill>
+                  </a:tcPr>
+                </a:tc>
+                <a:tc>
+                  <a:txBody>
+                    <a:bodyPr wrap="square"/>
+                    <a:lstStyle/>
+                    <a:p>
+                      <a:pPr algn="l"/>
+                      <a:r>
+                        <a:rPr sz="1100" b="0" i="0">
+                          <a:solidFill>
+                            <a:srgbClr val="1C1C1E"/>
+                          </a:solidFill>
+                          <a:latin typeface="Calibri"/>
+                          <a:ea typeface="Microsoft JhengHei"/>
+                        </a:rPr>
+                        <a:t>—</a:t>
+                      </a:r>
+                    </a:p>
+                  </a:txBody>
+                  <a:tcPr marL="73152" marR="73152" marT="27432" marB="27432" anchor="ctr">
+                    <a:solidFill>
+                      <a:srgbClr val="FFFFFF"/>
+                    </a:solidFill>
+                  </a:tcPr>
+                </a:tc>
+                <a:tc>
+                  <a:txBody>
+                    <a:bodyPr wrap="square"/>
+                    <a:lstStyle/>
+                    <a:p>
+                      <a:pPr algn="l"/>
+                      <a:r>
+                        <a:rPr sz="1100" b="0" i="0">
+                          <a:solidFill>
+                            <a:srgbClr val="1C1C1E"/>
+                          </a:solidFill>
+                          <a:latin typeface="Calibri"/>
+                          <a:ea typeface="Microsoft JhengHei"/>
+                        </a:rPr>
+                        <a:t>表格；runs/20260929T031927475103Z_baseline_ladder_full</a:t>
+                      </a:r>
+                    </a:p>
+                  </a:txBody>
+                  <a:tcPr marL="73152" marR="73152" marT="27432" marB="27432" anchor="ctr">
+                    <a:solidFill>
+                      <a:srgbClr val="FFFFFF"/>
+                    </a:solidFill>
+                  </a:tcPr>
+                </a:tc>
+              </a:tr>
+              <a:tr h="310896">
+                <a:tc>
+                  <a:txBody>
+                    <a:bodyPr wrap="square"/>
+                    <a:lstStyle/>
+                    <a:p>
+                      <a:pPr algn="ctr"/>
+                      <a:r>
+                        <a:rPr sz="1100" b="0" i="0">
+                          <a:solidFill>
+                            <a:srgbClr val="1C1C1E"/>
+                          </a:solidFill>
+                          <a:latin typeface="Calibri"/>
+                          <a:ea typeface="Microsoft JhengHei"/>
+                        </a:rPr>
+                        <a:t>L_con</a:t>
+                      </a:r>
+                    </a:p>
+                  </a:txBody>
+                  <a:tcPr marL="73152" marR="73152" marT="27432" marB="27432" anchor="ctr">
+                    <a:solidFill>
+                      <a:srgbClr val="FFFFFF"/>
+                    </a:solidFill>
+                  </a:tcPr>
+                </a:tc>
+                <a:tc>
+                  <a:txBody>
+                    <a:bodyPr wrap="square"/>
+                    <a:lstStyle/>
+                    <a:p>
+                      <a:pPr algn="l"/>
+                      <a:r>
+                        <a:rPr sz="1100" b="0" i="0">
+                          <a:solidFill>
+                            <a:srgbClr val="1C1C1E"/>
+                          </a:solidFill>
+                          <a:latin typeface="Calibri"/>
+                          <a:ea typeface="Microsoft JhengHei"/>
+                        </a:rPr>
+                        <a:t>—</a:t>
+                      </a:r>
+                    </a:p>
+                  </a:txBody>
+                  <a:tcPr marL="73152" marR="73152" marT="27432" marB="27432" anchor="ctr">
+                    <a:solidFill>
+                      <a:srgbClr val="FFFFFF"/>
+                    </a:solidFill>
+                  </a:tcPr>
+                </a:tc>
+                <a:tc>
+                  <a:txBody>
+                    <a:bodyPr wrap="square"/>
+                    <a:lstStyle/>
+                    <a:p>
+                      <a:pPr algn="l"/>
+                      <a:r>
+                        <a:rPr sz="1100" b="0" i="0">
+                          <a:solidFill>
+                            <a:srgbClr val="1C1C1E"/>
+                          </a:solidFill>
+                          <a:latin typeface="Calibri"/>
+                          <a:ea typeface="Microsoft JhengHei"/>
+                        </a:rPr>
+                        <a:t>configs/contrastive.json、src/loss.py</a:t>
+                      </a:r>
+                    </a:p>
+                  </a:txBody>
+                  <a:tcPr marL="73152" marR="73152" marT="27432" marB="27432" anchor="ctr">
+                    <a:solidFill>
+                      <a:srgbClr val="FFFFFF"/>
+                    </a:solidFill>
+                  </a:tcPr>
+                </a:tc>
+              </a:tr>
             </a:tbl>
           </a:graphicData>
         </a:graphic>
@@ -6662,6 +9267,33 @@
                 <a:ea typeface="Microsoft JhengHei"/>
               </a:rPr>
               <a:t>v9.0  runs/20260923T071856507630Z_baseline_ladder_full</a:t>
+            </a:r>
+          </a:p>
+          <a:p>
+            <a:pPr>
+              <a:spcAft>
+                <a:spcPts val="300"/>
+              </a:spcAft>
+            </a:pPr>
+            <a:r>
+              <a:rPr sz="1000" b="0" i="0">
+                <a:solidFill>
+                  <a:srgbClr val="1C1C1E"/>
+                </a:solidFill>
+                <a:latin typeface="Calibri"/>
+                <a:ea typeface="Microsoft JhengHei"/>
+              </a:rPr>
+              <a:t>     </a:t>
+            </a:r>
+            <a:r>
+              <a:rPr sz="1000" b="0" i="0">
+                <a:solidFill>
+                  <a:srgbClr val="66666E"/>
+                </a:solidFill>
+                <a:latin typeface="Calibri"/>
+                <a:ea typeface="Microsoft JhengHei"/>
+              </a:rPr>
+              <a:t>v10.0  runs/20260929T031927475103Z_baseline_ladder_full</a:t>
             </a:r>
           </a:p>
           <a:p>

</xml_diff>

<commit_message>
Bring the deck's overview slide and date range up to v10 and the L_con decision
Co-Authored-By: Claude Fable 5.1 <noreply@anthropic.com>
</commit_message>
<xml_diff>
--- a/reports/cdcnn-implementation-issues.pptx
+++ b/reports/cdcnn-implementation-issues.pptx
@@ -3212,7 +3212,7 @@
                 <a:latin typeface="Calibri"/>
                 <a:ea typeface="Microsoft JhengHei"/>
               </a:rPr>
-              <a:t>UCI Gas Sensor Array Drift，Batch 1 訓練、Batch 2–10 評估  ·  五個 seed  ·  runs 2026-09-22 至 09-23  ·  分支 exp/v7-redesign</a:t>
+              <a:t>UCI Gas Sensor Array Drift，Batch 1 訓練、Batch 2–10 評估  ·  五個 seed  ·  runs 2026-09-22 至 09-29  ·  分支 exp/v7-redesign</a:t>
             </a:r>
           </a:p>
         </p:txBody>
@@ -9467,7 +9467,7 @@
         </p:nvGraphicFramePr>
         <p:xfrm>
           <a:off x="548640" y="1600200"/>
-          <a:ext cx="11094414" cy="2523744"/>
+          <a:ext cx="11094413" cy="2688336"/>
         </p:xfrm>
         <a:graphic>
           <a:graphicData uri="http://schemas.openxmlformats.org/drawingml/2006/table">
@@ -9476,12 +9476,12 @@
                 <a:tableStyleId>{5C22544A-7EE6-4342-B048-85BDC9FD1C3A}</a:tableStyleId>
               </a:tblPr>
               <a:tblGrid>
-                <a:gridCol w="3772101"/>
-                <a:gridCol w="3772101"/>
+                <a:gridCol w="3993989"/>
+                <a:gridCol w="3550212"/>
                 <a:gridCol w="1775106"/>
                 <a:gridCol w="1775106"/>
               </a:tblGrid>
-              <a:tr h="420624">
+              <a:tr h="384048">
                 <a:tc>
                   <a:txBody>
                     <a:bodyPr wrap="square"/>
@@ -9489,7 +9489,7 @@
                     <a:p>
                       <a:pPr algn="l"/>
                       <a:r>
-                        <a:rPr sz="1300" b="1" i="0">
+                        <a:rPr sz="1250" b="1" i="0">
                           <a:solidFill>
                             <a:srgbClr val="FFFFFF"/>
                           </a:solidFill>
@@ -9513,7 +9513,7 @@
                     <a:p>
                       <a:pPr algn="l"/>
                       <a:r>
-                        <a:rPr sz="1300" b="1" i="0">
+                        <a:rPr sz="1250" b="1" i="0">
                           <a:solidFill>
                             <a:srgbClr val="FFFFFF"/>
                           </a:solidFill>
@@ -9537,7 +9537,7 @@
                     <a:p>
                       <a:pPr algn="r"/>
                       <a:r>
-                        <a:rPr sz="1300" b="1" i="0">
+                        <a:rPr sz="1250" b="1" i="0">
                           <a:solidFill>
                             <a:srgbClr val="FFFFFF"/>
                           </a:solidFill>
@@ -9561,7 +9561,7 @@
                     <a:p>
                       <a:pPr algn="r"/>
                       <a:r>
-                        <a:rPr sz="1300" b="1" i="0">
+                        <a:rPr sz="1250" b="1" i="0">
                           <a:solidFill>
                             <a:srgbClr val="FFFFFF"/>
                           </a:solidFill>
@@ -9579,7 +9579,7 @@
                   </a:tcPr>
                 </a:tc>
               </a:tr>
-              <a:tr h="420624">
+              <a:tr h="384048">
                 <a:tc>
                   <a:txBody>
                     <a:bodyPr wrap="square"/>
@@ -9587,7 +9587,7 @@
                     <a:p>
                       <a:pPr algn="l"/>
                       <a:r>
-                        <a:rPr sz="1300" b="0" i="0">
+                        <a:rPr sz="1250" b="0" i="0">
                           <a:solidFill>
                             <a:srgbClr val="1C1C1E"/>
                           </a:solidFill>
@@ -9611,7 +9611,7 @@
                     <a:p>
                       <a:pPr algn="l"/>
                       <a:r>
-                        <a:rPr sz="1300" b="0" i="0">
+                        <a:rPr sz="1250" b="0" i="0">
                           <a:solidFill>
                             <a:srgbClr val="1C1C1E"/>
                           </a:solidFill>
@@ -9635,7 +9635,7 @@
                     <a:p>
                       <a:pPr algn="r"/>
                       <a:r>
-                        <a:rPr sz="1300" b="0" i="0">
+                        <a:rPr sz="1250" b="0" i="0">
                           <a:solidFill>
                             <a:srgbClr val="1C1C1E"/>
                           </a:solidFill>
@@ -9659,7 +9659,7 @@
                     <a:p>
                       <a:pPr algn="r"/>
                       <a:r>
-                        <a:rPr sz="1300" b="0" i="0">
+                        <a:rPr sz="1250" b="0" i="0">
                           <a:solidFill>
                             <a:srgbClr val="1C1C1E"/>
                           </a:solidFill>
@@ -9677,7 +9677,7 @@
                   </a:tcPr>
                 </a:tc>
               </a:tr>
-              <a:tr h="420624">
+              <a:tr h="384048">
                 <a:tc>
                   <a:txBody>
                     <a:bodyPr wrap="square"/>
@@ -9685,7 +9685,7 @@
                     <a:p>
                       <a:pPr algn="l"/>
                       <a:r>
-                        <a:rPr sz="1300" b="0" i="0">
+                        <a:rPr sz="1250" b="0" i="0">
                           <a:solidFill>
                             <a:srgbClr val="1C1C1E"/>
                           </a:solidFill>
@@ -9709,7 +9709,7 @@
                     <a:p>
                       <a:pPr algn="l"/>
                       <a:r>
-                        <a:rPr sz="1300" b="0" i="0">
+                        <a:rPr sz="1250" b="0" i="0">
                           <a:solidFill>
                             <a:srgbClr val="1C1C1E"/>
                           </a:solidFill>
@@ -9733,7 +9733,7 @@
                     <a:p>
                       <a:pPr algn="r"/>
                       <a:r>
-                        <a:rPr sz="1300" b="0" i="0">
+                        <a:rPr sz="1250" b="0" i="0">
                           <a:solidFill>
                             <a:srgbClr val="1C1C1E"/>
                           </a:solidFill>
@@ -9757,7 +9757,7 @@
                     <a:p>
                       <a:pPr algn="r"/>
                       <a:r>
-                        <a:rPr sz="1300" b="0" i="0">
+                        <a:rPr sz="1250" b="0" i="0">
                           <a:solidFill>
                             <a:srgbClr val="1C1C1E"/>
                           </a:solidFill>
@@ -9775,7 +9775,7 @@
                   </a:tcPr>
                 </a:tc>
               </a:tr>
-              <a:tr h="420624">
+              <a:tr h="384048">
                 <a:tc>
                   <a:txBody>
                     <a:bodyPr wrap="square"/>
@@ -9783,7 +9783,7 @@
                     <a:p>
                       <a:pPr algn="l"/>
                       <a:r>
-                        <a:rPr sz="1300" b="0" i="0">
+                        <a:rPr sz="1250" b="0" i="0">
                           <a:solidFill>
                             <a:srgbClr val="1C1C1E"/>
                           </a:solidFill>
@@ -9807,7 +9807,7 @@
                     <a:p>
                       <a:pPr algn="l"/>
                       <a:r>
-                        <a:rPr sz="1300" b="0" i="0">
+                        <a:rPr sz="1250" b="0" i="0">
                           <a:solidFill>
                             <a:srgbClr val="1C1C1E"/>
                           </a:solidFill>
@@ -9831,7 +9831,7 @@
                     <a:p>
                       <a:pPr algn="r"/>
                       <a:r>
-                        <a:rPr sz="1300" b="0" i="0">
+                        <a:rPr sz="1250" b="0" i="0">
                           <a:solidFill>
                             <a:srgbClr val="1C1C1E"/>
                           </a:solidFill>
@@ -9855,7 +9855,7 @@
                     <a:p>
                       <a:pPr algn="r"/>
                       <a:r>
-                        <a:rPr sz="1300" b="0" i="0">
+                        <a:rPr sz="1250" b="0" i="0">
                           <a:solidFill>
                             <a:srgbClr val="1C1C1E"/>
                           </a:solidFill>
@@ -9873,7 +9873,7 @@
                   </a:tcPr>
                 </a:tc>
               </a:tr>
-              <a:tr h="420624">
+              <a:tr h="384048">
                 <a:tc>
                   <a:txBody>
                     <a:bodyPr wrap="square"/>
@@ -9881,7 +9881,105 @@
                     <a:p>
                       <a:pPr algn="l"/>
                       <a:r>
-                        <a:rPr sz="1300" b="0" i="0">
+                        <a:rPr sz="1250" b="0" i="0">
+                          <a:solidFill>
+                            <a:srgbClr val="1C1C1E"/>
+                          </a:solidFill>
+                          <a:latin typeface="Calibri"/>
+                          <a:ea typeface="Microsoft JhengHei"/>
+                        </a:rPr>
+                        <a:t>特徵生成，Eq. (14) 補上正負號與幅度（v10）</a:t>
+                      </a:r>
+                    </a:p>
+                  </a:txBody>
+                  <a:tcPr marL="73152" marR="73152" marT="27432" marB="27432" anchor="ctr">
+                    <a:solidFill>
+                      <a:srgbClr val="FFFFFF"/>
+                    </a:solidFill>
+                  </a:tcPr>
+                </a:tc>
+                <a:tc>
+                  <a:txBody>
+                    <a:bodyPr wrap="square"/>
+                    <a:lstStyle/>
+                    <a:p>
+                      <a:pPr algn="l"/>
+                      <a:r>
+                        <a:rPr sz="1250" b="0" i="0">
+                          <a:solidFill>
+                            <a:srgbClr val="1C1C1E"/>
+                          </a:solidFill>
+                          <a:latin typeface="Calibri"/>
+                          <a:ea typeface="Microsoft JhengHei"/>
+                        </a:rPr>
+                        <a:t>照 v9 的診斷修了，仍不動</a:t>
+                      </a:r>
+                    </a:p>
+                  </a:txBody>
+                  <a:tcPr marL="73152" marR="73152" marT="27432" marB="27432" anchor="ctr">
+                    <a:solidFill>
+                      <a:srgbClr val="FFFFFF"/>
+                    </a:solidFill>
+                  </a:tcPr>
+                </a:tc>
+                <a:tc>
+                  <a:txBody>
+                    <a:bodyPr wrap="square"/>
+                    <a:lstStyle/>
+                    <a:p>
+                      <a:pPr algn="r"/>
+                      <a:r>
+                        <a:rPr sz="1250" b="0" i="0">
+                          <a:solidFill>
+                            <a:srgbClr val="1C1C1E"/>
+                          </a:solidFill>
+                          <a:latin typeface="Calibri"/>
+                          <a:ea typeface="Microsoft JhengHei"/>
+                        </a:rPr>
+                        <a:t>+0.0023</a:t>
+                      </a:r>
+                    </a:p>
+                  </a:txBody>
+                  <a:tcPr marL="73152" marR="73152" marT="27432" marB="27432" anchor="ctr">
+                    <a:solidFill>
+                      <a:srgbClr val="FFFFFF"/>
+                    </a:solidFill>
+                  </a:tcPr>
+                </a:tc>
+                <a:tc>
+                  <a:txBody>
+                    <a:bodyPr wrap="square"/>
+                    <a:lstStyle/>
+                    <a:p>
+                      <a:pPr algn="r"/>
+                      <a:r>
+                        <a:rPr sz="1250" b="0" i="0">
+                          <a:solidFill>
+                            <a:srgbClr val="1C1C1E"/>
+                          </a:solidFill>
+                          <a:latin typeface="Calibri"/>
+                          <a:ea typeface="Microsoft JhengHei"/>
+                        </a:rPr>
+                        <a:t>—</a:t>
+                      </a:r>
+                    </a:p>
+                  </a:txBody>
+                  <a:tcPr marL="73152" marR="73152" marT="27432" marB="27432" anchor="ctr">
+                    <a:solidFill>
+                      <a:srgbClr val="FFFFFF"/>
+                    </a:solidFill>
+                  </a:tcPr>
+                </a:tc>
+              </a:tr>
+              <a:tr h="384048">
+                <a:tc>
+                  <a:txBody>
+                    <a:bodyPr wrap="square"/>
+                    <a:lstStyle/>
+                    <a:p>
+                      <a:pPr algn="l"/>
+                      <a:r>
+                        <a:rPr sz="1250" b="0" i="0">
                           <a:solidFill>
                             <a:srgbClr val="1C1C1E"/>
                           </a:solidFill>
@@ -9905,14 +10003,14 @@
                     <a:p>
                       <a:pPr algn="l"/>
                       <a:r>
-                        <a:rPr sz="1300" b="0" i="0">
-                          <a:solidFill>
-                            <a:srgbClr val="1C1C1E"/>
-                          </a:solidFill>
-                          <a:latin typeface="Calibri"/>
-                          <a:ea typeface="Microsoft JhengHei"/>
-                        </a:rPr>
-                        <a:t>尚未</a:t>
+                        <a:rPr sz="1250" b="0" i="0">
+                          <a:solidFill>
+                            <a:srgbClr val="1C1C1E"/>
+                          </a:solidFill>
+                          <a:latin typeface="Calibri"/>
+                          <a:ea typeface="Microsoft JhengHei"/>
+                        </a:rPr>
+                        <a:t>已實作，決定不跑</a:t>
                       </a:r>
                     </a:p>
                   </a:txBody>
@@ -9929,7 +10027,7 @@
                     <a:p>
                       <a:pPr algn="r"/>
                       <a:r>
-                        <a:rPr sz="1300" b="0" i="0">
+                        <a:rPr sz="1250" b="0" i="0">
                           <a:solidFill>
                             <a:srgbClr val="1C1C1E"/>
                           </a:solidFill>
@@ -9953,7 +10051,7 @@
                     <a:p>
                       <a:pPr algn="r"/>
                       <a:r>
-                        <a:rPr sz="1300" b="0" i="0">
+                        <a:rPr sz="1250" b="0" i="0">
                           <a:solidFill>
                             <a:srgbClr val="1C1C1E"/>
                           </a:solidFill>
@@ -9971,7 +10069,7 @@
                   </a:tcPr>
                 </a:tc>
               </a:tr>
-              <a:tr h="420624">
+              <a:tr h="384048">
                 <a:tc>
                   <a:txBody>
                     <a:bodyPr wrap="square"/>
@@ -9979,7 +10077,7 @@
                     <a:p>
                       <a:pPr algn="l"/>
                       <a:r>
-                        <a:rPr sz="1300" b="1" i="0">
+                        <a:rPr sz="1250" b="1" i="0">
                           <a:solidFill>
                             <a:srgbClr val="1C1C1E"/>
                           </a:solidFill>
@@ -10003,7 +10101,7 @@
                     <a:p>
                       <a:pPr algn="l"/>
                       <a:r>
-                        <a:rPr sz="1300" b="1" i="0">
+                        <a:rPr sz="1250" b="1" i="0">
                           <a:solidFill>
                             <a:srgbClr val="1C1C1E"/>
                           </a:solidFill>
@@ -10027,7 +10125,7 @@
                     <a:p>
                       <a:pPr algn="r"/>
                       <a:r>
-                        <a:rPr sz="1300" b="1" i="0">
+                        <a:rPr sz="1250" b="1" i="0">
                           <a:solidFill>
                             <a:srgbClr val="1C1C1E"/>
                           </a:solidFill>
@@ -10051,7 +10149,7 @@
                     <a:p>
                       <a:pPr algn="r"/>
                       <a:r>
-                        <a:rPr sz="1300" b="1" i="0">
+                        <a:rPr sz="1250" b="1" i="0">
                           <a:solidFill>
                             <a:srgbClr val="1C1C1E"/>
                           </a:solidFill>
@@ -10081,7 +10179,7 @@
         </p:nvSpPr>
         <p:spPr>
           <a:xfrm>
-            <a:off x="548640" y="4434840"/>
+            <a:off x="548640" y="4526280"/>
             <a:ext cx="11094415" cy="2011680"/>
           </a:xfrm>
           <a:prstGeom prst="rect">
@@ -10172,7 +10270,7 @@
                 <a:latin typeface="Calibri"/>
                 <a:ea typeface="Microsoft JhengHei"/>
               </a:rPr>
-              <a:t>接下來每頁一個實作時撞到的問題，重點在第 6、7 頁</a:t>
+              <a:t>接下來每頁一個實作時撞到的問題，重點在問題 6、7、8</a:t>
             </a:r>
           </a:p>
         </p:txBody>
@@ -13717,7 +13815,7 @@
                 <a:latin typeface="Calibri"/>
                 <a:ea typeface="Microsoft JhengHei"/>
               </a:rPr>
-              <a:t>Source-only 的替代：Batch 1 自己兩個採集區塊的偏移能估到方向（cos 0.850），尚未拿來訓練</a:t>
+              <a:t>Source-only 的替代：Batch 1 自己兩個採集區塊的偏移能估到方向（cos 0.850）；v10 在 block 3 用過，輸入端還沒有</a:t>
             </a:r>
           </a:p>
         </p:txBody>

</xml_diff>

<commit_message>
Add v12 and the literature comparison to the deck
Two slides. The v12 slide records the projection result (+0.0128, not
separable), the mechanism numbers and the Batch 1 drift-axis figure. The
literature slide lines up fifteen results on the same Batch 1 -> Batches
2-10 setting, ordered by how much target information each method uses:
nothing (SVM 38.9, OSC 56.5, ours 55.6, the CDCNN paper's claimed 63.5 to
72.3), unlabelled target samples (DRCA 62.2, D-DRCA 73.8, GFK 64.0), two
source batches (AMDS-PFFA 83.2) and labelled target samples (DAELM 80.8 to
91.9). Sources: arXiv 1505.06405, 1901.02321, 2409.13167, 2507.17071. The
summary table, closing slide, appendix and outline are updated to match.

Co-Authored-By: Claude Fable 5.1 <noreply@anthropic.com>
</commit_message>
<xml_diff>
--- a/reports/cdcnn-implementation-issues.pptx
+++ b/reports/cdcnn-implementation-issues.pptx
@@ -21,6 +21,8 @@
     <p:sldId id="269" r:id="rId20"/>
     <p:sldId id="270" r:id="rId21"/>
     <p:sldId id="271" r:id="rId22"/>
+    <p:sldId id="272" r:id="rId23"/>
+    <p:sldId id="273" r:id="rId24"/>
   </p:sldIdLst>
   <p:sldSz cx="12191695" cy="6858000" type="screen4x3"/>
   <p:notesSz cx="6858000" cy="9144000"/>
@@ -6945,7 +6947,7 @@
                 <a:latin typeface="Cambria"/>
                 <a:ea typeface="Microsoft JhengHei"/>
               </a:rPr>
-              <a:t>總結：機制都重現了，增益沒有</a:t>
+              <a:t>我們自己的延伸：把 Batch 1 估到的漂移軸投影掉（v12）</a:t>
             </a:r>
           </a:p>
           <a:p>
@@ -6962,7 +6964,7 @@
                 <a:latin typeface="Calibri"/>
                 <a:ea typeface="Microsoft JhengHei"/>
               </a:rPr>
-              <a:t>兩個分支、兩個 backbone，兩個元件在 source-only 下都約零</a:t>
+              <a:t>離開 CDCNN，留在 source-only：x′ = x − U Uᵀ x，U 來自 Batch 1 兩次採集的偏移，不帶擴充、不帶生成區塊</a:t>
             </a:r>
           </a:p>
         </p:txBody>
@@ -6977,7 +6979,1449 @@
         </p:nvGraphicFramePr>
         <p:xfrm>
           <a:off x="548640" y="1600200"/>
-          <a:ext cx="11094413" cy="2304288"/>
+          <a:ext cx="6766558" cy="1737360"/>
+        </p:xfrm>
+        <a:graphic>
+          <a:graphicData uri="http://schemas.openxmlformats.org/drawingml/2006/table">
+            <a:tbl>
+              <a:tblPr firstRow="0" bandRow="0">
+                <a:tableStyleId>{5C22544A-7EE6-4342-B048-85BDC9FD1C3A}</a:tableStyleId>
+              </a:tblPr>
+              <a:tblGrid>
+                <a:gridCol w="1014984"/>
+                <a:gridCol w="2503627"/>
+                <a:gridCol w="338328"/>
+                <a:gridCol w="947318"/>
+                <a:gridCol w="879652"/>
+                <a:gridCol w="1082649"/>
+              </a:tblGrid>
+              <a:tr h="347472">
+                <a:tc>
+                  <a:txBody>
+                    <a:bodyPr wrap="square"/>
+                    <a:lstStyle/>
+                    <a:p>
+                      <a:pPr algn="l"/>
+                      <a:r>
+                        <a:rPr sz="1050" b="1" i="0">
+                          <a:solidFill>
+                            <a:srgbClr val="FFFFFF"/>
+                          </a:solidFill>
+                          <a:latin typeface="Calibri"/>
+                          <a:ea typeface="Microsoft JhengHei"/>
+                        </a:rPr>
+                        <a:t>變體</a:t>
+                      </a:r>
+                    </a:p>
+                  </a:txBody>
+                  <a:tcPr marL="73152" marR="73152" marT="27432" marB="27432" anchor="ctr">
+                    <a:solidFill>
+                      <a:srgbClr val="2B2D42"/>
+                    </a:solidFill>
+                  </a:tcPr>
+                </a:tc>
+                <a:tc>
+                  <a:txBody>
+                    <a:bodyPr wrap="square"/>
+                    <a:lstStyle/>
+                    <a:p>
+                      <a:pPr algn="l"/>
+                      <a:r>
+                        <a:rPr sz="1050" b="1" i="0">
+                          <a:solidFill>
+                            <a:srgbClr val="FFFFFF"/>
+                          </a:solidFill>
+                          <a:latin typeface="Calibri"/>
+                          <a:ea typeface="Microsoft JhengHei"/>
+                        </a:rPr>
+                        <a:t>拿掉</a:t>
+                      </a:r>
+                    </a:p>
+                  </a:txBody>
+                  <a:tcPr marL="73152" marR="73152" marT="27432" marB="27432" anchor="ctr">
+                    <a:solidFill>
+                      <a:srgbClr val="2B2D42"/>
+                    </a:solidFill>
+                  </a:tcPr>
+                </a:tc>
+                <a:tc>
+                  <a:txBody>
+                    <a:bodyPr wrap="square"/>
+                    <a:lstStyle/>
+                    <a:p>
+                      <a:pPr algn="ctr"/>
+                      <a:r>
+                        <a:rPr sz="1050" b="1" i="0">
+                          <a:solidFill>
+                            <a:srgbClr val="FFFFFF"/>
+                          </a:solidFill>
+                          <a:latin typeface="Calibri"/>
+                          <a:ea typeface="Microsoft JhengHei"/>
+                        </a:rPr>
+                        <a:t>k</a:t>
+                      </a:r>
+                    </a:p>
+                  </a:txBody>
+                  <a:tcPr marL="73152" marR="73152" marT="27432" marB="27432" anchor="ctr">
+                    <a:solidFill>
+                      <a:srgbClr val="2B2D42"/>
+                    </a:solidFill>
+                  </a:tcPr>
+                </a:tc>
+                <a:tc>
+                  <a:txBody>
+                    <a:bodyPr wrap="square"/>
+                    <a:lstStyle/>
+                    <a:p>
+                      <a:pPr algn="r"/>
+                      <a:r>
+                        <a:rPr sz="1050" b="1" i="0">
+                          <a:solidFill>
+                            <a:srgbClr val="FFFFFF"/>
+                          </a:solidFill>
+                          <a:latin typeface="Calibri"/>
+                          <a:ea typeface="Microsoft JhengHei"/>
+                        </a:rPr>
+                        <a:t>target mean</a:t>
+                      </a:r>
+                    </a:p>
+                  </a:txBody>
+                  <a:tcPr marL="73152" marR="73152" marT="27432" marB="27432" anchor="ctr">
+                    <a:solidFill>
+                      <a:srgbClr val="2B2D42"/>
+                    </a:solidFill>
+                  </a:tcPr>
+                </a:tc>
+                <a:tc>
+                  <a:txBody>
+                    <a:bodyPr wrap="square"/>
+                    <a:lstStyle/>
+                    <a:p>
+                      <a:pPr algn="r"/>
+                      <a:r>
+                        <a:rPr sz="1050" b="1" i="0">
+                          <a:solidFill>
+                            <a:srgbClr val="FFFFFF"/>
+                          </a:solidFill>
+                          <a:latin typeface="Calibri"/>
+                          <a:ea typeface="Microsoft JhengHei"/>
+                        </a:rPr>
+                        <a:t>vs 基準</a:t>
+                      </a:r>
+                    </a:p>
+                  </a:txBody>
+                  <a:tcPr marL="73152" marR="73152" marT="27432" marB="27432" anchor="ctr">
+                    <a:solidFill>
+                      <a:srgbClr val="2B2D42"/>
+                    </a:solidFill>
+                  </a:tcPr>
+                </a:tc>
+                <a:tc>
+                  <a:txBody>
+                    <a:bodyPr wrap="square"/>
+                    <a:lstStyle/>
+                    <a:p>
+                      <a:pPr algn="l"/>
+                      <a:r>
+                        <a:rPr sz="1050" b="1" i="0">
+                          <a:solidFill>
+                            <a:srgbClr val="FFFFFF"/>
+                          </a:solidFill>
+                          <a:latin typeface="Calibri"/>
+                          <a:ea typeface="Microsoft JhengHei"/>
+                        </a:rPr>
+                        <a:t>可分辨</a:t>
+                      </a:r>
+                    </a:p>
+                  </a:txBody>
+                  <a:tcPr marL="73152" marR="73152" marT="27432" marB="27432" anchor="ctr">
+                    <a:solidFill>
+                      <a:srgbClr val="2B2D42"/>
+                    </a:solidFill>
+                  </a:tcPr>
+                </a:tc>
+              </a:tr>
+              <a:tr h="347472">
+                <a:tc>
+                  <a:txBody>
+                    <a:bodyPr wrap="square"/>
+                    <a:lstStyle/>
+                    <a:p>
+                      <a:pPr algn="l"/>
+                      <a:r>
+                        <a:rPr sz="1050" b="0" i="0">
+                          <a:solidFill>
+                            <a:srgbClr val="1C1C1E"/>
+                          </a:solidFill>
+                          <a:latin typeface="Calibri"/>
+                          <a:ea typeface="Microsoft JhengHei"/>
+                        </a:rPr>
+                        <a:t>R-proj-eth</a:t>
+                      </a:r>
+                    </a:p>
+                  </a:txBody>
+                  <a:tcPr marL="73152" marR="73152" marT="27432" marB="27432" anchor="ctr">
+                    <a:solidFill>
+                      <a:srgbClr val="FFFFFF"/>
+                    </a:solidFill>
+                  </a:tcPr>
+                </a:tc>
+                <a:tc>
+                  <a:txBody>
+                    <a:bodyPr wrap="square"/>
+                    <a:lstStyle/>
+                    <a:p>
+                      <a:pPr algn="l"/>
+                      <a:r>
+                        <a:rPr sz="1050" b="0" i="0">
+                          <a:solidFill>
+                            <a:srgbClr val="1C1C1E"/>
+                          </a:solidFill>
+                          <a:latin typeface="Calibri"/>
+                          <a:ea typeface="Microsoft JhengHei"/>
+                        </a:rPr>
+                        <a:t>Ethanol 的採集偏移（選它是看過 target）</a:t>
+                      </a:r>
+                    </a:p>
+                  </a:txBody>
+                  <a:tcPr marL="73152" marR="73152" marT="27432" marB="27432" anchor="ctr">
+                    <a:solidFill>
+                      <a:srgbClr val="FFFFFF"/>
+                    </a:solidFill>
+                  </a:tcPr>
+                </a:tc>
+                <a:tc>
+                  <a:txBody>
+                    <a:bodyPr wrap="square"/>
+                    <a:lstStyle/>
+                    <a:p>
+                      <a:pPr algn="ctr"/>
+                      <a:r>
+                        <a:rPr sz="1050" b="0" i="0">
+                          <a:solidFill>
+                            <a:srgbClr val="1C1C1E"/>
+                          </a:solidFill>
+                          <a:latin typeface="Calibri"/>
+                          <a:ea typeface="Microsoft JhengHei"/>
+                        </a:rPr>
+                        <a:t>1</a:t>
+                      </a:r>
+                    </a:p>
+                  </a:txBody>
+                  <a:tcPr marL="73152" marR="73152" marT="27432" marB="27432" anchor="ctr">
+                    <a:solidFill>
+                      <a:srgbClr val="FFFFFF"/>
+                    </a:solidFill>
+                  </a:tcPr>
+                </a:tc>
+                <a:tc>
+                  <a:txBody>
+                    <a:bodyPr wrap="square"/>
+                    <a:lstStyle/>
+                    <a:p>
+                      <a:pPr algn="r"/>
+                      <a:r>
+                        <a:rPr sz="1050" b="0" i="0">
+                          <a:solidFill>
+                            <a:srgbClr val="1C1C1E"/>
+                          </a:solidFill>
+                          <a:latin typeface="Calibri"/>
+                          <a:ea typeface="Microsoft JhengHei"/>
+                        </a:rPr>
+                        <a:t>0.5747</a:t>
+                      </a:r>
+                    </a:p>
+                  </a:txBody>
+                  <a:tcPr marL="73152" marR="73152" marT="27432" marB="27432" anchor="ctr">
+                    <a:solidFill>
+                      <a:srgbClr val="FFFFFF"/>
+                    </a:solidFill>
+                  </a:tcPr>
+                </a:tc>
+                <a:tc>
+                  <a:txBody>
+                    <a:bodyPr wrap="square"/>
+                    <a:lstStyle/>
+                    <a:p>
+                      <a:pPr algn="r"/>
+                      <a:r>
+                        <a:rPr sz="1050" b="0" i="0">
+                          <a:solidFill>
+                            <a:srgbClr val="1C1C1E"/>
+                          </a:solidFill>
+                          <a:latin typeface="Calibri"/>
+                          <a:ea typeface="Microsoft JhengHei"/>
+                        </a:rPr>
+                        <a:t>+0.0191</a:t>
+                      </a:r>
+                    </a:p>
+                  </a:txBody>
+                  <a:tcPr marL="73152" marR="73152" marT="27432" marB="27432" anchor="ctr">
+                    <a:solidFill>
+                      <a:srgbClr val="FFFFFF"/>
+                    </a:solidFill>
+                  </a:tcPr>
+                </a:tc>
+                <a:tc>
+                  <a:txBody>
+                    <a:bodyPr wrap="square"/>
+                    <a:lstStyle/>
+                    <a:p>
+                      <a:pPr algn="l"/>
+                      <a:r>
+                        <a:rPr sz="1050" b="0" i="0">
+                          <a:solidFill>
+                            <a:srgbClr val="1C1C1E"/>
+                          </a:solidFill>
+                          <a:latin typeface="Calibri"/>
+                          <a:ea typeface="Microsoft JhengHei"/>
+                        </a:rPr>
+                        <a:t>是（上界）</a:t>
+                      </a:r>
+                    </a:p>
+                  </a:txBody>
+                  <a:tcPr marL="73152" marR="73152" marT="27432" marB="27432" anchor="ctr">
+                    <a:solidFill>
+                      <a:srgbClr val="FFFFFF"/>
+                    </a:solidFill>
+                  </a:tcPr>
+                </a:tc>
+              </a:tr>
+              <a:tr h="347472">
+                <a:tc>
+                  <a:txBody>
+                    <a:bodyPr wrap="square"/>
+                    <a:lstStyle/>
+                    <a:p>
+                      <a:pPr algn="l"/>
+                      <a:r>
+                        <a:rPr sz="1050" b="1" i="0">
+                          <a:solidFill>
+                            <a:srgbClr val="1C1C1E"/>
+                          </a:solidFill>
+                          <a:latin typeface="Calibri"/>
+                          <a:ea typeface="Microsoft JhengHei"/>
+                        </a:rPr>
+                        <a:t>R-proj-axis</a:t>
+                      </a:r>
+                    </a:p>
+                  </a:txBody>
+                  <a:tcPr marL="73152" marR="73152" marT="27432" marB="27432" anchor="ctr">
+                    <a:solidFill>
+                      <a:srgbClr val="F3F4F6"/>
+                    </a:solidFill>
+                  </a:tcPr>
+                </a:tc>
+                <a:tc>
+                  <a:txBody>
+                    <a:bodyPr wrap="square"/>
+                    <a:lstStyle/>
+                    <a:p>
+                      <a:pPr algn="l"/>
+                      <a:r>
+                        <a:rPr sz="1050" b="1" i="0">
+                          <a:solidFill>
+                            <a:srgbClr val="1C1C1E"/>
+                          </a:solidFill>
+                          <a:latin typeface="Calibri"/>
+                          <a:ea typeface="Microsoft JhengHei"/>
+                        </a:rPr>
+                        <a:t>三個偏移的共同軸（頭條）</a:t>
+                      </a:r>
+                    </a:p>
+                  </a:txBody>
+                  <a:tcPr marL="73152" marR="73152" marT="27432" marB="27432" anchor="ctr">
+                    <a:solidFill>
+                      <a:srgbClr val="F3F4F6"/>
+                    </a:solidFill>
+                  </a:tcPr>
+                </a:tc>
+                <a:tc>
+                  <a:txBody>
+                    <a:bodyPr wrap="square"/>
+                    <a:lstStyle/>
+                    <a:p>
+                      <a:pPr algn="ctr"/>
+                      <a:r>
+                        <a:rPr sz="1050" b="1" i="0">
+                          <a:solidFill>
+                            <a:srgbClr val="1C1C1E"/>
+                          </a:solidFill>
+                          <a:latin typeface="Calibri"/>
+                          <a:ea typeface="Microsoft JhengHei"/>
+                        </a:rPr>
+                        <a:t>1</a:t>
+                      </a:r>
+                    </a:p>
+                  </a:txBody>
+                  <a:tcPr marL="73152" marR="73152" marT="27432" marB="27432" anchor="ctr">
+                    <a:solidFill>
+                      <a:srgbClr val="F3F4F6"/>
+                    </a:solidFill>
+                  </a:tcPr>
+                </a:tc>
+                <a:tc>
+                  <a:txBody>
+                    <a:bodyPr wrap="square"/>
+                    <a:lstStyle/>
+                    <a:p>
+                      <a:pPr algn="r"/>
+                      <a:r>
+                        <a:rPr sz="1050" b="1" i="0">
+                          <a:solidFill>
+                            <a:srgbClr val="1C1C1E"/>
+                          </a:solidFill>
+                          <a:latin typeface="Calibri"/>
+                          <a:ea typeface="Microsoft JhengHei"/>
+                        </a:rPr>
+                        <a:t>0.5684</a:t>
+                      </a:r>
+                    </a:p>
+                  </a:txBody>
+                  <a:tcPr marL="73152" marR="73152" marT="27432" marB="27432" anchor="ctr">
+                    <a:solidFill>
+                      <a:srgbClr val="F3F4F6"/>
+                    </a:solidFill>
+                  </a:tcPr>
+                </a:tc>
+                <a:tc>
+                  <a:txBody>
+                    <a:bodyPr wrap="square"/>
+                    <a:lstStyle/>
+                    <a:p>
+                      <a:pPr algn="r"/>
+                      <a:r>
+                        <a:rPr sz="1050" b="1" i="0">
+                          <a:solidFill>
+                            <a:srgbClr val="1C1C1E"/>
+                          </a:solidFill>
+                          <a:latin typeface="Calibri"/>
+                          <a:ea typeface="Microsoft JhengHei"/>
+                        </a:rPr>
+                        <a:t>+0.0128</a:t>
+                      </a:r>
+                    </a:p>
+                  </a:txBody>
+                  <a:tcPr marL="73152" marR="73152" marT="27432" marB="27432" anchor="ctr">
+                    <a:solidFill>
+                      <a:srgbClr val="F3F4F6"/>
+                    </a:solidFill>
+                  </a:tcPr>
+                </a:tc>
+                <a:tc>
+                  <a:txBody>
+                    <a:bodyPr wrap="square"/>
+                    <a:lstStyle/>
+                    <a:p>
+                      <a:pPr algn="l"/>
+                      <a:r>
+                        <a:rPr sz="1050" b="1" i="0">
+                          <a:solidFill>
+                            <a:srgbClr val="1C1C1E"/>
+                          </a:solidFill>
+                          <a:latin typeface="Calibri"/>
+                          <a:ea typeface="Microsoft JhengHei"/>
+                        </a:rPr>
+                        <a:t>否，門檻 0.0145</a:t>
+                      </a:r>
+                    </a:p>
+                  </a:txBody>
+                  <a:tcPr marL="73152" marR="73152" marT="27432" marB="27432" anchor="ctr">
+                    <a:solidFill>
+                      <a:srgbClr val="F3F4F6"/>
+                    </a:solidFill>
+                  </a:tcPr>
+                </a:tc>
+              </a:tr>
+              <a:tr h="347472">
+                <a:tc>
+                  <a:txBody>
+                    <a:bodyPr wrap="square"/>
+                    <a:lstStyle/>
+                    <a:p>
+                      <a:pPr algn="l"/>
+                      <a:r>
+                        <a:rPr sz="1050" b="0" i="0">
+                          <a:solidFill>
+                            <a:srgbClr val="1C1C1E"/>
+                          </a:solidFill>
+                          <a:latin typeface="Calibri"/>
+                          <a:ea typeface="Microsoft JhengHei"/>
+                        </a:rPr>
+                        <a:t>R-proj-sub3</a:t>
+                      </a:r>
+                    </a:p>
+                  </a:txBody>
+                  <a:tcPr marL="73152" marR="73152" marT="27432" marB="27432" anchor="ctr">
+                    <a:solidFill>
+                      <a:srgbClr val="FFFFFF"/>
+                    </a:solidFill>
+                  </a:tcPr>
+                </a:tc>
+                <a:tc>
+                  <a:txBody>
+                    <a:bodyPr wrap="square"/>
+                    <a:lstStyle/>
+                    <a:p>
+                      <a:pPr algn="l"/>
+                      <a:r>
+                        <a:rPr sz="1050" b="0" i="0">
+                          <a:solidFill>
+                            <a:srgbClr val="1C1C1E"/>
+                          </a:solidFill>
+                          <a:latin typeface="Calibri"/>
+                          <a:ea typeface="Microsoft JhengHei"/>
+                        </a:rPr>
+                        <a:t>三個偏移張成的空間</a:t>
+                      </a:r>
+                    </a:p>
+                  </a:txBody>
+                  <a:tcPr marL="73152" marR="73152" marT="27432" marB="27432" anchor="ctr">
+                    <a:solidFill>
+                      <a:srgbClr val="FFFFFF"/>
+                    </a:solidFill>
+                  </a:tcPr>
+                </a:tc>
+                <a:tc>
+                  <a:txBody>
+                    <a:bodyPr wrap="square"/>
+                    <a:lstStyle/>
+                    <a:p>
+                      <a:pPr algn="ctr"/>
+                      <a:r>
+                        <a:rPr sz="1050" b="0" i="0">
+                          <a:solidFill>
+                            <a:srgbClr val="1C1C1E"/>
+                          </a:solidFill>
+                          <a:latin typeface="Calibri"/>
+                          <a:ea typeface="Microsoft JhengHei"/>
+                        </a:rPr>
+                        <a:t>3</a:t>
+                      </a:r>
+                    </a:p>
+                  </a:txBody>
+                  <a:tcPr marL="73152" marR="73152" marT="27432" marB="27432" anchor="ctr">
+                    <a:solidFill>
+                      <a:srgbClr val="FFFFFF"/>
+                    </a:solidFill>
+                  </a:tcPr>
+                </a:tc>
+                <a:tc>
+                  <a:txBody>
+                    <a:bodyPr wrap="square"/>
+                    <a:lstStyle/>
+                    <a:p>
+                      <a:pPr algn="r"/>
+                      <a:r>
+                        <a:rPr sz="1050" b="0" i="0">
+                          <a:solidFill>
+                            <a:srgbClr val="1C1C1E"/>
+                          </a:solidFill>
+                          <a:latin typeface="Calibri"/>
+                          <a:ea typeface="Microsoft JhengHei"/>
+                        </a:rPr>
+                        <a:t>0.5610</a:t>
+                      </a:r>
+                    </a:p>
+                  </a:txBody>
+                  <a:tcPr marL="73152" marR="73152" marT="27432" marB="27432" anchor="ctr">
+                    <a:solidFill>
+                      <a:srgbClr val="FFFFFF"/>
+                    </a:solidFill>
+                  </a:tcPr>
+                </a:tc>
+                <a:tc>
+                  <a:txBody>
+                    <a:bodyPr wrap="square"/>
+                    <a:lstStyle/>
+                    <a:p>
+                      <a:pPr algn="r"/>
+                      <a:r>
+                        <a:rPr sz="1050" b="0" i="0">
+                          <a:solidFill>
+                            <a:srgbClr val="1C1C1E"/>
+                          </a:solidFill>
+                          <a:latin typeface="Calibri"/>
+                          <a:ea typeface="Microsoft JhengHei"/>
+                        </a:rPr>
+                        <a:t>+0.0055</a:t>
+                      </a:r>
+                    </a:p>
+                  </a:txBody>
+                  <a:tcPr marL="73152" marR="73152" marT="27432" marB="27432" anchor="ctr">
+                    <a:solidFill>
+                      <a:srgbClr val="FFFFFF"/>
+                    </a:solidFill>
+                  </a:tcPr>
+                </a:tc>
+                <a:tc>
+                  <a:txBody>
+                    <a:bodyPr wrap="square"/>
+                    <a:lstStyle/>
+                    <a:p>
+                      <a:pPr algn="l"/>
+                      <a:r>
+                        <a:rPr sz="1050" b="0" i="0">
+                          <a:solidFill>
+                            <a:srgbClr val="1C1C1E"/>
+                          </a:solidFill>
+                          <a:latin typeface="Calibri"/>
+                          <a:ea typeface="Microsoft JhengHei"/>
+                        </a:rPr>
+                        <a:t>否</a:t>
+                      </a:r>
+                    </a:p>
+                  </a:txBody>
+                  <a:tcPr marL="73152" marR="73152" marT="27432" marB="27432" anchor="ctr">
+                    <a:solidFill>
+                      <a:srgbClr val="FFFFFF"/>
+                    </a:solidFill>
+                  </a:tcPr>
+                </a:tc>
+              </a:tr>
+              <a:tr h="347472">
+                <a:tc>
+                  <a:txBody>
+                    <a:bodyPr wrap="square"/>
+                    <a:lstStyle/>
+                    <a:p>
+                      <a:pPr algn="l"/>
+                      <a:r>
+                        <a:rPr sz="1050" b="0" i="0">
+                          <a:solidFill>
+                            <a:srgbClr val="1C1C1E"/>
+                          </a:solidFill>
+                          <a:latin typeface="Calibri"/>
+                          <a:ea typeface="Microsoft JhengHei"/>
+                        </a:rPr>
+                        <a:t>R-fig-logps</a:t>
+                      </a:r>
+                    </a:p>
+                  </a:txBody>
+                  <a:tcPr marL="73152" marR="73152" marT="27432" marB="27432" anchor="ctr">
+                    <a:solidFill>
+                      <a:srgbClr val="FFFFFF"/>
+                    </a:solidFill>
+                  </a:tcPr>
+                </a:tc>
+                <a:tc>
+                  <a:txBody>
+                    <a:bodyPr wrap="square"/>
+                    <a:lstStyle/>
+                    <a:p>
+                      <a:pPr algn="l"/>
+                      <a:r>
+                        <a:rPr sz="1050" b="0" i="0">
+                          <a:solidFill>
+                            <a:srgbClr val="1C1C1E"/>
+                          </a:solidFill>
+                          <a:latin typeface="Calibri"/>
+                          <a:ea typeface="Microsoft JhengHei"/>
+                        </a:rPr>
+                        <a:t>不拿</a:t>
+                      </a:r>
+                    </a:p>
+                  </a:txBody>
+                  <a:tcPr marL="73152" marR="73152" marT="27432" marB="27432" anchor="ctr">
+                    <a:solidFill>
+                      <a:srgbClr val="FFFFFF"/>
+                    </a:solidFill>
+                  </a:tcPr>
+                </a:tc>
+                <a:tc>
+                  <a:txBody>
+                    <a:bodyPr wrap="square"/>
+                    <a:lstStyle/>
+                    <a:p>
+                      <a:pPr algn="ctr"/>
+                      <a:r>
+                        <a:rPr sz="1050" b="0" i="0">
+                          <a:solidFill>
+                            <a:srgbClr val="1C1C1E"/>
+                          </a:solidFill>
+                          <a:latin typeface="Calibri"/>
+                          <a:ea typeface="Microsoft JhengHei"/>
+                        </a:rPr>
+                        <a:t>0</a:t>
+                      </a:r>
+                    </a:p>
+                  </a:txBody>
+                  <a:tcPr marL="73152" marR="73152" marT="27432" marB="27432" anchor="ctr">
+                    <a:solidFill>
+                      <a:srgbClr val="FFFFFF"/>
+                    </a:solidFill>
+                  </a:tcPr>
+                </a:tc>
+                <a:tc>
+                  <a:txBody>
+                    <a:bodyPr wrap="square"/>
+                    <a:lstStyle/>
+                    <a:p>
+                      <a:pPr algn="r"/>
+                      <a:r>
+                        <a:rPr sz="1050" b="0" i="0">
+                          <a:solidFill>
+                            <a:srgbClr val="1C1C1E"/>
+                          </a:solidFill>
+                          <a:latin typeface="Calibri"/>
+                          <a:ea typeface="Microsoft JhengHei"/>
+                        </a:rPr>
+                        <a:t>0.5556</a:t>
+                      </a:r>
+                    </a:p>
+                  </a:txBody>
+                  <a:tcPr marL="73152" marR="73152" marT="27432" marB="27432" anchor="ctr">
+                    <a:solidFill>
+                      <a:srgbClr val="FFFFFF"/>
+                    </a:solidFill>
+                  </a:tcPr>
+                </a:tc>
+                <a:tc>
+                  <a:txBody>
+                    <a:bodyPr wrap="square"/>
+                    <a:lstStyle/>
+                    <a:p>
+                      <a:pPr algn="r"/>
+                      <a:r>
+                        <a:rPr sz="1050" b="0" i="0">
+                          <a:solidFill>
+                            <a:srgbClr val="1C1C1E"/>
+                          </a:solidFill>
+                          <a:latin typeface="Calibri"/>
+                          <a:ea typeface="Microsoft JhengHei"/>
+                        </a:rPr>
+                        <a:t>—</a:t>
+                      </a:r>
+                    </a:p>
+                  </a:txBody>
+                  <a:tcPr marL="73152" marR="73152" marT="27432" marB="27432" anchor="ctr">
+                    <a:solidFill>
+                      <a:srgbClr val="FFFFFF"/>
+                    </a:solidFill>
+                  </a:tcPr>
+                </a:tc>
+                <a:tc>
+                  <a:txBody>
+                    <a:bodyPr wrap="square"/>
+                    <a:lstStyle/>
+                    <a:p>
+                      <a:pPr algn="l"/>
+                      <a:r>
+                        <a:rPr sz="1050" b="0" i="0">
+                          <a:solidFill>
+                            <a:srgbClr val="1C1C1E"/>
+                          </a:solidFill>
+                          <a:latin typeface="Calibri"/>
+                          <a:ea typeface="Microsoft JhengHei"/>
+                        </a:rPr>
+                        <a:t>—</a:t>
+                      </a:r>
+                    </a:p>
+                  </a:txBody>
+                  <a:tcPr marL="73152" marR="73152" marT="27432" marB="27432" anchor="ctr">
+                    <a:solidFill>
+                      <a:srgbClr val="FFFFFF"/>
+                    </a:solidFill>
+                  </a:tcPr>
+                </a:tc>
+              </a:tr>
+            </a:tbl>
+          </a:graphicData>
+        </a:graphic>
+      </p:graphicFrame>
+      <p:graphicFrame>
+        <p:nvGraphicFramePr>
+          <p:cNvPr id="4" name="Table 3"/>
+          <p:cNvGraphicFramePr>
+            <a:graphicFrameLocks noGrp="1"/>
+          </p:cNvGraphicFramePr>
+          <p:nvPr/>
+        </p:nvGraphicFramePr>
+        <p:xfrm>
+          <a:off x="7589520" y="1600200"/>
+          <a:ext cx="4069078" cy="1389888"/>
+        </p:xfrm>
+        <a:graphic>
+          <a:graphicData uri="http://schemas.openxmlformats.org/drawingml/2006/table">
+            <a:tbl>
+              <a:tblPr firstRow="0" bandRow="0">
+                <a:tableStyleId>{5C22544A-7EE6-4342-B048-85BDC9FD1C3A}</a:tableStyleId>
+              </a:tblPr>
+              <a:tblGrid>
+                <a:gridCol w="1993849"/>
+                <a:gridCol w="691743"/>
+                <a:gridCol w="691743"/>
+                <a:gridCol w="691743"/>
+              </a:tblGrid>
+              <a:tr h="347472">
+                <a:tc>
+                  <a:txBody>
+                    <a:bodyPr wrap="square"/>
+                    <a:lstStyle/>
+                    <a:p>
+                      <a:pPr algn="l"/>
+                      <a:r>
+                        <a:rPr sz="1100" b="1" i="0">
+                          <a:solidFill>
+                            <a:srgbClr val="FFFFFF"/>
+                          </a:solidFill>
+                          <a:latin typeface="Calibri"/>
+                          <a:ea typeface="Microsoft JhengHei"/>
+                        </a:rPr>
+                        <a:t>機制指標</a:t>
+                      </a:r>
+                    </a:p>
+                  </a:txBody>
+                  <a:tcPr marL="73152" marR="73152" marT="27432" marB="27432" anchor="ctr">
+                    <a:solidFill>
+                      <a:srgbClr val="2B2D42"/>
+                    </a:solidFill>
+                  </a:tcPr>
+                </a:tc>
+                <a:tc>
+                  <a:txBody>
+                    <a:bodyPr wrap="square"/>
+                    <a:lstStyle/>
+                    <a:p>
+                      <a:pPr algn="r"/>
+                      <a:r>
+                        <a:rPr sz="1100" b="1" i="0">
+                          <a:solidFill>
+                            <a:srgbClr val="FFFFFF"/>
+                          </a:solidFill>
+                          <a:latin typeface="Calibri"/>
+                          <a:ea typeface="Microsoft JhengHei"/>
+                        </a:rPr>
+                        <a:t>axis</a:t>
+                      </a:r>
+                    </a:p>
+                  </a:txBody>
+                  <a:tcPr marL="73152" marR="73152" marT="27432" marB="27432" anchor="ctr">
+                    <a:solidFill>
+                      <a:srgbClr val="2B2D42"/>
+                    </a:solidFill>
+                  </a:tcPr>
+                </a:tc>
+                <a:tc>
+                  <a:txBody>
+                    <a:bodyPr wrap="square"/>
+                    <a:lstStyle/>
+                    <a:p>
+                      <a:pPr algn="r"/>
+                      <a:r>
+                        <a:rPr sz="1100" b="1" i="0">
+                          <a:solidFill>
+                            <a:srgbClr val="FFFFFF"/>
+                          </a:solidFill>
+                          <a:latin typeface="Calibri"/>
+                          <a:ea typeface="Microsoft JhengHei"/>
+                        </a:rPr>
+                        <a:t>sub3</a:t>
+                      </a:r>
+                    </a:p>
+                  </a:txBody>
+                  <a:tcPr marL="73152" marR="73152" marT="27432" marB="27432" anchor="ctr">
+                    <a:solidFill>
+                      <a:srgbClr val="2B2D42"/>
+                    </a:solidFill>
+                  </a:tcPr>
+                </a:tc>
+                <a:tc>
+                  <a:txBody>
+                    <a:bodyPr wrap="square"/>
+                    <a:lstStyle/>
+                    <a:p>
+                      <a:pPr algn="r"/>
+                      <a:r>
+                        <a:rPr sz="1100" b="1" i="0">
+                          <a:solidFill>
+                            <a:srgbClr val="FFFFFF"/>
+                          </a:solidFill>
+                          <a:latin typeface="Calibri"/>
+                          <a:ea typeface="Microsoft JhengHei"/>
+                        </a:rPr>
+                        <a:t>eth</a:t>
+                      </a:r>
+                    </a:p>
+                  </a:txBody>
+                  <a:tcPr marL="73152" marR="73152" marT="27432" marB="27432" anchor="ctr">
+                    <a:solidFill>
+                      <a:srgbClr val="2B2D42"/>
+                    </a:solidFill>
+                  </a:tcPr>
+                </a:tc>
+              </a:tr>
+              <a:tr h="347472">
+                <a:tc>
+                  <a:txBody>
+                    <a:bodyPr wrap="square"/>
+                    <a:lstStyle/>
+                    <a:p>
+                      <a:pPr algn="l"/>
+                      <a:r>
+                        <a:rPr sz="1100" b="0" i="0">
+                          <a:solidFill>
+                            <a:srgbClr val="1C1C1E"/>
+                          </a:solidFill>
+                          <a:latin typeface="Calibri"/>
+                          <a:ea typeface="Microsoft JhengHei"/>
+                        </a:rPr>
+                        <a:t>真實漂移幅度保留</a:t>
+                      </a:r>
+                    </a:p>
+                  </a:txBody>
+                  <a:tcPr marL="73152" marR="73152" marT="27432" marB="27432" anchor="ctr">
+                    <a:solidFill>
+                      <a:srgbClr val="FFFFFF"/>
+                    </a:solidFill>
+                  </a:tcPr>
+                </a:tc>
+                <a:tc>
+                  <a:txBody>
+                    <a:bodyPr wrap="square"/>
+                    <a:lstStyle/>
+                    <a:p>
+                      <a:pPr algn="r"/>
+                      <a:r>
+                        <a:rPr sz="1100" b="0" i="0">
+                          <a:solidFill>
+                            <a:srgbClr val="1C1C1E"/>
+                          </a:solidFill>
+                          <a:latin typeface="Calibri"/>
+                          <a:ea typeface="Microsoft JhengHei"/>
+                        </a:rPr>
+                        <a:t>0.84</a:t>
+                      </a:r>
+                    </a:p>
+                  </a:txBody>
+                  <a:tcPr marL="73152" marR="73152" marT="27432" marB="27432" anchor="ctr">
+                    <a:solidFill>
+                      <a:srgbClr val="FFFFFF"/>
+                    </a:solidFill>
+                  </a:tcPr>
+                </a:tc>
+                <a:tc>
+                  <a:txBody>
+                    <a:bodyPr wrap="square"/>
+                    <a:lstStyle/>
+                    <a:p>
+                      <a:pPr algn="r"/>
+                      <a:r>
+                        <a:rPr sz="1100" b="0" i="0">
+                          <a:solidFill>
+                            <a:srgbClr val="1C1C1E"/>
+                          </a:solidFill>
+                          <a:latin typeface="Calibri"/>
+                          <a:ea typeface="Microsoft JhengHei"/>
+                        </a:rPr>
+                        <a:t>0.52</a:t>
+                      </a:r>
+                    </a:p>
+                  </a:txBody>
+                  <a:tcPr marL="73152" marR="73152" marT="27432" marB="27432" anchor="ctr">
+                    <a:solidFill>
+                      <a:srgbClr val="FFFFFF"/>
+                    </a:solidFill>
+                  </a:tcPr>
+                </a:tc>
+                <a:tc>
+                  <a:txBody>
+                    <a:bodyPr wrap="square"/>
+                    <a:lstStyle/>
+                    <a:p>
+                      <a:pPr algn="r"/>
+                      <a:r>
+                        <a:rPr sz="1100" b="0" i="0">
+                          <a:solidFill>
+                            <a:srgbClr val="1C1C1E"/>
+                          </a:solidFill>
+                          <a:latin typeface="Calibri"/>
+                          <a:ea typeface="Microsoft JhengHei"/>
+                        </a:rPr>
+                        <a:t>0.69</a:t>
+                      </a:r>
+                    </a:p>
+                  </a:txBody>
+                  <a:tcPr marL="73152" marR="73152" marT="27432" marB="27432" anchor="ctr">
+                    <a:solidFill>
+                      <a:srgbClr val="FFFFFF"/>
+                    </a:solidFill>
+                  </a:tcPr>
+                </a:tc>
+              </a:tr>
+              <a:tr h="347472">
+                <a:tc>
+                  <a:txBody>
+                    <a:bodyPr wrap="square"/>
+                    <a:lstStyle/>
+                    <a:p>
+                      <a:pPr algn="l"/>
+                      <a:r>
+                        <a:rPr sz="1100" b="0" i="0">
+                          <a:solidFill>
+                            <a:srgbClr val="1C1C1E"/>
+                          </a:solidFill>
+                          <a:latin typeface="Calibri"/>
+                          <a:ea typeface="Microsoft JhengHei"/>
+                        </a:rPr>
+                        <a:t>類內半徑保留</a:t>
+                      </a:r>
+                    </a:p>
+                  </a:txBody>
+                  <a:tcPr marL="73152" marR="73152" marT="27432" marB="27432" anchor="ctr">
+                    <a:solidFill>
+                      <a:srgbClr val="FFFFFF"/>
+                    </a:solidFill>
+                  </a:tcPr>
+                </a:tc>
+                <a:tc>
+                  <a:txBody>
+                    <a:bodyPr wrap="square"/>
+                    <a:lstStyle/>
+                    <a:p>
+                      <a:pPr algn="r"/>
+                      <a:r>
+                        <a:rPr sz="1100" b="0" i="0">
+                          <a:solidFill>
+                            <a:srgbClr val="1C1C1E"/>
+                          </a:solidFill>
+                          <a:latin typeface="Calibri"/>
+                          <a:ea typeface="Microsoft JhengHei"/>
+                        </a:rPr>
+                        <a:t>0.58</a:t>
+                      </a:r>
+                    </a:p>
+                  </a:txBody>
+                  <a:tcPr marL="73152" marR="73152" marT="27432" marB="27432" anchor="ctr">
+                    <a:solidFill>
+                      <a:srgbClr val="FFFFFF"/>
+                    </a:solidFill>
+                  </a:tcPr>
+                </a:tc>
+                <a:tc>
+                  <a:txBody>
+                    <a:bodyPr wrap="square"/>
+                    <a:lstStyle/>
+                    <a:p>
+                      <a:pPr algn="r"/>
+                      <a:r>
+                        <a:rPr sz="1100" b="0" i="0">
+                          <a:solidFill>
+                            <a:srgbClr val="1C1C1E"/>
+                          </a:solidFill>
+                          <a:latin typeface="Calibri"/>
+                          <a:ea typeface="Microsoft JhengHei"/>
+                        </a:rPr>
+                        <a:t>0.50</a:t>
+                      </a:r>
+                    </a:p>
+                  </a:txBody>
+                  <a:tcPr marL="73152" marR="73152" marT="27432" marB="27432" anchor="ctr">
+                    <a:solidFill>
+                      <a:srgbClr val="FFFFFF"/>
+                    </a:solidFill>
+                  </a:tcPr>
+                </a:tc>
+                <a:tc>
+                  <a:txBody>
+                    <a:bodyPr wrap="square"/>
+                    <a:lstStyle/>
+                    <a:p>
+                      <a:pPr algn="r"/>
+                      <a:r>
+                        <a:rPr sz="1100" b="0" i="0">
+                          <a:solidFill>
+                            <a:srgbClr val="1C1C1E"/>
+                          </a:solidFill>
+                          <a:latin typeface="Calibri"/>
+                          <a:ea typeface="Microsoft JhengHei"/>
+                        </a:rPr>
+                        <a:t>0.74</a:t>
+                      </a:r>
+                    </a:p>
+                  </a:txBody>
+                  <a:tcPr marL="73152" marR="73152" marT="27432" marB="27432" anchor="ctr">
+                    <a:solidFill>
+                      <a:srgbClr val="FFFFFF"/>
+                    </a:solidFill>
+                  </a:tcPr>
+                </a:tc>
+              </a:tr>
+              <a:tr h="347472">
+                <a:tc>
+                  <a:txBody>
+                    <a:bodyPr wrap="square"/>
+                    <a:lstStyle/>
+                    <a:p>
+                      <a:pPr algn="l"/>
+                      <a:r>
+                        <a:rPr sz="1100" b="0" i="0">
+                          <a:solidFill>
+                            <a:srgbClr val="1C1C1E"/>
+                          </a:solidFill>
+                          <a:latin typeface="Calibri"/>
+                          <a:ea typeface="Microsoft JhengHei"/>
+                        </a:rPr>
+                        <a:t>Acetaldehyde 落在 Ethanol 上</a:t>
+                      </a:r>
+                    </a:p>
+                  </a:txBody>
+                  <a:tcPr marL="73152" marR="73152" marT="27432" marB="27432" anchor="ctr">
+                    <a:solidFill>
+                      <a:srgbClr val="FFFFFF"/>
+                    </a:solidFill>
+                  </a:tcPr>
+                </a:tc>
+                <a:tc>
+                  <a:txBody>
+                    <a:bodyPr wrap="square"/>
+                    <a:lstStyle/>
+                    <a:p>
+                      <a:pPr algn="r"/>
+                      <a:r>
+                        <a:rPr sz="1100" b="0" i="0">
+                          <a:solidFill>
+                            <a:srgbClr val="1C1C1E"/>
+                          </a:solidFill>
+                          <a:latin typeface="Calibri"/>
+                          <a:ea typeface="Microsoft JhengHei"/>
+                        </a:rPr>
+                        <a:t>7/9</a:t>
+                      </a:r>
+                    </a:p>
+                  </a:txBody>
+                  <a:tcPr marL="73152" marR="73152" marT="27432" marB="27432" anchor="ctr">
+                    <a:solidFill>
+                      <a:srgbClr val="FFFFFF"/>
+                    </a:solidFill>
+                  </a:tcPr>
+                </a:tc>
+                <a:tc>
+                  <a:txBody>
+                    <a:bodyPr wrap="square"/>
+                    <a:lstStyle/>
+                    <a:p>
+                      <a:pPr algn="r"/>
+                      <a:r>
+                        <a:rPr sz="1100" b="0" i="0">
+                          <a:solidFill>
+                            <a:srgbClr val="1C1C1E"/>
+                          </a:solidFill>
+                          <a:latin typeface="Calibri"/>
+                          <a:ea typeface="Microsoft JhengHei"/>
+                        </a:rPr>
+                        <a:t>8/9</a:t>
+                      </a:r>
+                    </a:p>
+                  </a:txBody>
+                  <a:tcPr marL="73152" marR="73152" marT="27432" marB="27432" anchor="ctr">
+                    <a:solidFill>
+                      <a:srgbClr val="FFFFFF"/>
+                    </a:solidFill>
+                  </a:tcPr>
+                </a:tc>
+                <a:tc>
+                  <a:txBody>
+                    <a:bodyPr wrap="square"/>
+                    <a:lstStyle/>
+                    <a:p>
+                      <a:pPr algn="r"/>
+                      <a:r>
+                        <a:rPr sz="1100" b="0" i="0">
+                          <a:solidFill>
+                            <a:srgbClr val="1C1C1E"/>
+                          </a:solidFill>
+                          <a:latin typeface="Calibri"/>
+                          <a:ea typeface="Microsoft JhengHei"/>
+                        </a:rPr>
+                        <a:t>8/9</a:t>
+                      </a:r>
+                    </a:p>
+                  </a:txBody>
+                  <a:tcPr marL="73152" marR="73152" marT="27432" marB="27432" anchor="ctr">
+                    <a:solidFill>
+                      <a:srgbClr val="FFFFFF"/>
+                    </a:solidFill>
+                  </a:tcPr>
+                </a:tc>
+              </a:tr>
+            </a:tbl>
+          </a:graphicData>
+        </a:graphic>
+      </p:graphicFrame>
+      <p:pic>
+        <p:nvPicPr>
+          <p:cNvPr id="5" name="Picture 4" descr="batch1_drift_axis.png"/>
+          <p:cNvPicPr>
+            <a:picLocks noChangeAspect="1"/>
+          </p:cNvPicPr>
+          <p:nvPr/>
+        </p:nvPicPr>
+        <p:blipFill>
+          <a:blip r:embed="rId2"/>
+          <a:stretch>
+            <a:fillRect/>
+          </a:stretch>
+        </p:blipFill>
+        <p:spPr>
+          <a:xfrm>
+            <a:off x="548640" y="3611880"/>
+            <a:ext cx="6766560" cy="2337210"/>
+          </a:xfrm>
+          <a:prstGeom prst="rect">
+            <a:avLst/>
+          </a:prstGeom>
+        </p:spPr>
+      </p:pic>
+      <p:sp>
+        <p:nvSpPr>
+          <p:cNvPr id="6" name="TextBox 5"/>
+          <p:cNvSpPr txBox="1"/>
+          <p:nvPr/>
+        </p:nvSpPr>
+        <p:spPr>
+          <a:xfrm>
+            <a:off x="548640" y="5989320"/>
+            <a:ext cx="6766560" cy="274320"/>
+          </a:xfrm>
+          <a:prstGeom prst="rect">
+            <a:avLst/>
+          </a:prstGeom>
+          <a:noFill/>
+        </p:spPr>
+        <p:txBody>
+          <a:bodyPr wrap="square" lIns="0" rIns="0" tIns="0" bIns="0" anchor="t">
+            <a:spAutoFit/>
+          </a:bodyPr>
+          <a:lstStyle/>
+          <a:p>
+            <a:pPr algn="l"/>
+            <a:r>
+              <a:rPr sz="1050" b="0" i="1">
+                <a:solidFill>
+                  <a:srgbClr val="66666E"/>
+                </a:solidFill>
+                <a:latin typeface="Calibri"/>
+                <a:ea typeface="Microsoft JhengHei"/>
+              </a:rPr>
+              <a:t>Batch 1 自己的 PCA 平面：氣體沿 PC1 分開，兩次採集沿 PC2 錯開；拿掉那條軸後 Batch 1 還分得開（CV 0.9709 對 0.9680）</a:t>
+            </a:r>
+          </a:p>
+        </p:txBody>
+      </p:sp>
+      <p:sp>
+        <p:nvSpPr>
+          <p:cNvPr id="7" name="TextBox 6"/>
+          <p:cNvSpPr txBox="1"/>
+          <p:nvPr/>
+        </p:nvSpPr>
+        <p:spPr>
+          <a:xfrm>
+            <a:off x="7589520" y="3108960"/>
+            <a:ext cx="4069080" cy="3566160"/>
+          </a:xfrm>
+          <a:prstGeom prst="rect">
+            <a:avLst/>
+          </a:prstGeom>
+          <a:noFill/>
+        </p:spPr>
+        <p:txBody>
+          <a:bodyPr wrap="square" lIns="0" rIns="0" tIns="0" bIns="0" anchor="t">
+            <a:spAutoFit/>
+          </a:bodyPr>
+          <a:lstStyle/>
+          <a:p>
+            <a:pPr algn="l">
+              <a:spcAft>
+                <a:spcPts val="500"/>
+              </a:spcAft>
+            </a:pPr>
+            <a:r>
+              <a:rPr sz="1150" b="1" i="0">
+                <a:solidFill>
+                  <a:srgbClr val="EB6834"/>
+                </a:solidFill>
+                <a:latin typeface="Calibri"/>
+                <a:ea typeface="Microsoft JhengHei"/>
+              </a:rPr>
+              <a:t>▍ </a:t>
+            </a:r>
+            <a:r>
+              <a:rPr sz="1150" b="1" i="0">
+                <a:solidFill>
+                  <a:srgbClr val="1C1C1E"/>
+                </a:solidFill>
+                <a:latin typeface="Calibri"/>
+                <a:ea typeface="Microsoft JhengHei"/>
+              </a:rPr>
+              <a:t>Batch 1 估得到的軸只裝 29% 的三年漂移能量，卻裝 42% 的類內散佈：它是方向估計，不是漂移本身</a:t>
+            </a:r>
+          </a:p>
+          <a:p>
+            <a:pPr>
+              <a:spcAft>
+                <a:spcPts val="500"/>
+              </a:spcAft>
+            </a:pPr>
+            <a:r>
+              <a:rPr sz="1150" b="0" i="0">
+                <a:solidFill>
+                  <a:srgbClr val="EB6834"/>
+                </a:solidFill>
+                <a:latin typeface="Calibri"/>
+                <a:ea typeface="Microsoft JhengHei"/>
+              </a:rPr>
+              <a:t>•  </a:t>
+            </a:r>
+            <a:r>
+              <a:rPr sz="1150" b="0" i="0">
+                <a:solidFill>
+                  <a:srgbClr val="1C1C1E"/>
+                </a:solidFill>
+                <a:latin typeface="Calibri"/>
+                <a:ea typeface="Microsoft JhengHei"/>
+              </a:rPr>
+              <a:t>要拿掉夠多漂移就得拿三維，而那三維裝 76% 的類間變異。漂移與類別資訊在同一個低維子空間裡糾在一起</a:t>
+            </a:r>
+          </a:p>
+          <a:p>
+            <a:pPr>
+              <a:spcAft>
+                <a:spcPts val="500"/>
+              </a:spcAft>
+            </a:pPr>
+            <a:r>
+              <a:rPr sz="1150" b="0" i="0">
+                <a:solidFill>
+                  <a:srgbClr val="EB6834"/>
+                </a:solidFill>
+                <a:latin typeface="Calibri"/>
+                <a:ea typeface="Microsoft JhengHei"/>
+              </a:rPr>
+              <a:t>•  </a:t>
+            </a:r>
+            <a:r>
+              <a:rPr sz="1150" b="0" i="0">
+                <a:solidFill>
+                  <a:srgbClr val="1C1C1E"/>
+                </a:solidFill>
+                <a:latin typeface="Calibri"/>
+                <a:ea typeface="Microsoft JhengHei"/>
+              </a:rPr>
+              <a:t>逐類別形狀與擴充一模一樣：Acetone +0.24、Ethylene −0.28。加樣本與刪座標撞到同一個天花板，天花板是資料的</a:t>
+            </a:r>
+          </a:p>
+          <a:p>
+            <a:pPr>
+              <a:spcAft>
+                <a:spcPts val="500"/>
+              </a:spcAft>
+            </a:pPr>
+            <a:r>
+              <a:rPr sz="1150" b="1" i="0">
+                <a:solidFill>
+                  <a:srgbClr val="EB6834"/>
+                </a:solidFill>
+                <a:latin typeface="Calibri"/>
+                <a:ea typeface="Microsoft JhengHei"/>
+              </a:rPr>
+              <a:t>▍ </a:t>
+            </a:r>
+            <a:r>
+              <a:rPr sz="1150" b="1" i="0">
+                <a:solidFill>
+                  <a:srgbClr val="1C1C1E"/>
+                </a:solidFill>
+                <a:latin typeface="Calibri"/>
+                <a:ea typeface="Microsoft JhengHei"/>
+              </a:rPr>
+              <a:t>兩個事前否證條件都觸發；source-only 定案仍是 0.5556</a:t>
+            </a:r>
+          </a:p>
+        </p:txBody>
+      </p:sp>
+    </p:spTree>
+  </p:cSld>
+  <p:clrMapOvr>
+    <a:masterClrMapping/>
+  </p:clrMapOvr>
+</p:sld>
+</file>
+
+<file path=ppt/slides/slide15.xml><?xml version="1.0" encoding="utf-8"?>
+<p:sld xmlns:a="http://schemas.openxmlformats.org/drawingml/2006/main" xmlns:p="http://schemas.openxmlformats.org/presentationml/2006/main" xmlns:r="http://schemas.openxmlformats.org/officeDocument/2006/relationships">
+  <p:cSld>
+    <p:spTree>
+      <p:nvGrpSpPr>
+        <p:cNvPr id="1" name=""/>
+        <p:cNvGrpSpPr/>
+        <p:nvPr/>
+      </p:nvGrpSpPr>
+      <p:grpSpPr/>
+      <p:sp>
+        <p:nvSpPr>
+          <p:cNvPr id="2" name="TextBox 1"/>
+          <p:cNvSpPr txBox="1"/>
+          <p:nvPr/>
+        </p:nvSpPr>
+        <p:spPr>
+          <a:xfrm>
+            <a:off x="548640" y="457200"/>
+            <a:ext cx="11094415" cy="822960"/>
+          </a:xfrm>
+          <a:prstGeom prst="rect">
+            <a:avLst/>
+          </a:prstGeom>
+          <a:noFill/>
+        </p:spPr>
+        <p:txBody>
+          <a:bodyPr wrap="square" lIns="0" rIns="0" tIns="0" bIns="0" anchor="t">
+            <a:spAutoFit/>
+          </a:bodyPr>
+          <a:lstStyle/>
+          <a:p>
+            <a:pPr algn="l"/>
+            <a:r>
+              <a:rPr sz="3000" b="1" i="0">
+                <a:solidFill>
+                  <a:srgbClr val="2B2D42"/>
+                </a:solidFill>
+                <a:latin typeface="Cambria"/>
+                <a:ea typeface="Microsoft JhengHei"/>
+              </a:rPr>
+              <a:t>總結：機制都重現了，增益沒有</a:t>
+            </a:r>
+          </a:p>
+          <a:p>
+            <a:pPr>
+              <a:spcBef>
+                <a:spcPts val="400"/>
+              </a:spcBef>
+            </a:pPr>
+            <a:r>
+              <a:rPr sz="1400" b="0" i="0">
+                <a:solidFill>
+                  <a:srgbClr val="66666E"/>
+                </a:solidFill>
+                <a:latin typeface="Calibri"/>
+                <a:ea typeface="Microsoft JhengHei"/>
+              </a:rPr>
+              <a:t>兩個分支、兩個 backbone，兩個元件在 source-only 下都約零</a:t>
+            </a:r>
+          </a:p>
+        </p:txBody>
+      </p:sp>
+      <p:graphicFrame>
+        <p:nvGraphicFramePr>
+          <p:cNvPr id="3" name="Table 2"/>
+          <p:cNvGraphicFramePr>
+            <a:graphicFrameLocks noGrp="1"/>
+          </p:cNvGraphicFramePr>
+          <p:nvPr/>
+        </p:nvGraphicFramePr>
+        <p:xfrm>
+          <a:off x="548640" y="1600200"/>
+          <a:ext cx="11094413" cy="2560320"/>
         </p:xfrm>
         <a:graphic>
           <a:graphicData uri="http://schemas.openxmlformats.org/drawingml/2006/table">
@@ -6987,11 +8431,11 @@
               </a:tblPr>
               <a:tblGrid>
                 <a:gridCol w="3993989"/>
-                <a:gridCol w="1775106"/>
-                <a:gridCol w="2884547"/>
+                <a:gridCol w="1996994"/>
+                <a:gridCol w="2662659"/>
                 <a:gridCol w="2440771"/>
               </a:tblGrid>
-              <a:tr h="384048">
+              <a:tr h="365760">
                 <a:tc>
                   <a:txBody>
                     <a:bodyPr wrap="square"/>
@@ -6999,7 +8443,7 @@
                     <a:p>
                       <a:pPr algn="l"/>
                       <a:r>
-                        <a:rPr sz="1300" b="1" i="0">
+                        <a:rPr sz="1250" b="1" i="0">
                           <a:solidFill>
                             <a:srgbClr val="FFFFFF"/>
                           </a:solidFill>
@@ -7023,7 +8467,7 @@
                     <a:p>
                       <a:pPr algn="r"/>
                       <a:r>
-                        <a:rPr sz="1300" b="1" i="0">
+                        <a:rPr sz="1250" b="1" i="0">
                           <a:solidFill>
                             <a:srgbClr val="FFFFFF"/>
                           </a:solidFill>
@@ -7047,7 +8491,7 @@
                     <a:p>
                       <a:pPr algn="r"/>
                       <a:r>
-                        <a:rPr sz="1300" b="1" i="0">
+                        <a:rPr sz="1250" b="1" i="0">
                           <a:solidFill>
                             <a:srgbClr val="FFFFFF"/>
                           </a:solidFill>
@@ -7071,7 +8515,7 @@
                     <a:p>
                       <a:pPr algn="r"/>
                       <a:r>
-                        <a:rPr sz="1300" b="1" i="0">
+                        <a:rPr sz="1250" b="1" i="0">
                           <a:solidFill>
                             <a:srgbClr val="FFFFFF"/>
                           </a:solidFill>
@@ -7089,7 +8533,7 @@
                   </a:tcPr>
                 </a:tc>
               </a:tr>
-              <a:tr h="384048">
+              <a:tr h="365760">
                 <a:tc>
                   <a:txBody>
                     <a:bodyPr wrap="square"/>
@@ -7097,7 +8541,7 @@
                     <a:p>
                       <a:pPr algn="l"/>
                       <a:r>
-                        <a:rPr sz="1300" b="0" i="0">
+                        <a:rPr sz="1250" b="0" i="0">
                           <a:solidFill>
                             <a:srgbClr val="1C1C1E"/>
                           </a:solidFill>
@@ -7121,7 +8565,7 @@
                     <a:p>
                       <a:pPr algn="r"/>
                       <a:r>
-                        <a:rPr sz="1300" b="0" i="0">
+                        <a:rPr sz="1250" b="0" i="0">
                           <a:solidFill>
                             <a:srgbClr val="1C1C1E"/>
                           </a:solidFill>
@@ -7145,7 +8589,7 @@
                     <a:p>
                       <a:pPr algn="r"/>
                       <a:r>
-                        <a:rPr sz="1300" b="0" i="0">
+                        <a:rPr sz="1250" b="0" i="0">
                           <a:solidFill>
                             <a:srgbClr val="1C1C1E"/>
                           </a:solidFill>
@@ -7169,7 +8613,7 @@
                     <a:p>
                       <a:pPr algn="r"/>
                       <a:r>
-                        <a:rPr sz="1300" b="0" i="0">
+                        <a:rPr sz="1250" b="0" i="0">
                           <a:solidFill>
                             <a:srgbClr val="1C1C1E"/>
                           </a:solidFill>
@@ -7187,7 +8631,7 @@
                   </a:tcPr>
                 </a:tc>
               </a:tr>
-              <a:tr h="384048">
+              <a:tr h="365760">
                 <a:tc>
                   <a:txBody>
                     <a:bodyPr wrap="square"/>
@@ -7195,7 +8639,7 @@
                     <a:p>
                       <a:pPr algn="l"/>
                       <a:r>
-                        <a:rPr sz="1300" b="0" i="0">
+                        <a:rPr sz="1250" b="0" i="0">
                           <a:solidFill>
                             <a:srgbClr val="1C1C1E"/>
                           </a:solidFill>
@@ -7219,7 +8663,7 @@
                     <a:p>
                       <a:pPr algn="r"/>
                       <a:r>
-                        <a:rPr sz="1300" b="0" i="0">
+                        <a:rPr sz="1250" b="0" i="0">
                           <a:solidFill>
                             <a:srgbClr val="1C1C1E"/>
                           </a:solidFill>
@@ -7243,7 +8687,7 @@
                     <a:p>
                       <a:pPr algn="r"/>
                       <a:r>
-                        <a:rPr sz="1300" b="0" i="0">
+                        <a:rPr sz="1250" b="0" i="0">
                           <a:solidFill>
                             <a:srgbClr val="1C1C1E"/>
                           </a:solidFill>
@@ -7267,7 +8711,7 @@
                     <a:p>
                       <a:pPr algn="r"/>
                       <a:r>
-                        <a:rPr sz="1300" b="0" i="0">
+                        <a:rPr sz="1250" b="0" i="0">
                           <a:solidFill>
                             <a:srgbClr val="1C1C1E"/>
                           </a:solidFill>
@@ -7285,7 +8729,7 @@
                   </a:tcPr>
                 </a:tc>
               </a:tr>
-              <a:tr h="384048">
+              <a:tr h="365760">
                 <a:tc>
                   <a:txBody>
                     <a:bodyPr wrap="square"/>
@@ -7293,7 +8737,7 @@
                     <a:p>
                       <a:pPr algn="l"/>
                       <a:r>
-                        <a:rPr sz="1300" b="1" i="0">
+                        <a:rPr sz="1250" b="1" i="0">
                           <a:solidFill>
                             <a:srgbClr val="1C1C1E"/>
                           </a:solidFill>
@@ -7317,7 +8761,7 @@
                     <a:p>
                       <a:pPr algn="r"/>
                       <a:r>
-                        <a:rPr sz="1300" b="1" i="0">
+                        <a:rPr sz="1250" b="1" i="0">
                           <a:solidFill>
                             <a:srgbClr val="1C1C1E"/>
                           </a:solidFill>
@@ -7341,7 +8785,7 @@
                     <a:p>
                       <a:pPr algn="r"/>
                       <a:r>
-                        <a:rPr sz="1300" b="1" i="0">
+                        <a:rPr sz="1250" b="1" i="0">
                           <a:solidFill>
                             <a:srgbClr val="1C1C1E"/>
                           </a:solidFill>
@@ -7365,7 +8809,7 @@
                     <a:p>
                       <a:pPr algn="r"/>
                       <a:r>
-                        <a:rPr sz="1300" b="1" i="0">
+                        <a:rPr sz="1250" b="1" i="0">
                           <a:solidFill>
                             <a:srgbClr val="1C1C1E"/>
                           </a:solidFill>
@@ -7383,7 +8827,7 @@
                   </a:tcPr>
                 </a:tc>
               </a:tr>
-              <a:tr h="384048">
+              <a:tr h="365760">
                 <a:tc>
                   <a:txBody>
                     <a:bodyPr wrap="square"/>
@@ -7391,7 +8835,7 @@
                     <a:p>
                       <a:pPr algn="l"/>
                       <a:r>
-                        <a:rPr sz="1300" b="1" i="0">
+                        <a:rPr sz="1250" b="1" i="0">
                           <a:solidFill>
                             <a:srgbClr val="1C1C1E"/>
                           </a:solidFill>
@@ -7415,7 +8859,7 @@
                     <a:p>
                       <a:pPr algn="r"/>
                       <a:r>
-                        <a:rPr sz="1300" b="1" i="0">
+                        <a:rPr sz="1250" b="1" i="0">
                           <a:solidFill>
                             <a:srgbClr val="1C1C1E"/>
                           </a:solidFill>
@@ -7439,7 +8883,7 @@
                     <a:p>
                       <a:pPr algn="r"/>
                       <a:r>
-                        <a:rPr sz="1300" b="1" i="0">
+                        <a:rPr sz="1250" b="1" i="0">
                           <a:solidFill>
                             <a:srgbClr val="1C1C1E"/>
                           </a:solidFill>
@@ -7463,7 +8907,7 @@
                     <a:p>
                       <a:pPr algn="r"/>
                       <a:r>
-                        <a:rPr sz="1300" b="1" i="0">
+                        <a:rPr sz="1250" b="1" i="0">
                           <a:solidFill>
                             <a:srgbClr val="1C1C1E"/>
                           </a:solidFill>
@@ -7481,7 +8925,7 @@
                   </a:tcPr>
                 </a:tc>
               </a:tr>
-              <a:tr h="384048">
+              <a:tr h="365760">
                 <a:tc>
                   <a:txBody>
                     <a:bodyPr wrap="square"/>
@@ -7489,7 +8933,7 @@
                     <a:p>
                       <a:pPr algn="l"/>
                       <a:r>
-                        <a:rPr sz="1300" b="0" i="0">
+                        <a:rPr sz="1250" b="0" i="0">
                           <a:solidFill>
                             <a:srgbClr val="1C1C1E"/>
                           </a:solidFill>
@@ -7513,7 +8957,7 @@
                     <a:p>
                       <a:pPr algn="r"/>
                       <a:r>
-                        <a:rPr sz="1300" b="0" i="0">
+                        <a:rPr sz="1250" b="0" i="0">
                           <a:solidFill>
                             <a:srgbClr val="1C1C1E"/>
                           </a:solidFill>
@@ -7537,7 +8981,7 @@
                     <a:p>
                       <a:pPr algn="r"/>
                       <a:r>
-                        <a:rPr sz="1300" b="0" i="0">
+                        <a:rPr sz="1250" b="0" i="0">
                           <a:solidFill>
                             <a:srgbClr val="1C1C1E"/>
                           </a:solidFill>
@@ -7561,7 +9005,7 @@
                     <a:p>
                       <a:pPr algn="r"/>
                       <a:r>
-                        <a:rPr sz="1300" b="0" i="0">
+                        <a:rPr sz="1250" b="0" i="0">
                           <a:solidFill>
                             <a:srgbClr val="1C1C1E"/>
                           </a:solidFill>
@@ -7569,6 +9013,104 @@
                           <a:ea typeface="Microsoft JhengHei"/>
                         </a:rPr>
                         <a:t>CDWC→CDCNN +0.053</a:t>
+                      </a:r>
+                    </a:p>
+                  </a:txBody>
+                  <a:tcPr marL="73152" marR="73152" marT="27432" marB="27432" anchor="ctr">
+                    <a:solidFill>
+                      <a:srgbClr val="FFFFFF"/>
+                    </a:solidFill>
+                  </a:tcPr>
+                </a:tc>
+              </a:tr>
+              <a:tr h="365760">
+                <a:tc>
+                  <a:txBody>
+                    <a:bodyPr wrap="square"/>
+                    <a:lstStyle/>
+                    <a:p>
+                      <a:pPr algn="l"/>
+                      <a:r>
+                        <a:rPr sz="1250" b="0" i="0">
+                          <a:solidFill>
+                            <a:srgbClr val="1C1C1E"/>
+                          </a:solidFill>
+                          <a:latin typeface="Calibri"/>
+                          <a:ea typeface="Microsoft JhengHei"/>
+                        </a:rPr>
+                        <a:t>（非論文）投影掉 Batch 1 估的漂移軸（v12）</a:t>
+                      </a:r>
+                    </a:p>
+                  </a:txBody>
+                  <a:tcPr marL="73152" marR="73152" marT="27432" marB="27432" anchor="ctr">
+                    <a:solidFill>
+                      <a:srgbClr val="FFFFFF"/>
+                    </a:solidFill>
+                  </a:tcPr>
+                </a:tc>
+                <a:tc>
+                  <a:txBody>
+                    <a:bodyPr wrap="square"/>
+                    <a:lstStyle/>
+                    <a:p>
+                      <a:pPr algn="r"/>
+                      <a:r>
+                        <a:rPr sz="1250" b="0" i="0">
+                          <a:solidFill>
+                            <a:srgbClr val="1C1C1E"/>
+                          </a:solidFill>
+                          <a:latin typeface="Calibri"/>
+                          <a:ea typeface="Microsoft JhengHei"/>
+                        </a:rPr>
+                        <a:t>+0.0128，不可分辨</a:t>
+                      </a:r>
+                    </a:p>
+                  </a:txBody>
+                  <a:tcPr marL="73152" marR="73152" marT="27432" marB="27432" anchor="ctr">
+                    <a:solidFill>
+                      <a:srgbClr val="FFFFFF"/>
+                    </a:solidFill>
+                  </a:tcPr>
+                </a:tc>
+                <a:tc>
+                  <a:txBody>
+                    <a:bodyPr wrap="square"/>
+                    <a:lstStyle/>
+                    <a:p>
+                      <a:pPr algn="r"/>
+                      <a:r>
+                        <a:rPr sz="1250" b="0" i="0">
+                          <a:solidFill>
+                            <a:srgbClr val="1C1C1E"/>
+                          </a:solidFill>
+                          <a:latin typeface="Calibri"/>
+                          <a:ea typeface="Microsoft JhengHei"/>
+                        </a:rPr>
+                        <a:t>—</a:t>
+                      </a:r>
+                    </a:p>
+                  </a:txBody>
+                  <a:tcPr marL="73152" marR="73152" marT="27432" marB="27432" anchor="ctr">
+                    <a:solidFill>
+                      <a:srgbClr val="FFFFFF"/>
+                    </a:solidFill>
+                  </a:tcPr>
+                </a:tc>
+                <a:tc>
+                  <a:txBody>
+                    <a:bodyPr wrap="square"/>
+                    <a:lstStyle/>
+                    <a:p>
+                      <a:pPr algn="r"/>
+                      <a:r>
+                        <a:rPr sz="1250" b="0" i="0">
+                          <a:solidFill>
+                            <a:srgbClr val="1C1C1E"/>
+                          </a:solidFill>
+                          <a:latin typeface="Calibri"/>
+                          <a:ea typeface="Microsoft JhengHei"/>
+                        </a:rPr>
+                        <a:t>—</a:t>
                       </a:r>
                     </a:p>
                   </a:txBody>
@@ -7591,8 +9133,8 @@
         </p:nvSpPr>
         <p:spPr>
           <a:xfrm>
-            <a:off x="548640" y="4206240"/>
-            <a:ext cx="11094415" cy="2377440"/>
+            <a:off x="548640" y="4343400"/>
+            <a:ext cx="11094415" cy="2286000"/>
           </a:xfrm>
           <a:prstGeom prst="rect">
             <a:avLst/>
@@ -7702,7 +9244,1859 @@
 </p:sld>
 </file>
 
-<file path=ppt/slides/slide15.xml><?xml version="1.0" encoding="utf-8"?>
+<file path=ppt/slides/slide16.xml><?xml version="1.0" encoding="utf-8"?>
+<p:sld xmlns:a="http://schemas.openxmlformats.org/drawingml/2006/main" xmlns:p="http://schemas.openxmlformats.org/presentationml/2006/main" xmlns:r="http://schemas.openxmlformats.org/officeDocument/2006/relationships">
+  <p:cSld>
+    <p:spTree>
+      <p:nvGrpSpPr>
+        <p:cNvPr id="1" name=""/>
+        <p:cNvGrpSpPr/>
+        <p:nvPr/>
+      </p:nvGrpSpPr>
+      <p:grpSpPr/>
+      <p:sp>
+        <p:nvSpPr>
+          <p:cNvPr id="2" name="TextBox 1"/>
+          <p:cNvSpPr txBox="1"/>
+          <p:nvPr/>
+        </p:nvSpPr>
+        <p:spPr>
+          <a:xfrm>
+            <a:off x="548640" y="457200"/>
+            <a:ext cx="11094415" cy="822960"/>
+          </a:xfrm>
+          <a:prstGeom prst="rect">
+            <a:avLst/>
+          </a:prstGeom>
+          <a:noFill/>
+        </p:spPr>
+        <p:txBody>
+          <a:bodyPr wrap="square" lIns="0" rIns="0" tIns="0" bIns="0" anchor="t">
+            <a:spAutoFit/>
+          </a:bodyPr>
+          <a:lstStyle/>
+          <a:p>
+            <a:pPr algn="l"/>
+            <a:r>
+              <a:rPr sz="3000" b="1" i="0">
+                <a:solidFill>
+                  <a:srgbClr val="2B2D42"/>
+                </a:solidFill>
+                <a:latin typeface="Cambria"/>
+                <a:ea typeface="Microsoft JhengHei"/>
+              </a:rPr>
+              <a:t>文獻對照：Batch 1 訓練、Batch 2–10 測試</a:t>
+            </a:r>
+          </a:p>
+          <a:p>
+            <a:pPr>
+              <a:spcBef>
+                <a:spcPts val="400"/>
+              </a:spcBef>
+            </a:pPr>
+            <a:r>
+              <a:rPr sz="1400" b="0" i="0">
+                <a:solidFill>
+                  <a:srgbClr val="66666E"/>
+                </a:solidFill>
+                <a:latin typeface="Calibri"/>
+                <a:ea typeface="Microsoft JhengHei"/>
+              </a:rPr>
+              <a:t>平均準確率是九個 batch 的未加權平均，與我們的 target mean 相同；差別只在各方法看到多少 target 的資訊</a:t>
+            </a:r>
+          </a:p>
+        </p:txBody>
+      </p:sp>
+      <p:graphicFrame>
+        <p:nvGraphicFramePr>
+          <p:cNvPr id="3" name="Table 2"/>
+          <p:cNvGraphicFramePr>
+            <a:graphicFrameLocks noGrp="1"/>
+          </p:cNvGraphicFramePr>
+          <p:nvPr/>
+        </p:nvGraphicFramePr>
+        <p:xfrm>
+          <a:off x="548640" y="1554480"/>
+          <a:ext cx="7680959" cy="4828032"/>
+        </p:xfrm>
+        <a:graphic>
+          <a:graphicData uri="http://schemas.openxmlformats.org/drawingml/2006/table">
+            <a:tbl>
+              <a:tblPr firstRow="0" bandRow="0">
+                <a:tableStyleId>{5C22544A-7EE6-4342-B048-85BDC9FD1C3A}</a:tableStyleId>
+              </a:tblPr>
+              <a:tblGrid>
+                <a:gridCol w="1920240"/>
+                <a:gridCol w="3149193"/>
+                <a:gridCol w="1305763"/>
+                <a:gridCol w="1305763"/>
+              </a:tblGrid>
+              <a:tr h="301752">
+                <a:tc>
+                  <a:txBody>
+                    <a:bodyPr wrap="square"/>
+                    <a:lstStyle/>
+                    <a:p>
+                      <a:pPr algn="l"/>
+                      <a:r>
+                        <a:rPr sz="1050" b="1" i="0">
+                          <a:solidFill>
+                            <a:srgbClr val="FFFFFF"/>
+                          </a:solidFill>
+                          <a:latin typeface="Calibri"/>
+                          <a:ea typeface="Microsoft JhengHei"/>
+                        </a:rPr>
+                        <a:t>用到的 target 資訊</a:t>
+                      </a:r>
+                    </a:p>
+                  </a:txBody>
+                  <a:tcPr marL="73152" marR="73152" marT="27432" marB="27432" anchor="ctr">
+                    <a:solidFill>
+                      <a:srgbClr val="2B2D42"/>
+                    </a:solidFill>
+                  </a:tcPr>
+                </a:tc>
+                <a:tc>
+                  <a:txBody>
+                    <a:bodyPr wrap="square"/>
+                    <a:lstStyle/>
+                    <a:p>
+                      <a:pPr algn="l"/>
+                      <a:r>
+                        <a:rPr sz="1050" b="1" i="0">
+                          <a:solidFill>
+                            <a:srgbClr val="FFFFFF"/>
+                          </a:solidFill>
+                          <a:latin typeface="Calibri"/>
+                          <a:ea typeface="Microsoft JhengHei"/>
+                        </a:rPr>
+                        <a:t>方法</a:t>
+                      </a:r>
+                    </a:p>
+                  </a:txBody>
+                  <a:tcPr marL="73152" marR="73152" marT="27432" marB="27432" anchor="ctr">
+                    <a:solidFill>
+                      <a:srgbClr val="2B2D42"/>
+                    </a:solidFill>
+                  </a:tcPr>
+                </a:tc>
+                <a:tc>
+                  <a:txBody>
+                    <a:bodyPr wrap="square"/>
+                    <a:lstStyle/>
+                    <a:p>
+                      <a:pPr algn="l"/>
+                      <a:r>
+                        <a:rPr sz="1050" b="1" i="0">
+                          <a:solidFill>
+                            <a:srgbClr val="FFFFFF"/>
+                          </a:solidFill>
+                          <a:latin typeface="Calibri"/>
+                          <a:ea typeface="Microsoft JhengHei"/>
+                        </a:rPr>
+                        <a:t>來源</a:t>
+                      </a:r>
+                    </a:p>
+                  </a:txBody>
+                  <a:tcPr marL="73152" marR="73152" marT="27432" marB="27432" anchor="ctr">
+                    <a:solidFill>
+                      <a:srgbClr val="2B2D42"/>
+                    </a:solidFill>
+                  </a:tcPr>
+                </a:tc>
+                <a:tc>
+                  <a:txBody>
+                    <a:bodyPr wrap="square"/>
+                    <a:lstStyle/>
+                    <a:p>
+                      <a:pPr algn="r"/>
+                      <a:r>
+                        <a:rPr sz="1050" b="1" i="0">
+                          <a:solidFill>
+                            <a:srgbClr val="FFFFFF"/>
+                          </a:solidFill>
+                          <a:latin typeface="Calibri"/>
+                          <a:ea typeface="Microsoft JhengHei"/>
+                        </a:rPr>
+                        <a:t>平均 B2–10 (%)</a:t>
+                      </a:r>
+                    </a:p>
+                  </a:txBody>
+                  <a:tcPr marL="73152" marR="73152" marT="27432" marB="27432" anchor="ctr">
+                    <a:solidFill>
+                      <a:srgbClr val="2B2D42"/>
+                    </a:solidFill>
+                  </a:tcPr>
+                </a:tc>
+              </a:tr>
+              <a:tr h="301752">
+                <a:tc>
+                  <a:txBody>
+                    <a:bodyPr wrap="square"/>
+                    <a:lstStyle/>
+                    <a:p>
+                      <a:pPr algn="l"/>
+                      <a:r>
+                        <a:rPr sz="1050" b="0" i="0">
+                          <a:solidFill>
+                            <a:srgbClr val="1C1C1E"/>
+                          </a:solidFill>
+                          <a:latin typeface="Calibri"/>
+                          <a:ea typeface="Microsoft JhengHei"/>
+                        </a:rPr>
+                        <a:t>不碰 target</a:t>
+                      </a:r>
+                    </a:p>
+                  </a:txBody>
+                  <a:tcPr marL="73152" marR="73152" marT="27432" marB="27432" anchor="ctr">
+                    <a:solidFill>
+                      <a:srgbClr val="FFFFFF"/>
+                    </a:solidFill>
+                  </a:tcPr>
+                </a:tc>
+                <a:tc>
+                  <a:txBody>
+                    <a:bodyPr wrap="square"/>
+                    <a:lstStyle/>
+                    <a:p>
+                      <a:pPr algn="l"/>
+                      <a:r>
+                        <a:rPr sz="1050" b="0" i="0">
+                          <a:solidFill>
+                            <a:srgbClr val="1C1C1E"/>
+                          </a:solidFill>
+                          <a:latin typeface="Calibri"/>
+                          <a:ea typeface="Microsoft JhengHei"/>
+                        </a:rPr>
+                        <a:t>SVM-rbf，資料集原論文的基線</a:t>
+                      </a:r>
+                    </a:p>
+                  </a:txBody>
+                  <a:tcPr marL="73152" marR="73152" marT="27432" marB="27432" anchor="ctr">
+                    <a:solidFill>
+                      <a:srgbClr val="FFFFFF"/>
+                    </a:solidFill>
+                  </a:tcPr>
+                </a:tc>
+                <a:tc>
+                  <a:txBody>
+                    <a:bodyPr wrap="square"/>
+                    <a:lstStyle/>
+                    <a:p>
+                      <a:pPr algn="l"/>
+                      <a:r>
+                        <a:rPr sz="1050" b="0" i="0">
+                          <a:solidFill>
+                            <a:srgbClr val="1C1C1E"/>
+                          </a:solidFill>
+                          <a:latin typeface="Calibri"/>
+                          <a:ea typeface="Microsoft JhengHei"/>
+                        </a:rPr>
+                        <a:t>Vergara 2012</a:t>
+                      </a:r>
+                    </a:p>
+                  </a:txBody>
+                  <a:tcPr marL="73152" marR="73152" marT="27432" marB="27432" anchor="ctr">
+                    <a:solidFill>
+                      <a:srgbClr val="FFFFFF"/>
+                    </a:solidFill>
+                  </a:tcPr>
+                </a:tc>
+                <a:tc>
+                  <a:txBody>
+                    <a:bodyPr wrap="square"/>
+                    <a:lstStyle/>
+                    <a:p>
+                      <a:pPr algn="r"/>
+                      <a:r>
+                        <a:rPr sz="1050" b="0" i="0">
+                          <a:solidFill>
+                            <a:srgbClr val="1C1C1E"/>
+                          </a:solidFill>
+                          <a:latin typeface="Calibri"/>
+                          <a:ea typeface="Microsoft JhengHei"/>
+                        </a:rPr>
+                        <a:t>38.9</a:t>
+                      </a:r>
+                    </a:p>
+                  </a:txBody>
+                  <a:tcPr marL="73152" marR="73152" marT="27432" marB="27432" anchor="ctr">
+                    <a:solidFill>
+                      <a:srgbClr val="FFFFFF"/>
+                    </a:solidFill>
+                  </a:tcPr>
+                </a:tc>
+              </a:tr>
+              <a:tr h="301752">
+                <a:tc>
+                  <a:txBody>
+                    <a:bodyPr wrap="square"/>
+                    <a:lstStyle/>
+                    <a:p>
+                      <a:pPr algn="l"/>
+                      <a:r>
+                        <a:rPr sz="1050" b="0" i="0">
+                          <a:solidFill>
+                            <a:srgbClr val="1C1C1E"/>
+                          </a:solidFill>
+                          <a:latin typeface="Calibri"/>
+                          <a:ea typeface="Microsoft JhengHei"/>
+                        </a:rPr>
+                        <a:t>不碰 target</a:t>
+                      </a:r>
+                    </a:p>
+                  </a:txBody>
+                  <a:tcPr marL="73152" marR="73152" marT="27432" marB="27432" anchor="ctr">
+                    <a:solidFill>
+                      <a:srgbClr val="FFFFFF"/>
+                    </a:solidFill>
+                  </a:tcPr>
+                </a:tc>
+                <a:tc>
+                  <a:txBody>
+                    <a:bodyPr wrap="square"/>
+                    <a:lstStyle/>
+                    <a:p>
+                      <a:pPr algn="l"/>
+                      <a:r>
+                        <a:rPr sz="1050" b="0" i="0">
+                          <a:solidFill>
+                            <a:srgbClr val="1C1C1E"/>
+                          </a:solidFill>
+                          <a:latin typeface="Calibri"/>
+                          <a:ea typeface="Microsoft JhengHei"/>
+                        </a:rPr>
+                        <a:t>FCNN，無補償（NC）</a:t>
+                      </a:r>
+                    </a:p>
+                  </a:txBody>
+                  <a:tcPr marL="73152" marR="73152" marT="27432" marB="27432" anchor="ctr">
+                    <a:solidFill>
+                      <a:srgbClr val="FFFFFF"/>
+                    </a:solidFill>
+                  </a:tcPr>
+                </a:tc>
+                <a:tc>
+                  <a:txBody>
+                    <a:bodyPr wrap="square"/>
+                    <a:lstStyle/>
+                    <a:p>
+                      <a:pPr algn="l"/>
+                      <a:r>
+                        <a:rPr sz="1050" b="0" i="0">
+                          <a:solidFill>
+                            <a:srgbClr val="1C1C1E"/>
+                          </a:solidFill>
+                          <a:latin typeface="Calibri"/>
+                          <a:ea typeface="Microsoft JhengHei"/>
+                        </a:rPr>
+                        <a:t>KD 論文 2025</a:t>
+                      </a:r>
+                    </a:p>
+                  </a:txBody>
+                  <a:tcPr marL="73152" marR="73152" marT="27432" marB="27432" anchor="ctr">
+                    <a:solidFill>
+                      <a:srgbClr val="FFFFFF"/>
+                    </a:solidFill>
+                  </a:tcPr>
+                </a:tc>
+                <a:tc>
+                  <a:txBody>
+                    <a:bodyPr wrap="square"/>
+                    <a:lstStyle/>
+                    <a:p>
+                      <a:pPr algn="r"/>
+                      <a:r>
+                        <a:rPr sz="1050" b="0" i="0">
+                          <a:solidFill>
+                            <a:srgbClr val="1C1C1E"/>
+                          </a:solidFill>
+                          <a:latin typeface="Calibri"/>
+                          <a:ea typeface="Microsoft JhengHei"/>
+                        </a:rPr>
+                        <a:t>38.7</a:t>
+                      </a:r>
+                    </a:p>
+                  </a:txBody>
+                  <a:tcPr marL="73152" marR="73152" marT="27432" marB="27432" anchor="ctr">
+                    <a:solidFill>
+                      <a:srgbClr val="FFFFFF"/>
+                    </a:solidFill>
+                  </a:tcPr>
+                </a:tc>
+              </a:tr>
+              <a:tr h="301752">
+                <a:tc>
+                  <a:txBody>
+                    <a:bodyPr wrap="square"/>
+                    <a:lstStyle/>
+                    <a:p>
+                      <a:pPr algn="l"/>
+                      <a:r>
+                        <a:rPr sz="1050" b="0" i="0">
+                          <a:solidFill>
+                            <a:srgbClr val="1C1C1E"/>
+                          </a:solidFill>
+                          <a:latin typeface="Calibri"/>
+                          <a:ea typeface="Microsoft JhengHei"/>
+                        </a:rPr>
+                        <a:t>不碰 target</a:t>
+                      </a:r>
+                    </a:p>
+                  </a:txBody>
+                  <a:tcPr marL="73152" marR="73152" marT="27432" marB="27432" anchor="ctr">
+                    <a:solidFill>
+                      <a:srgbClr val="FFFFFF"/>
+                    </a:solidFill>
+                  </a:tcPr>
+                </a:tc>
+                <a:tc>
+                  <a:txBody>
+                    <a:bodyPr wrap="square"/>
+                    <a:lstStyle/>
+                    <a:p>
+                      <a:pPr algn="l"/>
+                      <a:r>
+                        <a:rPr sz="1050" b="0" i="0">
+                          <a:solidFill>
+                            <a:srgbClr val="1C1C1E"/>
+                          </a:solidFill>
+                          <a:latin typeface="Calibri"/>
+                          <a:ea typeface="Microsoft JhengHei"/>
+                        </a:rPr>
+                        <a:t>OSC 正交訊號校正</a:t>
+                      </a:r>
+                    </a:p>
+                  </a:txBody>
+                  <a:tcPr marL="73152" marR="73152" marT="27432" marB="27432" anchor="ctr">
+                    <a:solidFill>
+                      <a:srgbClr val="FFFFFF"/>
+                    </a:solidFill>
+                  </a:tcPr>
+                </a:tc>
+                <a:tc>
+                  <a:txBody>
+                    <a:bodyPr wrap="square"/>
+                    <a:lstStyle/>
+                    <a:p>
+                      <a:pPr algn="l"/>
+                      <a:r>
+                        <a:rPr sz="1050" b="0" i="0">
+                          <a:solidFill>
+                            <a:srgbClr val="1C1C1E"/>
+                          </a:solidFill>
+                          <a:latin typeface="Calibri"/>
+                          <a:ea typeface="Microsoft JhengHei"/>
+                        </a:rPr>
+                        <a:t>Yi 2019 表</a:t>
+                      </a:r>
+                    </a:p>
+                  </a:txBody>
+                  <a:tcPr marL="73152" marR="73152" marT="27432" marB="27432" anchor="ctr">
+                    <a:solidFill>
+                      <a:srgbClr val="FFFFFF"/>
+                    </a:solidFill>
+                  </a:tcPr>
+                </a:tc>
+                <a:tc>
+                  <a:txBody>
+                    <a:bodyPr wrap="square"/>
+                    <a:lstStyle/>
+                    <a:p>
+                      <a:pPr algn="r"/>
+                      <a:r>
+                        <a:rPr sz="1050" b="0" i="0">
+                          <a:solidFill>
+                            <a:srgbClr val="1C1C1E"/>
+                          </a:solidFill>
+                          <a:latin typeface="Calibri"/>
+                          <a:ea typeface="Microsoft JhengHei"/>
+                        </a:rPr>
+                        <a:t>56.5</a:t>
+                      </a:r>
+                    </a:p>
+                  </a:txBody>
+                  <a:tcPr marL="73152" marR="73152" marT="27432" marB="27432" anchor="ctr">
+                    <a:solidFill>
+                      <a:srgbClr val="FFFFFF"/>
+                    </a:solidFill>
+                  </a:tcPr>
+                </a:tc>
+              </a:tr>
+              <a:tr h="301752">
+                <a:tc>
+                  <a:txBody>
+                    <a:bodyPr wrap="square"/>
+                    <a:lstStyle/>
+                    <a:p>
+                      <a:pPr algn="l"/>
+                      <a:r>
+                        <a:rPr sz="1050" b="1" i="0">
+                          <a:solidFill>
+                            <a:srgbClr val="1C1C1E"/>
+                          </a:solidFill>
+                          <a:latin typeface="Calibri"/>
+                          <a:ea typeface="Microsoft JhengHei"/>
+                        </a:rPr>
+                        <a:t>不碰 target</a:t>
+                      </a:r>
+                    </a:p>
+                  </a:txBody>
+                  <a:tcPr marL="73152" marR="73152" marT="27432" marB="27432" anchor="ctr">
+                    <a:solidFill>
+                      <a:srgbClr val="F3F4F6"/>
+                    </a:solidFill>
+                  </a:tcPr>
+                </a:tc>
+                <a:tc>
+                  <a:txBody>
+                    <a:bodyPr wrap="square"/>
+                    <a:lstStyle/>
+                    <a:p>
+                      <a:pPr algn="l"/>
+                      <a:r>
+                        <a:rPr sz="1050" b="1" i="0">
+                          <a:solidFill>
+                            <a:srgbClr val="1C1C1E"/>
+                          </a:solidFill>
+                          <a:latin typeface="Calibri"/>
+                          <a:ea typeface="Microsoft JhengHei"/>
+                        </a:rPr>
+                        <a:t>我們的 ResNet，R-fig-logps</a:t>
+                      </a:r>
+                    </a:p>
+                  </a:txBody>
+                  <a:tcPr marL="73152" marR="73152" marT="27432" marB="27432" anchor="ctr">
+                    <a:solidFill>
+                      <a:srgbClr val="F3F4F6"/>
+                    </a:solidFill>
+                  </a:tcPr>
+                </a:tc>
+                <a:tc>
+                  <a:txBody>
+                    <a:bodyPr wrap="square"/>
+                    <a:lstStyle/>
+                    <a:p>
+                      <a:pPr algn="l"/>
+                      <a:r>
+                        <a:rPr sz="1050" b="1" i="0">
+                          <a:solidFill>
+                            <a:srgbClr val="1C1C1E"/>
+                          </a:solidFill>
+                          <a:latin typeface="Calibri"/>
+                          <a:ea typeface="Microsoft JhengHei"/>
+                        </a:rPr>
+                        <a:t>本專案</a:t>
+                      </a:r>
+                    </a:p>
+                  </a:txBody>
+                  <a:tcPr marL="73152" marR="73152" marT="27432" marB="27432" anchor="ctr">
+                    <a:solidFill>
+                      <a:srgbClr val="F3F4F6"/>
+                    </a:solidFill>
+                  </a:tcPr>
+                </a:tc>
+                <a:tc>
+                  <a:txBody>
+                    <a:bodyPr wrap="square"/>
+                    <a:lstStyle/>
+                    <a:p>
+                      <a:pPr algn="r"/>
+                      <a:r>
+                        <a:rPr sz="1050" b="1" i="0">
+                          <a:solidFill>
+                            <a:srgbClr val="1C1C1E"/>
+                          </a:solidFill>
+                          <a:latin typeface="Calibri"/>
+                          <a:ea typeface="Microsoft JhengHei"/>
+                        </a:rPr>
+                        <a:t>55.6</a:t>
+                      </a:r>
+                    </a:p>
+                  </a:txBody>
+                  <a:tcPr marL="73152" marR="73152" marT="27432" marB="27432" anchor="ctr">
+                    <a:solidFill>
+                      <a:srgbClr val="F3F4F6"/>
+                    </a:solidFill>
+                  </a:tcPr>
+                </a:tc>
+              </a:tr>
+              <a:tr h="301752">
+                <a:tc>
+                  <a:txBody>
+                    <a:bodyPr wrap="square"/>
+                    <a:lstStyle/>
+                    <a:p>
+                      <a:pPr algn="l"/>
+                      <a:r>
+                        <a:rPr sz="1050" b="1" i="0">
+                          <a:solidFill>
+                            <a:srgbClr val="1C1C1E"/>
+                          </a:solidFill>
+                          <a:latin typeface="Calibri"/>
+                          <a:ea typeface="Microsoft JhengHei"/>
+                        </a:rPr>
+                        <a:t>不碰 target</a:t>
+                      </a:r>
+                    </a:p>
+                  </a:txBody>
+                  <a:tcPr marL="73152" marR="73152" marT="27432" marB="27432" anchor="ctr">
+                    <a:solidFill>
+                      <a:srgbClr val="F3F4F6"/>
+                    </a:solidFill>
+                  </a:tcPr>
+                </a:tc>
+                <a:tc>
+                  <a:txBody>
+                    <a:bodyPr wrap="square"/>
+                    <a:lstStyle/>
+                    <a:p>
+                      <a:pPr algn="l"/>
+                      <a:r>
+                        <a:rPr sz="1050" b="1" i="0">
+                          <a:solidFill>
+                            <a:srgbClr val="1C1C1E"/>
+                          </a:solidFill>
+                          <a:latin typeface="Calibri"/>
+                          <a:ea typeface="Microsoft JhengHei"/>
+                        </a:rPr>
+                        <a:t>我們的投影，R-proj-axis（不可分辨）</a:t>
+                      </a:r>
+                    </a:p>
+                  </a:txBody>
+                  <a:tcPr marL="73152" marR="73152" marT="27432" marB="27432" anchor="ctr">
+                    <a:solidFill>
+                      <a:srgbClr val="F3F4F6"/>
+                    </a:solidFill>
+                  </a:tcPr>
+                </a:tc>
+                <a:tc>
+                  <a:txBody>
+                    <a:bodyPr wrap="square"/>
+                    <a:lstStyle/>
+                    <a:p>
+                      <a:pPr algn="l"/>
+                      <a:r>
+                        <a:rPr sz="1050" b="1" i="0">
+                          <a:solidFill>
+                            <a:srgbClr val="1C1C1E"/>
+                          </a:solidFill>
+                          <a:latin typeface="Calibri"/>
+                          <a:ea typeface="Microsoft JhengHei"/>
+                        </a:rPr>
+                        <a:t>本專案 v12</a:t>
+                      </a:r>
+                    </a:p>
+                  </a:txBody>
+                  <a:tcPr marL="73152" marR="73152" marT="27432" marB="27432" anchor="ctr">
+                    <a:solidFill>
+                      <a:srgbClr val="F3F4F6"/>
+                    </a:solidFill>
+                  </a:tcPr>
+                </a:tc>
+                <a:tc>
+                  <a:txBody>
+                    <a:bodyPr wrap="square"/>
+                    <a:lstStyle/>
+                    <a:p>
+                      <a:pPr algn="r"/>
+                      <a:r>
+                        <a:rPr sz="1050" b="1" i="0">
+                          <a:solidFill>
+                            <a:srgbClr val="1C1C1E"/>
+                          </a:solidFill>
+                          <a:latin typeface="Calibri"/>
+                          <a:ea typeface="Microsoft JhengHei"/>
+                        </a:rPr>
+                        <a:t>56.8</a:t>
+                      </a:r>
+                    </a:p>
+                  </a:txBody>
+                  <a:tcPr marL="73152" marR="73152" marT="27432" marB="27432" anchor="ctr">
+                    <a:solidFill>
+                      <a:srgbClr val="F3F4F6"/>
+                    </a:solidFill>
+                  </a:tcPr>
+                </a:tc>
+              </a:tr>
+              <a:tr h="301752">
+                <a:tc>
+                  <a:txBody>
+                    <a:bodyPr wrap="square"/>
+                    <a:lstStyle/>
+                    <a:p>
+                      <a:pPr algn="l"/>
+                      <a:r>
+                        <a:rPr sz="1050" b="0" i="0">
+                          <a:solidFill>
+                            <a:srgbClr val="1C1C1E"/>
+                          </a:solidFill>
+                          <a:latin typeface="Calibri"/>
+                          <a:ea typeface="Microsoft JhengHei"/>
+                        </a:rPr>
+                        <a:t>不碰 target（宣稱）</a:t>
+                      </a:r>
+                    </a:p>
+                  </a:txBody>
+                  <a:tcPr marL="73152" marR="73152" marT="27432" marB="27432" anchor="ctr">
+                    <a:solidFill>
+                      <a:srgbClr val="FFFFFF"/>
+                    </a:solidFill>
+                  </a:tcPr>
+                </a:tc>
+                <a:tc>
+                  <a:txBody>
+                    <a:bodyPr wrap="square"/>
+                    <a:lstStyle/>
+                    <a:p>
+                      <a:pPr algn="l"/>
+                      <a:r>
+                        <a:rPr sz="1050" b="0" i="0">
+                          <a:solidFill>
+                            <a:srgbClr val="1C1C1E"/>
+                          </a:solidFill>
+                          <a:latin typeface="Calibri"/>
+                          <a:ea typeface="Microsoft JhengHei"/>
+                        </a:rPr>
+                        <a:t>CDCNN 論文的 ResNet / CDWC / CDCNN</a:t>
+                      </a:r>
+                    </a:p>
+                  </a:txBody>
+                  <a:tcPr marL="73152" marR="73152" marT="27432" marB="27432" anchor="ctr">
+                    <a:solidFill>
+                      <a:srgbClr val="FFFFFF"/>
+                    </a:solidFill>
+                  </a:tcPr>
+                </a:tc>
+                <a:tc>
+                  <a:txBody>
+                    <a:bodyPr wrap="square"/>
+                    <a:lstStyle/>
+                    <a:p>
+                      <a:pPr algn="l"/>
+                      <a:r>
+                        <a:rPr sz="1050" b="0" i="0">
+                          <a:solidFill>
+                            <a:srgbClr val="1C1C1E"/>
+                          </a:solidFill>
+                          <a:latin typeface="Calibri"/>
+                          <a:ea typeface="Microsoft JhengHei"/>
+                        </a:rPr>
+                        <a:t>論文 Table 3</a:t>
+                      </a:r>
+                    </a:p>
+                  </a:txBody>
+                  <a:tcPr marL="73152" marR="73152" marT="27432" marB="27432" anchor="ctr">
+                    <a:solidFill>
+                      <a:srgbClr val="FFFFFF"/>
+                    </a:solidFill>
+                  </a:tcPr>
+                </a:tc>
+                <a:tc>
+                  <a:txBody>
+                    <a:bodyPr wrap="square"/>
+                    <a:lstStyle/>
+                    <a:p>
+                      <a:pPr algn="r"/>
+                      <a:r>
+                        <a:rPr sz="1050" b="0" i="0">
+                          <a:solidFill>
+                            <a:srgbClr val="1C1C1E"/>
+                          </a:solidFill>
+                          <a:latin typeface="Calibri"/>
+                          <a:ea typeface="Microsoft JhengHei"/>
+                        </a:rPr>
+                        <a:t>63.5 / 67.1 / 72.3</a:t>
+                      </a:r>
+                    </a:p>
+                  </a:txBody>
+                  <a:tcPr marL="73152" marR="73152" marT="27432" marB="27432" anchor="ctr">
+                    <a:solidFill>
+                      <a:srgbClr val="FFFFFF"/>
+                    </a:solidFill>
+                  </a:tcPr>
+                </a:tc>
+              </a:tr>
+              <a:tr h="301752">
+                <a:tc>
+                  <a:txBody>
+                    <a:bodyPr wrap="square"/>
+                    <a:lstStyle/>
+                    <a:p>
+                      <a:pPr algn="l"/>
+                      <a:r>
+                        <a:rPr sz="1050" b="0" i="0">
+                          <a:solidFill>
+                            <a:srgbClr val="1C1C1E"/>
+                          </a:solidFill>
+                          <a:latin typeface="Calibri"/>
+                          <a:ea typeface="Microsoft JhengHei"/>
+                        </a:rPr>
+                        <a:t>看過 target 選方向</a:t>
+                      </a:r>
+                    </a:p>
+                  </a:txBody>
+                  <a:tcPr marL="73152" marR="73152" marT="27432" marB="27432" anchor="ctr">
+                    <a:solidFill>
+                      <a:srgbClr val="FFFFFF"/>
+                    </a:solidFill>
+                  </a:tcPr>
+                </a:tc>
+                <a:tc>
+                  <a:txBody>
+                    <a:bodyPr wrap="square"/>
+                    <a:lstStyle/>
+                    <a:p>
+                      <a:pPr algn="l"/>
+                      <a:r>
+                        <a:rPr sz="1050" b="0" i="0">
+                          <a:solidFill>
+                            <a:srgbClr val="1C1C1E"/>
+                          </a:solidFill>
+                          <a:latin typeface="Calibri"/>
+                          <a:ea typeface="Microsoft JhengHei"/>
+                        </a:rPr>
+                        <a:t>我們的 R-aug-t2 / R-proj-eth（上界）</a:t>
+                      </a:r>
+                    </a:p>
+                  </a:txBody>
+                  <a:tcPr marL="73152" marR="73152" marT="27432" marB="27432" anchor="ctr">
+                    <a:solidFill>
+                      <a:srgbClr val="FFFFFF"/>
+                    </a:solidFill>
+                  </a:tcPr>
+                </a:tc>
+                <a:tc>
+                  <a:txBody>
+                    <a:bodyPr wrap="square"/>
+                    <a:lstStyle/>
+                    <a:p>
+                      <a:pPr algn="l"/>
+                      <a:r>
+                        <a:rPr sz="1050" b="0" i="0">
+                          <a:solidFill>
+                            <a:srgbClr val="1C1C1E"/>
+                          </a:solidFill>
+                          <a:latin typeface="Calibri"/>
+                          <a:ea typeface="Microsoft JhengHei"/>
+                        </a:rPr>
+                        <a:t>本專案 v8.1 / v12</a:t>
+                      </a:r>
+                    </a:p>
+                  </a:txBody>
+                  <a:tcPr marL="73152" marR="73152" marT="27432" marB="27432" anchor="ctr">
+                    <a:solidFill>
+                      <a:srgbClr val="FFFFFF"/>
+                    </a:solidFill>
+                  </a:tcPr>
+                </a:tc>
+                <a:tc>
+                  <a:txBody>
+                    <a:bodyPr wrap="square"/>
+                    <a:lstStyle/>
+                    <a:p>
+                      <a:pPr algn="r"/>
+                      <a:r>
+                        <a:rPr sz="1050" b="0" i="0">
+                          <a:solidFill>
+                            <a:srgbClr val="1C1C1E"/>
+                          </a:solidFill>
+                          <a:latin typeface="Calibri"/>
+                          <a:ea typeface="Microsoft JhengHei"/>
+                        </a:rPr>
+                        <a:t>57.7 / 57.5</a:t>
+                      </a:r>
+                    </a:p>
+                  </a:txBody>
+                  <a:tcPr marL="73152" marR="73152" marT="27432" marB="27432" anchor="ctr">
+                    <a:solidFill>
+                      <a:srgbClr val="FFFFFF"/>
+                    </a:solidFill>
+                  </a:tcPr>
+                </a:tc>
+              </a:tr>
+              <a:tr h="301752">
+                <a:tc>
+                  <a:txBody>
+                    <a:bodyPr wrap="square"/>
+                    <a:lstStyle/>
+                    <a:p>
+                      <a:pPr algn="l"/>
+                      <a:r>
+                        <a:rPr sz="1050" b="0" i="0">
+                          <a:solidFill>
+                            <a:srgbClr val="1C1C1E"/>
+                          </a:solidFill>
+                          <a:latin typeface="Calibri"/>
+                          <a:ea typeface="Microsoft JhengHei"/>
+                        </a:rPr>
+                        <a:t>無標籤 target 樣本</a:t>
+                      </a:r>
+                    </a:p>
+                  </a:txBody>
+                  <a:tcPr marL="73152" marR="73152" marT="27432" marB="27432" anchor="ctr">
+                    <a:solidFill>
+                      <a:srgbClr val="FFFFFF"/>
+                    </a:solidFill>
+                  </a:tcPr>
+                </a:tc>
+                <a:tc>
+                  <a:txBody>
+                    <a:bodyPr wrap="square"/>
+                    <a:lstStyle/>
+                    <a:p>
+                      <a:pPr algn="l"/>
+                      <a:r>
+                        <a:rPr sz="1050" b="0" i="0">
+                          <a:solidFill>
+                            <a:srgbClr val="1C1C1E"/>
+                          </a:solidFill>
+                          <a:latin typeface="Calibri"/>
+                          <a:ea typeface="Microsoft JhengHei"/>
+                        </a:rPr>
+                        <a:t>SVM-gfk / SVM-comgfk 測地流核</a:t>
+                      </a:r>
+                    </a:p>
+                  </a:txBody>
+                  <a:tcPr marL="73152" marR="73152" marT="27432" marB="27432" anchor="ctr">
+                    <a:solidFill>
+                      <a:srgbClr val="FFFFFF"/>
+                    </a:solidFill>
+                  </a:tcPr>
+                </a:tc>
+                <a:tc>
+                  <a:txBody>
+                    <a:bodyPr wrap="square"/>
+                    <a:lstStyle/>
+                    <a:p>
+                      <a:pPr algn="l"/>
+                      <a:r>
+                        <a:rPr sz="1050" b="0" i="0">
+                          <a:solidFill>
+                            <a:srgbClr val="1C1C1E"/>
+                          </a:solidFill>
+                          <a:latin typeface="Calibri"/>
+                          <a:ea typeface="Microsoft JhengHei"/>
+                        </a:rPr>
+                        <a:t>Vergara 2012</a:t>
+                      </a:r>
+                    </a:p>
+                  </a:txBody>
+                  <a:tcPr marL="73152" marR="73152" marT="27432" marB="27432" anchor="ctr">
+                    <a:solidFill>
+                      <a:srgbClr val="FFFFFF"/>
+                    </a:solidFill>
+                  </a:tcPr>
+                </a:tc>
+                <a:tc>
+                  <a:txBody>
+                    <a:bodyPr wrap="square"/>
+                    <a:lstStyle/>
+                    <a:p>
+                      <a:pPr algn="r"/>
+                      <a:r>
+                        <a:rPr sz="1050" b="0" i="0">
+                          <a:solidFill>
+                            <a:srgbClr val="1C1C1E"/>
+                          </a:solidFill>
+                          <a:latin typeface="Calibri"/>
+                          <a:ea typeface="Microsoft JhengHei"/>
+                        </a:rPr>
+                        <a:t>63.8 / 64.0</a:t>
+                      </a:r>
+                    </a:p>
+                  </a:txBody>
+                  <a:tcPr marL="73152" marR="73152" marT="27432" marB="27432" anchor="ctr">
+                    <a:solidFill>
+                      <a:srgbClr val="FFFFFF"/>
+                    </a:solidFill>
+                  </a:tcPr>
+                </a:tc>
+              </a:tr>
+              <a:tr h="301752">
+                <a:tc>
+                  <a:txBody>
+                    <a:bodyPr wrap="square"/>
+                    <a:lstStyle/>
+                    <a:p>
+                      <a:pPr algn="l"/>
+                      <a:r>
+                        <a:rPr sz="1050" b="0" i="0">
+                          <a:solidFill>
+                            <a:srgbClr val="1C1C1E"/>
+                          </a:solidFill>
+                          <a:latin typeface="Calibri"/>
+                          <a:ea typeface="Microsoft JhengHei"/>
+                        </a:rPr>
+                        <a:t>無標籤 target 樣本</a:t>
+                      </a:r>
+                    </a:p>
+                  </a:txBody>
+                  <a:tcPr marL="73152" marR="73152" marT="27432" marB="27432" anchor="ctr">
+                    <a:solidFill>
+                      <a:srgbClr val="FFFFFF"/>
+                    </a:solidFill>
+                  </a:tcPr>
+                </a:tc>
+                <a:tc>
+                  <a:txBody>
+                    <a:bodyPr wrap="square"/>
+                    <a:lstStyle/>
+                    <a:p>
+                      <a:pPr algn="l"/>
+                      <a:r>
+                        <a:rPr sz="1050" b="0" i="0">
+                          <a:solidFill>
+                            <a:srgbClr val="1C1C1E"/>
+                          </a:solidFill>
+                          <a:latin typeface="Calibri"/>
+                          <a:ea typeface="Microsoft JhengHei"/>
+                        </a:rPr>
+                        <a:t>ML-comgfk 流形正則化</a:t>
+                      </a:r>
+                    </a:p>
+                  </a:txBody>
+                  <a:tcPr marL="73152" marR="73152" marT="27432" marB="27432" anchor="ctr">
+                    <a:solidFill>
+                      <a:srgbClr val="FFFFFF"/>
+                    </a:solidFill>
+                  </a:tcPr>
+                </a:tc>
+                <a:tc>
+                  <a:txBody>
+                    <a:bodyPr wrap="square"/>
+                    <a:lstStyle/>
+                    <a:p>
+                      <a:pPr algn="l"/>
+                      <a:r>
+                        <a:rPr sz="1050" b="0" i="0">
+                          <a:solidFill>
+                            <a:srgbClr val="1C1C1E"/>
+                          </a:solidFill>
+                          <a:latin typeface="Calibri"/>
+                          <a:ea typeface="Microsoft JhengHei"/>
+                        </a:rPr>
+                        <a:t>Vergara 2012</a:t>
+                      </a:r>
+                    </a:p>
+                  </a:txBody>
+                  <a:tcPr marL="73152" marR="73152" marT="27432" marB="27432" anchor="ctr">
+                    <a:solidFill>
+                      <a:srgbClr val="FFFFFF"/>
+                    </a:solidFill>
+                  </a:tcPr>
+                </a:tc>
+                <a:tc>
+                  <a:txBody>
+                    <a:bodyPr wrap="square"/>
+                    <a:lstStyle/>
+                    <a:p>
+                      <a:pPr algn="r"/>
+                      <a:r>
+                        <a:rPr sz="1050" b="0" i="0">
+                          <a:solidFill>
+                            <a:srgbClr val="1C1C1E"/>
+                          </a:solidFill>
+                          <a:latin typeface="Calibri"/>
+                          <a:ea typeface="Microsoft JhengHei"/>
+                        </a:rPr>
+                        <a:t>67.3</a:t>
+                      </a:r>
+                    </a:p>
+                  </a:txBody>
+                  <a:tcPr marL="73152" marR="73152" marT="27432" marB="27432" anchor="ctr">
+                    <a:solidFill>
+                      <a:srgbClr val="FFFFFF"/>
+                    </a:solidFill>
+                  </a:tcPr>
+                </a:tc>
+              </a:tr>
+              <a:tr h="301752">
+                <a:tc>
+                  <a:txBody>
+                    <a:bodyPr wrap="square"/>
+                    <a:lstStyle/>
+                    <a:p>
+                      <a:pPr algn="l"/>
+                      <a:r>
+                        <a:rPr sz="1050" b="0" i="0">
+                          <a:solidFill>
+                            <a:srgbClr val="1C1C1E"/>
+                          </a:solidFill>
+                          <a:latin typeface="Calibri"/>
+                          <a:ea typeface="Microsoft JhengHei"/>
+                        </a:rPr>
+                        <a:t>無標籤 target 樣本</a:t>
+                      </a:r>
+                    </a:p>
+                  </a:txBody>
+                  <a:tcPr marL="73152" marR="73152" marT="27432" marB="27432" anchor="ctr">
+                    <a:solidFill>
+                      <a:srgbClr val="FFFFFF"/>
+                    </a:solidFill>
+                  </a:tcPr>
+                </a:tc>
+                <a:tc>
+                  <a:txBody>
+                    <a:bodyPr wrap="square"/>
+                    <a:lstStyle/>
+                    <a:p>
+                      <a:pPr algn="l"/>
+                      <a:r>
+                        <a:rPr sz="1050" b="0" i="0">
+                          <a:solidFill>
+                            <a:srgbClr val="1C1C1E"/>
+                          </a:solidFill>
+                          <a:latin typeface="Calibri"/>
+                          <a:ea typeface="Microsoft JhengHei"/>
+                        </a:rPr>
+                        <a:t>DRCA 子空間對齊</a:t>
+                      </a:r>
+                    </a:p>
+                  </a:txBody>
+                  <a:tcPr marL="73152" marR="73152" marT="27432" marB="27432" anchor="ctr">
+                    <a:solidFill>
+                      <a:srgbClr val="FFFFFF"/>
+                    </a:solidFill>
+                  </a:tcPr>
+                </a:tc>
+                <a:tc>
+                  <a:txBody>
+                    <a:bodyPr wrap="square"/>
+                    <a:lstStyle/>
+                    <a:p>
+                      <a:pPr algn="l"/>
+                      <a:r>
+                        <a:rPr sz="1050" b="0" i="0">
+                          <a:solidFill>
+                            <a:srgbClr val="1C1C1E"/>
+                          </a:solidFill>
+                          <a:latin typeface="Calibri"/>
+                          <a:ea typeface="Microsoft JhengHei"/>
+                        </a:rPr>
+                        <a:t>Zhang 2017</a:t>
+                      </a:r>
+                    </a:p>
+                  </a:txBody>
+                  <a:tcPr marL="73152" marR="73152" marT="27432" marB="27432" anchor="ctr">
+                    <a:solidFill>
+                      <a:srgbClr val="FFFFFF"/>
+                    </a:solidFill>
+                  </a:tcPr>
+                </a:tc>
+                <a:tc>
+                  <a:txBody>
+                    <a:bodyPr wrap="square"/>
+                    <a:lstStyle/>
+                    <a:p>
+                      <a:pPr algn="r"/>
+                      <a:r>
+                        <a:rPr sz="1050" b="0" i="0">
+                          <a:solidFill>
+                            <a:srgbClr val="1C1C1E"/>
+                          </a:solidFill>
+                          <a:latin typeface="Calibri"/>
+                          <a:ea typeface="Microsoft JhengHei"/>
+                        </a:rPr>
+                        <a:t>62.2</a:t>
+                      </a:r>
+                    </a:p>
+                  </a:txBody>
+                  <a:tcPr marL="73152" marR="73152" marT="27432" marB="27432" anchor="ctr">
+                    <a:solidFill>
+                      <a:srgbClr val="FFFFFF"/>
+                    </a:solidFill>
+                  </a:tcPr>
+                </a:tc>
+              </a:tr>
+              <a:tr h="301752">
+                <a:tc>
+                  <a:txBody>
+                    <a:bodyPr wrap="square"/>
+                    <a:lstStyle/>
+                    <a:p>
+                      <a:pPr algn="l"/>
+                      <a:r>
+                        <a:rPr sz="1050" b="0" i="0">
+                          <a:solidFill>
+                            <a:srgbClr val="1C1C1E"/>
+                          </a:solidFill>
+                          <a:latin typeface="Calibri"/>
+                          <a:ea typeface="Microsoft JhengHei"/>
+                        </a:rPr>
+                        <a:t>無標籤 target 樣本</a:t>
+                      </a:r>
+                    </a:p>
+                  </a:txBody>
+                  <a:tcPr marL="73152" marR="73152" marT="27432" marB="27432" anchor="ctr">
+                    <a:solidFill>
+                      <a:srgbClr val="FFFFFF"/>
+                    </a:solidFill>
+                  </a:tcPr>
+                </a:tc>
+                <a:tc>
+                  <a:txBody>
+                    <a:bodyPr wrap="square"/>
+                    <a:lstStyle/>
+                    <a:p>
+                      <a:pPr algn="l"/>
+                      <a:r>
+                        <a:rPr sz="1050" b="0" i="0">
+                          <a:solidFill>
+                            <a:srgbClr val="1C1C1E"/>
+                          </a:solidFill>
+                          <a:latin typeface="Calibri"/>
+                          <a:ea typeface="Microsoft JhengHei"/>
+                        </a:rPr>
+                        <a:t>D-DRCA 有判別力的子空間對齊</a:t>
+                      </a:r>
+                    </a:p>
+                  </a:txBody>
+                  <a:tcPr marL="73152" marR="73152" marT="27432" marB="27432" anchor="ctr">
+                    <a:solidFill>
+                      <a:srgbClr val="FFFFFF"/>
+                    </a:solidFill>
+                  </a:tcPr>
+                </a:tc>
+                <a:tc>
+                  <a:txBody>
+                    <a:bodyPr wrap="square"/>
+                    <a:lstStyle/>
+                    <a:p>
+                      <a:pPr algn="l"/>
+                      <a:r>
+                        <a:rPr sz="1050" b="0" i="0">
+                          <a:solidFill>
+                            <a:srgbClr val="1C1C1E"/>
+                          </a:solidFill>
+                          <a:latin typeface="Calibri"/>
+                          <a:ea typeface="Microsoft JhengHei"/>
+                        </a:rPr>
+                        <a:t>Yi 2019</a:t>
+                      </a:r>
+                    </a:p>
+                  </a:txBody>
+                  <a:tcPr marL="73152" marR="73152" marT="27432" marB="27432" anchor="ctr">
+                    <a:solidFill>
+                      <a:srgbClr val="FFFFFF"/>
+                    </a:solidFill>
+                  </a:tcPr>
+                </a:tc>
+                <a:tc>
+                  <a:txBody>
+                    <a:bodyPr wrap="square"/>
+                    <a:lstStyle/>
+                    <a:p>
+                      <a:pPr algn="r"/>
+                      <a:r>
+                        <a:rPr sz="1050" b="0" i="0">
+                          <a:solidFill>
+                            <a:srgbClr val="1C1C1E"/>
+                          </a:solidFill>
+                          <a:latin typeface="Calibri"/>
+                          <a:ea typeface="Microsoft JhengHei"/>
+                        </a:rPr>
+                        <a:t>73.8</a:t>
+                      </a:r>
+                    </a:p>
+                  </a:txBody>
+                  <a:tcPr marL="73152" marR="73152" marT="27432" marB="27432" anchor="ctr">
+                    <a:solidFill>
+                      <a:srgbClr val="FFFFFF"/>
+                    </a:solidFill>
+                  </a:tcPr>
+                </a:tc>
+              </a:tr>
+              <a:tr h="301752">
+                <a:tc>
+                  <a:txBody>
+                    <a:bodyPr wrap="square"/>
+                    <a:lstStyle/>
+                    <a:p>
+                      <a:pPr algn="l"/>
+                      <a:r>
+                        <a:rPr sz="1050" b="0" i="0">
+                          <a:solidFill>
+                            <a:srgbClr val="1C1C1E"/>
+                          </a:solidFill>
+                          <a:latin typeface="Calibri"/>
+                          <a:ea typeface="Microsoft JhengHei"/>
+                        </a:rPr>
+                        <a:t>無標籤 target，半批調參</a:t>
+                      </a:r>
+                    </a:p>
+                  </a:txBody>
+                  <a:tcPr marL="73152" marR="73152" marT="27432" marB="27432" anchor="ctr">
+                    <a:solidFill>
+                      <a:srgbClr val="FFFFFF"/>
+                    </a:solidFill>
+                  </a:tcPr>
+                </a:tc>
+                <a:tc>
+                  <a:txBody>
+                    <a:bodyPr wrap="square"/>
+                    <a:lstStyle/>
+                    <a:p>
+                      <a:pPr algn="l"/>
+                      <a:r>
+                        <a:rPr sz="1050" b="0" i="0">
+                          <a:solidFill>
+                            <a:srgbClr val="1C1C1E"/>
+                          </a:solidFill>
+                          <a:latin typeface="Calibri"/>
+                          <a:ea typeface="Microsoft JhengHei"/>
+                        </a:rPr>
+                        <a:t>KD-DM 知識蒸餾</a:t>
+                      </a:r>
+                    </a:p>
+                  </a:txBody>
+                  <a:tcPr marL="73152" marR="73152" marT="27432" marB="27432" anchor="ctr">
+                    <a:solidFill>
+                      <a:srgbClr val="FFFFFF"/>
+                    </a:solidFill>
+                  </a:tcPr>
+                </a:tc>
+                <a:tc>
+                  <a:txBody>
+                    <a:bodyPr wrap="square"/>
+                    <a:lstStyle/>
+                    <a:p>
+                      <a:pPr algn="l"/>
+                      <a:r>
+                        <a:rPr sz="1050" b="0" i="0">
+                          <a:solidFill>
+                            <a:srgbClr val="1C1C1E"/>
+                          </a:solidFill>
+                          <a:latin typeface="Calibri"/>
+                          <a:ea typeface="Microsoft JhengHei"/>
+                        </a:rPr>
+                        <a:t>KD 論文 2025</a:t>
+                      </a:r>
+                    </a:p>
+                  </a:txBody>
+                  <a:tcPr marL="73152" marR="73152" marT="27432" marB="27432" anchor="ctr">
+                    <a:solidFill>
+                      <a:srgbClr val="FFFFFF"/>
+                    </a:solidFill>
+                  </a:tcPr>
+                </a:tc>
+                <a:tc>
+                  <a:txBody>
+                    <a:bodyPr wrap="square"/>
+                    <a:lstStyle/>
+                    <a:p>
+                      <a:pPr algn="r"/>
+                      <a:r>
+                        <a:rPr sz="1050" b="0" i="0">
+                          <a:solidFill>
+                            <a:srgbClr val="1C1C1E"/>
+                          </a:solidFill>
+                          <a:latin typeface="Calibri"/>
+                          <a:ea typeface="Microsoft JhengHei"/>
+                        </a:rPr>
+                        <a:t>47.9</a:t>
+                      </a:r>
+                    </a:p>
+                  </a:txBody>
+                  <a:tcPr marL="73152" marR="73152" marT="27432" marB="27432" anchor="ctr">
+                    <a:solidFill>
+                      <a:srgbClr val="FFFFFF"/>
+                    </a:solidFill>
+                  </a:tcPr>
+                </a:tc>
+              </a:tr>
+              <a:tr h="301752">
+                <a:tc>
+                  <a:txBody>
+                    <a:bodyPr wrap="square"/>
+                    <a:lstStyle/>
+                    <a:p>
+                      <a:pPr algn="l"/>
+                      <a:r>
+                        <a:rPr sz="1050" b="0" i="0">
+                          <a:solidFill>
+                            <a:srgbClr val="1C1C1E"/>
+                          </a:solidFill>
+                          <a:latin typeface="Calibri"/>
+                          <a:ea typeface="Microsoft JhengHei"/>
+                        </a:rPr>
+                        <a:t>兩個 source batch + 無標籤</a:t>
+                      </a:r>
+                    </a:p>
+                  </a:txBody>
+                  <a:tcPr marL="73152" marR="73152" marT="27432" marB="27432" anchor="ctr">
+                    <a:solidFill>
+                      <a:srgbClr val="FFFFFF"/>
+                    </a:solidFill>
+                  </a:tcPr>
+                </a:tc>
+                <a:tc>
+                  <a:txBody>
+                    <a:bodyPr wrap="square"/>
+                    <a:lstStyle/>
+                    <a:p>
+                      <a:pPr algn="l"/>
+                      <a:r>
+                        <a:rPr sz="1050" b="0" i="0">
+                          <a:solidFill>
+                            <a:srgbClr val="1C1C1E"/>
+                          </a:solidFill>
+                          <a:latin typeface="Calibri"/>
+                          <a:ea typeface="Microsoft JhengHei"/>
+                        </a:rPr>
+                        <a:t>AMDS-PFFA 注意力多源域適應（加權平均）</a:t>
+                      </a:r>
+                    </a:p>
+                  </a:txBody>
+                  <a:tcPr marL="73152" marR="73152" marT="27432" marB="27432" anchor="ctr">
+                    <a:solidFill>
+                      <a:srgbClr val="FFFFFF"/>
+                    </a:solidFill>
+                  </a:tcPr>
+                </a:tc>
+                <a:tc>
+                  <a:txBody>
+                    <a:bodyPr wrap="square"/>
+                    <a:lstStyle/>
+                    <a:p>
+                      <a:pPr algn="l"/>
+                      <a:r>
+                        <a:rPr sz="1050" b="0" i="0">
+                          <a:solidFill>
+                            <a:srgbClr val="1C1C1E"/>
+                          </a:solidFill>
+                          <a:latin typeface="Calibri"/>
+                          <a:ea typeface="Microsoft JhengHei"/>
+                        </a:rPr>
+                        <a:t>2024</a:t>
+                      </a:r>
+                    </a:p>
+                  </a:txBody>
+                  <a:tcPr marL="73152" marR="73152" marT="27432" marB="27432" anchor="ctr">
+                    <a:solidFill>
+                      <a:srgbClr val="FFFFFF"/>
+                    </a:solidFill>
+                  </a:tcPr>
+                </a:tc>
+                <a:tc>
+                  <a:txBody>
+                    <a:bodyPr wrap="square"/>
+                    <a:lstStyle/>
+                    <a:p>
+                      <a:pPr algn="r"/>
+                      <a:r>
+                        <a:rPr sz="1050" b="0" i="0">
+                          <a:solidFill>
+                            <a:srgbClr val="1C1C1E"/>
+                          </a:solidFill>
+                          <a:latin typeface="Calibri"/>
+                          <a:ea typeface="Microsoft JhengHei"/>
+                        </a:rPr>
+                        <a:t>83.2</a:t>
+                      </a:r>
+                    </a:p>
+                  </a:txBody>
+                  <a:tcPr marL="73152" marR="73152" marT="27432" marB="27432" anchor="ctr">
+                    <a:solidFill>
+                      <a:srgbClr val="FFFFFF"/>
+                    </a:solidFill>
+                  </a:tcPr>
+                </a:tc>
+              </a:tr>
+              <a:tr h="301752">
+                <a:tc>
+                  <a:txBody>
+                    <a:bodyPr wrap="square"/>
+                    <a:lstStyle/>
+                    <a:p>
+                      <a:pPr algn="l"/>
+                      <a:r>
+                        <a:rPr sz="1050" b="0" i="0">
+                          <a:solidFill>
+                            <a:srgbClr val="1C1C1E"/>
+                          </a:solidFill>
+                          <a:latin typeface="Calibri"/>
+                          <a:ea typeface="Microsoft JhengHei"/>
+                        </a:rPr>
+                        <a:t>每批 20 筆有標籤</a:t>
+                      </a:r>
+                    </a:p>
+                  </a:txBody>
+                  <a:tcPr marL="73152" marR="73152" marT="27432" marB="27432" anchor="ctr">
+                    <a:solidFill>
+                      <a:srgbClr val="FFFFFF"/>
+                    </a:solidFill>
+                  </a:tcPr>
+                </a:tc>
+                <a:tc>
+                  <a:txBody>
+                    <a:bodyPr wrap="square"/>
+                    <a:lstStyle/>
+                    <a:p>
+                      <a:pPr algn="l"/>
+                      <a:r>
+                        <a:rPr sz="1050" b="0" i="0">
+                          <a:solidFill>
+                            <a:srgbClr val="1C1C1E"/>
+                          </a:solidFill>
+                          <a:latin typeface="Calibri"/>
+                          <a:ea typeface="Microsoft JhengHei"/>
+                        </a:rPr>
+                        <a:t>DAELM-S(20)</a:t>
+                      </a:r>
+                    </a:p>
+                  </a:txBody>
+                  <a:tcPr marL="73152" marR="73152" marT="27432" marB="27432" anchor="ctr">
+                    <a:solidFill>
+                      <a:srgbClr val="FFFFFF"/>
+                    </a:solidFill>
+                  </a:tcPr>
+                </a:tc>
+                <a:tc>
+                  <a:txBody>
+                    <a:bodyPr wrap="square"/>
+                    <a:lstStyle/>
+                    <a:p>
+                      <a:pPr algn="l"/>
+                      <a:r>
+                        <a:rPr sz="1050" b="0" i="0">
+                          <a:solidFill>
+                            <a:srgbClr val="1C1C1E"/>
+                          </a:solidFill>
+                          <a:latin typeface="Calibri"/>
+                          <a:ea typeface="Microsoft JhengHei"/>
+                        </a:rPr>
+                        <a:t>Zhang 2015</a:t>
+                      </a:r>
+                    </a:p>
+                  </a:txBody>
+                  <a:tcPr marL="73152" marR="73152" marT="27432" marB="27432" anchor="ctr">
+                    <a:solidFill>
+                      <a:srgbClr val="FFFFFF"/>
+                    </a:solidFill>
+                  </a:tcPr>
+                </a:tc>
+                <a:tc>
+                  <a:txBody>
+                    <a:bodyPr wrap="square"/>
+                    <a:lstStyle/>
+                    <a:p>
+                      <a:pPr algn="r"/>
+                      <a:r>
+                        <a:rPr sz="1050" b="0" i="0">
+                          <a:solidFill>
+                            <a:srgbClr val="1C1C1E"/>
+                          </a:solidFill>
+                          <a:latin typeface="Calibri"/>
+                          <a:ea typeface="Microsoft JhengHei"/>
+                        </a:rPr>
+                        <a:t>80.8</a:t>
+                      </a:r>
+                    </a:p>
+                  </a:txBody>
+                  <a:tcPr marL="73152" marR="73152" marT="27432" marB="27432" anchor="ctr">
+                    <a:solidFill>
+                      <a:srgbClr val="FFFFFF"/>
+                    </a:solidFill>
+                  </a:tcPr>
+                </a:tc>
+              </a:tr>
+              <a:tr h="301752">
+                <a:tc>
+                  <a:txBody>
+                    <a:bodyPr wrap="square"/>
+                    <a:lstStyle/>
+                    <a:p>
+                      <a:pPr algn="l"/>
+                      <a:r>
+                        <a:rPr sz="1050" b="0" i="0">
+                          <a:solidFill>
+                            <a:srgbClr val="1C1C1E"/>
+                          </a:solidFill>
+                          <a:latin typeface="Calibri"/>
+                          <a:ea typeface="Microsoft JhengHei"/>
+                        </a:rPr>
+                        <a:t>每批 50 筆有標籤</a:t>
+                      </a:r>
+                    </a:p>
+                  </a:txBody>
+                  <a:tcPr marL="73152" marR="73152" marT="27432" marB="27432" anchor="ctr">
+                    <a:solidFill>
+                      <a:srgbClr val="FFFFFF"/>
+                    </a:solidFill>
+                  </a:tcPr>
+                </a:tc>
+                <a:tc>
+                  <a:txBody>
+                    <a:bodyPr wrap="square"/>
+                    <a:lstStyle/>
+                    <a:p>
+                      <a:pPr algn="l"/>
+                      <a:r>
+                        <a:rPr sz="1050" b="0" i="0">
+                          <a:solidFill>
+                            <a:srgbClr val="1C1C1E"/>
+                          </a:solidFill>
+                          <a:latin typeface="Calibri"/>
+                          <a:ea typeface="Microsoft JhengHei"/>
+                        </a:rPr>
+                        <a:t>DAELM-T(50)</a:t>
+                      </a:r>
+                    </a:p>
+                  </a:txBody>
+                  <a:tcPr marL="73152" marR="73152" marT="27432" marB="27432" anchor="ctr">
+                    <a:solidFill>
+                      <a:srgbClr val="FFFFFF"/>
+                    </a:solidFill>
+                  </a:tcPr>
+                </a:tc>
+                <a:tc>
+                  <a:txBody>
+                    <a:bodyPr wrap="square"/>
+                    <a:lstStyle/>
+                    <a:p>
+                      <a:pPr algn="l"/>
+                      <a:r>
+                        <a:rPr sz="1050" b="0" i="0">
+                          <a:solidFill>
+                            <a:srgbClr val="1C1C1E"/>
+                          </a:solidFill>
+                          <a:latin typeface="Calibri"/>
+                          <a:ea typeface="Microsoft JhengHei"/>
+                        </a:rPr>
+                        <a:t>Zhang 2015</a:t>
+                      </a:r>
+                    </a:p>
+                  </a:txBody>
+                  <a:tcPr marL="73152" marR="73152" marT="27432" marB="27432" anchor="ctr">
+                    <a:solidFill>
+                      <a:srgbClr val="FFFFFF"/>
+                    </a:solidFill>
+                  </a:tcPr>
+                </a:tc>
+                <a:tc>
+                  <a:txBody>
+                    <a:bodyPr wrap="square"/>
+                    <a:lstStyle/>
+                    <a:p>
+                      <a:pPr algn="r"/>
+                      <a:r>
+                        <a:rPr sz="1050" b="0" i="0">
+                          <a:solidFill>
+                            <a:srgbClr val="1C1C1E"/>
+                          </a:solidFill>
+                          <a:latin typeface="Calibri"/>
+                          <a:ea typeface="Microsoft JhengHei"/>
+                        </a:rPr>
+                        <a:t>91.9</a:t>
+                      </a:r>
+                    </a:p>
+                  </a:txBody>
+                  <a:tcPr marL="73152" marR="73152" marT="27432" marB="27432" anchor="ctr">
+                    <a:solidFill>
+                      <a:srgbClr val="FFFFFF"/>
+                    </a:solidFill>
+                  </a:tcPr>
+                </a:tc>
+              </a:tr>
+            </a:tbl>
+          </a:graphicData>
+        </a:graphic>
+      </p:graphicFrame>
+      <p:sp>
+        <p:nvSpPr>
+          <p:cNvPr id="4" name="TextBox 3"/>
+          <p:cNvSpPr txBox="1"/>
+          <p:nvPr/>
+        </p:nvSpPr>
+        <p:spPr>
+          <a:xfrm>
+            <a:off x="8503920" y="1554480"/>
+            <a:ext cx="3154680" cy="5120640"/>
+          </a:xfrm>
+          <a:prstGeom prst="rect">
+            <a:avLst/>
+          </a:prstGeom>
+          <a:noFill/>
+        </p:spPr>
+        <p:txBody>
+          <a:bodyPr wrap="square" lIns="0" rIns="0" tIns="0" bIns="0" anchor="t">
+            <a:spAutoFit/>
+          </a:bodyPr>
+          <a:lstStyle/>
+          <a:p>
+            <a:pPr algn="l">
+              <a:spcAft>
+                <a:spcPts val="500"/>
+              </a:spcAft>
+            </a:pPr>
+            <a:r>
+              <a:rPr sz="1100" b="1" i="0">
+                <a:solidFill>
+                  <a:srgbClr val="EB6834"/>
+                </a:solidFill>
+                <a:latin typeface="Calibri"/>
+                <a:ea typeface="Microsoft JhengHei"/>
+              </a:rPr>
+              <a:t>▍ </a:t>
+            </a:r>
+            <a:r>
+              <a:rPr sz="1100" b="1" i="0">
+                <a:solidFill>
+                  <a:srgbClr val="1C1C1E"/>
+                </a:solidFill>
+                <a:latin typeface="Calibri"/>
+                <a:ea typeface="Microsoft JhengHei"/>
+              </a:rPr>
+              <a:t>不碰 target 的方法沒有一個超過 60%</a:t>
+            </a:r>
+          </a:p>
+          <a:p>
+            <a:pPr>
+              <a:spcAft>
+                <a:spcPts val="500"/>
+              </a:spcAft>
+            </a:pPr>
+            <a:r>
+              <a:rPr sz="1100" b="0" i="0">
+                <a:solidFill>
+                  <a:srgbClr val="EB6834"/>
+                </a:solidFill>
+                <a:latin typeface="Calibri"/>
+                <a:ea typeface="Microsoft JhengHei"/>
+              </a:rPr>
+              <a:t>•  </a:t>
+            </a:r>
+            <a:r>
+              <a:rPr sz="1100" b="0" i="0">
+                <a:solidFill>
+                  <a:srgbClr val="1C1C1E"/>
+                </a:solidFill>
+                <a:latin typeface="Calibri"/>
+                <a:ea typeface="Microsoft JhengHei"/>
+              </a:rPr>
+              <a:t>我們的 55.6 比原論文的 SVM 高 17 個百分點，與 OSC 持平；CDCNN 論文的 63.5 是這一列唯一的例外，而它的 Fig. 5 已被抓到用了 target 資料</a:t>
+            </a:r>
+          </a:p>
+          <a:p>
+            <a:pPr>
+              <a:spcAft>
+                <a:spcPts val="500"/>
+              </a:spcAft>
+            </a:pPr>
+            <a:r>
+              <a:rPr sz="1100" b="1" i="0">
+                <a:solidFill>
+                  <a:srgbClr val="EB6834"/>
+                </a:solidFill>
+                <a:latin typeface="Calibri"/>
+                <a:ea typeface="Microsoft JhengHei"/>
+              </a:rPr>
+              <a:t>▍ </a:t>
+            </a:r>
+            <a:r>
+              <a:rPr sz="1100" b="1" i="0">
+                <a:solidFill>
+                  <a:srgbClr val="1C1C1E"/>
+                </a:solidFill>
+                <a:latin typeface="Calibri"/>
+                <a:ea typeface="Microsoft JhengHei"/>
+              </a:rPr>
+              <a:t>跨過 60% 的做法清一色是看 target 的無標籤樣本做子空間對齊，DRCA 那一家</a:t>
+            </a:r>
+          </a:p>
+          <a:p>
+            <a:pPr>
+              <a:spcAft>
+                <a:spcPts val="500"/>
+              </a:spcAft>
+            </a:pPr>
+            <a:r>
+              <a:rPr sz="1100" b="0" i="0">
+                <a:solidFill>
+                  <a:srgbClr val="EB6834"/>
+                </a:solidFill>
+                <a:latin typeface="Calibri"/>
+                <a:ea typeface="Microsoft JhengHei"/>
+              </a:rPr>
+              <a:t>•  </a:t>
+            </a:r>
+            <a:r>
+              <a:rPr sz="1100" b="0" i="0">
+                <a:solidFill>
+                  <a:srgbClr val="1C1C1E"/>
+                </a:solidFill>
+                <a:latin typeface="Calibri"/>
+                <a:ea typeface="Microsoft JhengHei"/>
+              </a:rPr>
+              <a:t>DRCA 做的事和 v12 的投影幾乎一樣，差別是方向來自 source 與 target 的平均差，而不是 Batch 1 自己猜。這正好對上 v12 的失敗原因</a:t>
+            </a:r>
+          </a:p>
+          <a:p>
+            <a:pPr>
+              <a:spcAft>
+                <a:spcPts val="500"/>
+              </a:spcAft>
+            </a:pPr>
+            <a:r>
+              <a:rPr sz="1100" b="0" i="0">
+                <a:solidFill>
+                  <a:srgbClr val="EB6834"/>
+                </a:solidFill>
+                <a:latin typeface="Calibri"/>
+                <a:ea typeface="Microsoft JhengHei"/>
+              </a:rPr>
+              <a:t>•  </a:t>
+            </a:r>
+            <a:r>
+              <a:rPr sz="1100" b="0" i="0">
+                <a:solidFill>
+                  <a:srgbClr val="1C1C1E"/>
+                </a:solidFill>
+                <a:latin typeface="Calibri"/>
+                <a:ea typeface="Microsoft JhengHei"/>
+              </a:rPr>
+              <a:t>80% 以上要每批幾十筆有標籤的校正樣本，或兩個以上的 source batch</a:t>
+            </a:r>
+          </a:p>
+          <a:p>
+            <a:pPr>
+              <a:spcAft>
+                <a:spcPts val="500"/>
+              </a:spcAft>
+            </a:pPr>
+            <a:r>
+              <a:rPr sz="1100" b="1" i="0">
+                <a:solidFill>
+                  <a:srgbClr val="EB6834"/>
+                </a:solidFill>
+                <a:latin typeface="Calibri"/>
+                <a:ea typeface="Microsoft JhengHei"/>
+              </a:rPr>
+              <a:t>▍ </a:t>
+            </a:r>
+            <a:r>
+              <a:rPr sz="1100" b="1" i="0">
+                <a:solidFill>
+                  <a:srgbClr val="1C1C1E"/>
+                </a:solidFill>
+                <a:latin typeface="Calibri"/>
+                <a:ea typeface="Microsoft JhengHei"/>
+              </a:rPr>
+              <a:t>結論：這份資料集該用的設定是「無標籤 target 樣本可用於對齊」，那是文獻主流，也有明確對照組</a:t>
+            </a:r>
+          </a:p>
+        </p:txBody>
+      </p:sp>
+    </p:spTree>
+  </p:cSld>
+  <p:clrMapOvr>
+    <a:masterClrMapping/>
+  </p:clrMapOvr>
+</p:sld>
+</file>
+
+<file path=ppt/slides/slide17.xml><?xml version="1.0" encoding="utf-8"?>
 <p:sld xmlns:a="http://schemas.openxmlformats.org/drawingml/2006/main" xmlns:p="http://schemas.openxmlformats.org/presentationml/2006/main" xmlns:r="http://schemas.openxmlformats.org/officeDocument/2006/relationships">
   <p:cSld>
     <p:spTree>
@@ -8297,7 +11691,7 @@
                 <a:latin typeface="Calibri"/>
                 <a:ea typeface="Microsoft JhengHei"/>
               </a:rPr>
-              <a:t>唯一可分辨的槓桿是輸入端有方向的位移（+0.0214），而它的方向能從 Batch 1 自己估（cos 0.850）。任何後續結果都分五類與六類報告，Acetaldehyde 是共用方向方法的天花板。</a:t>
+              <a:t>文獻在同一設定下不碰 target 沒有人過 60%；過 60% 的全是用 target 無標籤樣本做子空間對齊（DRCA 62、D-DRCA 74）。v12 的投影程式把方向來源換成 target 平均差就是最簡單的版本。報告時明說是 unsupervised domain adaptation。</a:t>
             </a:r>
           </a:p>
         </p:txBody>
@@ -8310,7 +11704,7 @@
 </p:sld>
 </file>
 
-<file path=ppt/slides/slide16.xml><?xml version="1.0" encoding="utf-8"?>
+<file path=ppt/slides/slide18.xml><?xml version="1.0" encoding="utf-8"?>
 <p:sld xmlns:a="http://schemas.openxmlformats.org/drawingml/2006/main" xmlns:p="http://schemas.openxmlformats.org/presentationml/2006/main" xmlns:r="http://schemas.openxmlformats.org/officeDocument/2006/relationships">
   <p:cSld>
     <p:spTree>
@@ -8366,7 +11760,7 @@
         </p:nvGraphicFramePr>
         <p:xfrm>
           <a:off x="548640" y="1463040"/>
-          <a:ext cx="6949439" cy="3108960"/>
+          <a:ext cx="7132319" cy="3730752"/>
         </p:xfrm>
         <a:graphic>
           <a:graphicData uri="http://schemas.openxmlformats.org/drawingml/2006/table">
@@ -8375,9 +11769,9 @@
                 <a:tableStyleId>{5C22544A-7EE6-4342-B048-85BDC9FD1C3A}</a:tableStyleId>
               </a:tblPr>
               <a:tblGrid>
-                <a:gridCol w="555955"/>
-                <a:gridCol w="2779776"/>
-                <a:gridCol w="3613708"/>
+                <a:gridCol w="641908"/>
+                <a:gridCol w="2211019"/>
+                <a:gridCol w="4279392"/>
               </a:tblGrid>
               <a:tr h="310896">
                 <a:tc>
@@ -8387,7 +11781,7 @@
                     <a:p>
                       <a:pPr algn="ctr"/>
                       <a:r>
-                        <a:rPr sz="1100" b="1" i="0">
+                        <a:rPr sz="1050" b="1" i="0">
                           <a:solidFill>
                             <a:srgbClr val="FFFFFF"/>
                           </a:solidFill>
@@ -8411,7 +11805,7 @@
                     <a:p>
                       <a:pPr algn="l"/>
                       <a:r>
-                        <a:rPr sz="1100" b="1" i="0">
+                        <a:rPr sz="1050" b="1" i="0">
                           <a:solidFill>
                             <a:srgbClr val="FFFFFF"/>
                           </a:solidFill>
@@ -8435,7 +11829,7 @@
                     <a:p>
                       <a:pPr algn="l"/>
                       <a:r>
-                        <a:rPr sz="1100" b="1" i="0">
+                        <a:rPr sz="1050" b="1" i="0">
                           <a:solidFill>
                             <a:srgbClr val="FFFFFF"/>
                           </a:solidFill>
@@ -8461,7 +11855,7 @@
                     <a:p>
                       <a:pPr algn="ctr"/>
                       <a:r>
-                        <a:rPr sz="1100" b="0" i="0">
+                        <a:rPr sz="1050" b="0" i="0">
                           <a:solidFill>
                             <a:srgbClr val="1C1C1E"/>
                           </a:solidFill>
@@ -8485,7 +11879,7 @@
                     <a:p>
                       <a:pPr algn="l"/>
                       <a:r>
-                        <a:rPr sz="1100" b="0" i="0">
+                        <a:rPr sz="1050" b="0" i="0">
                           <a:solidFill>
                             <a:srgbClr val="1C1C1E"/>
                           </a:solidFill>
@@ -8509,7 +11903,7 @@
                     <a:p>
                       <a:pPr algn="l"/>
                       <a:r>
-                        <a:rPr sz="1100" b="0" i="0">
+                        <a:rPr sz="1050" b="0" i="0">
                           <a:solidFill>
                             <a:srgbClr val="1C1C1E"/>
                           </a:solidFill>
@@ -8535,7 +11929,7 @@
                     <a:p>
                       <a:pPr algn="ctr"/>
                       <a:r>
-                        <a:rPr sz="1100" b="0" i="0">
+                        <a:rPr sz="1050" b="0" i="0">
                           <a:solidFill>
                             <a:srgbClr val="1C1C1E"/>
                           </a:solidFill>
@@ -8559,7 +11953,7 @@
                     <a:p>
                       <a:pPr algn="l"/>
                       <a:r>
-                        <a:rPr sz="1100" b="0" i="0">
+                        <a:rPr sz="1050" b="0" i="0">
                           <a:solidFill>
                             <a:srgbClr val="1C1C1E"/>
                           </a:solidFill>
@@ -8583,7 +11977,7 @@
                     <a:p>
                       <a:pPr algn="l"/>
                       <a:r>
-                        <a:rPr sz="1100" b="0" i="0">
+                        <a:rPr sz="1050" b="0" i="0">
                           <a:solidFill>
                             <a:srgbClr val="1C1C1E"/>
                           </a:solidFill>
@@ -8609,7 +12003,7 @@
                     <a:p>
                       <a:pPr algn="ctr"/>
                       <a:r>
-                        <a:rPr sz="1100" b="0" i="0">
+                        <a:rPr sz="1050" b="0" i="0">
                           <a:solidFill>
                             <a:srgbClr val="1C1C1E"/>
                           </a:solidFill>
@@ -8633,7 +12027,7 @@
                     <a:p>
                       <a:pPr algn="l"/>
                       <a:r>
-                        <a:rPr sz="1100" b="0" i="0">
+                        <a:rPr sz="1050" b="0" i="0">
                           <a:solidFill>
                             <a:srgbClr val="1C1C1E"/>
                           </a:solidFill>
@@ -8657,7 +12051,7 @@
                     <a:p>
                       <a:pPr algn="l"/>
                       <a:r>
-                        <a:rPr sz="1100" b="0" i="0">
+                        <a:rPr sz="1050" b="0" i="0">
                           <a:solidFill>
                             <a:srgbClr val="1C1C1E"/>
                           </a:solidFill>
@@ -8683,7 +12077,7 @@
                     <a:p>
                       <a:pPr algn="ctr"/>
                       <a:r>
-                        <a:rPr sz="1100" b="0" i="0">
+                        <a:rPr sz="1050" b="0" i="0">
                           <a:solidFill>
                             <a:srgbClr val="1C1C1E"/>
                           </a:solidFill>
@@ -8707,7 +12101,7 @@
                     <a:p>
                       <a:pPr algn="l"/>
                       <a:r>
-                        <a:rPr sz="1100" b="0" i="0">
+                        <a:rPr sz="1050" b="0" i="0">
                           <a:solidFill>
                             <a:srgbClr val="1C1C1E"/>
                           </a:solidFill>
@@ -8731,7 +12125,7 @@
                     <a:p>
                       <a:pPr algn="l"/>
                       <a:r>
-                        <a:rPr sz="1100" b="0" i="0">
+                        <a:rPr sz="1050" b="0" i="0">
                           <a:solidFill>
                             <a:srgbClr val="1C1C1E"/>
                           </a:solidFill>
@@ -8757,7 +12151,7 @@
                     <a:p>
                       <a:pPr algn="ctr"/>
                       <a:r>
-                        <a:rPr sz="1100" b="0" i="0">
+                        <a:rPr sz="1050" b="0" i="0">
                           <a:solidFill>
                             <a:srgbClr val="1C1C1E"/>
                           </a:solidFill>
@@ -8781,7 +12175,7 @@
                     <a:p>
                       <a:pPr algn="l"/>
                       <a:r>
-                        <a:rPr sz="1100" b="0" i="0">
+                        <a:rPr sz="1050" b="0" i="0">
                           <a:solidFill>
                             <a:srgbClr val="1C1C1E"/>
                           </a:solidFill>
@@ -8805,7 +12199,7 @@
                     <a:p>
                       <a:pPr algn="l"/>
                       <a:r>
-                        <a:rPr sz="1100" b="0" i="0">
+                        <a:rPr sz="1050" b="0" i="0">
                           <a:solidFill>
                             <a:srgbClr val="1C1C1E"/>
                           </a:solidFill>
@@ -8831,7 +12225,7 @@
                     <a:p>
                       <a:pPr algn="ctr"/>
                       <a:r>
-                        <a:rPr sz="1100" b="0" i="0">
+                        <a:rPr sz="1050" b="0" i="0">
                           <a:solidFill>
                             <a:srgbClr val="1C1C1E"/>
                           </a:solidFill>
@@ -8855,7 +12249,7 @@
                     <a:p>
                       <a:pPr algn="l"/>
                       <a:r>
-                        <a:rPr sz="1100" b="0" i="0">
+                        <a:rPr sz="1050" b="0" i="0">
                           <a:solidFill>
                             <a:srgbClr val="1C1C1E"/>
                           </a:solidFill>
@@ -8879,7 +12273,7 @@
                     <a:p>
                       <a:pPr algn="l"/>
                       <a:r>
-                        <a:rPr sz="1100" b="0" i="0">
+                        <a:rPr sz="1050" b="0" i="0">
                           <a:solidFill>
                             <a:srgbClr val="1C1C1E"/>
                           </a:solidFill>
@@ -8905,7 +12299,7 @@
                     <a:p>
                       <a:pPr algn="ctr"/>
                       <a:r>
-                        <a:rPr sz="1100" b="0" i="0">
+                        <a:rPr sz="1050" b="0" i="0">
                           <a:solidFill>
                             <a:srgbClr val="1C1C1E"/>
                           </a:solidFill>
@@ -8929,7 +12323,7 @@
                     <a:p>
                       <a:pPr algn="l"/>
                       <a:r>
-                        <a:rPr sz="1100" b="0" i="0">
+                        <a:rPr sz="1050" b="0" i="0">
                           <a:solidFill>
                             <a:srgbClr val="1C1C1E"/>
                           </a:solidFill>
@@ -8953,7 +12347,7 @@
                     <a:p>
                       <a:pPr algn="l"/>
                       <a:r>
-                        <a:rPr sz="1100" b="0" i="0">
+                        <a:rPr sz="1050" b="0" i="0">
                           <a:solidFill>
                             <a:srgbClr val="1C1C1E"/>
                           </a:solidFill>
@@ -8979,7 +12373,7 @@
                     <a:p>
                       <a:pPr algn="ctr"/>
                       <a:r>
-                        <a:rPr sz="1100" b="0" i="0">
+                        <a:rPr sz="1050" b="0" i="0">
                           <a:solidFill>
                             <a:srgbClr val="1C1C1E"/>
                           </a:solidFill>
@@ -9003,7 +12397,7 @@
                     <a:p>
                       <a:pPr algn="l"/>
                       <a:r>
-                        <a:rPr sz="1100" b="0" i="0">
+                        <a:rPr sz="1050" b="0" i="0">
                           <a:solidFill>
                             <a:srgbClr val="1C1C1E"/>
                           </a:solidFill>
@@ -9027,14 +12421,14 @@
                     <a:p>
                       <a:pPr algn="l"/>
                       <a:r>
-                        <a:rPr sz="1100" b="0" i="0">
-                          <a:solidFill>
-                            <a:srgbClr val="1C1C1E"/>
-                          </a:solidFill>
-                          <a:latin typeface="Calibri"/>
-                          <a:ea typeface="Microsoft JhengHei"/>
-                        </a:rPr>
-                        <a:t>表格；runs/20260929T031927475103Z_baseline_ladder_full</a:t>
+                        <a:rPr sz="1050" b="0" i="0">
+                          <a:solidFill>
+                            <a:srgbClr val="1C1C1E"/>
+                          </a:solidFill>
+                          <a:latin typeface="Calibri"/>
+                          <a:ea typeface="Microsoft JhengHei"/>
+                        </a:rPr>
+                        <a:t>表格；run 20260929T031927475103Z</a:t>
                       </a:r>
                     </a:p>
                   </a:txBody>
@@ -9053,7 +12447,7 @@
                     <a:p>
                       <a:pPr algn="ctr"/>
                       <a:r>
-                        <a:rPr sz="1100" b="0" i="0">
+                        <a:rPr sz="1050" b="0" i="0">
                           <a:solidFill>
                             <a:srgbClr val="1C1C1E"/>
                           </a:solidFill>
@@ -9077,7 +12471,7 @@
                     <a:p>
                       <a:pPr algn="l"/>
                       <a:r>
-                        <a:rPr sz="1100" b="0" i="0">
+                        <a:rPr sz="1050" b="0" i="0">
                           <a:solidFill>
                             <a:srgbClr val="1C1C1E"/>
                           </a:solidFill>
@@ -9101,7 +12495,7 @@
                     <a:p>
                       <a:pPr algn="l"/>
                       <a:r>
-                        <a:rPr sz="1100" b="0" i="0">
+                        <a:rPr sz="1050" b="0" i="0">
                           <a:solidFill>
                             <a:srgbClr val="1C1C1E"/>
                           </a:solidFill>
@@ -9109,6 +12503,154 @@
                           <a:ea typeface="Microsoft JhengHei"/>
                         </a:rPr>
                         <a:t>configs/contrastive.json、src/loss.py</a:t>
+                      </a:r>
+                    </a:p>
+                  </a:txBody>
+                  <a:tcPr marL="73152" marR="73152" marT="27432" marB="27432" anchor="ctr">
+                    <a:solidFill>
+                      <a:srgbClr val="FFFFFF"/>
+                    </a:solidFill>
+                  </a:tcPr>
+                </a:tc>
+              </a:tr>
+              <a:tr h="310896">
+                <a:tc>
+                  <a:txBody>
+                    <a:bodyPr wrap="square"/>
+                    <a:lstStyle/>
+                    <a:p>
+                      <a:pPr algn="ctr"/>
+                      <a:r>
+                        <a:rPr sz="1050" b="0" i="0">
+                          <a:solidFill>
+                            <a:srgbClr val="1C1C1E"/>
+                          </a:solidFill>
+                          <a:latin typeface="Calibri"/>
+                          <a:ea typeface="Microsoft JhengHei"/>
+                        </a:rPr>
+                        <a:t>v12</a:t>
+                      </a:r>
+                    </a:p>
+                  </a:txBody>
+                  <a:tcPr marL="73152" marR="73152" marT="27432" marB="27432" anchor="ctr">
+                    <a:solidFill>
+                      <a:srgbClr val="FFFFFF"/>
+                    </a:solidFill>
+                  </a:tcPr>
+                </a:tc>
+                <a:tc>
+                  <a:txBody>
+                    <a:bodyPr wrap="square"/>
+                    <a:lstStyle/>
+                    <a:p>
+                      <a:pPr algn="l"/>
+                      <a:r>
+                        <a:rPr sz="1050" b="0" i="0">
+                          <a:solidFill>
+                            <a:srgbClr val="1C1C1E"/>
+                          </a:solidFill>
+                          <a:latin typeface="Calibri"/>
+                          <a:ea typeface="Microsoft JhengHei"/>
+                        </a:rPr>
+                        <a:t>—</a:t>
+                      </a:r>
+                    </a:p>
+                  </a:txBody>
+                  <a:tcPr marL="73152" marR="73152" marT="27432" marB="27432" anchor="ctr">
+                    <a:solidFill>
+                      <a:srgbClr val="FFFFFF"/>
+                    </a:solidFill>
+                  </a:tcPr>
+                </a:tc>
+                <a:tc>
+                  <a:txBody>
+                    <a:bodyPr wrap="square"/>
+                    <a:lstStyle/>
+                    <a:p>
+                      <a:pPr algn="l"/>
+                      <a:r>
+                        <a:rPr sz="1050" b="0" i="0">
+                          <a:solidFill>
+                            <a:srgbClr val="1C1C1E"/>
+                          </a:solidFill>
+                          <a:latin typeface="Calibri"/>
+                          <a:ea typeface="Microsoft JhengHei"/>
+                        </a:rPr>
+                        <a:t>batch1_drift_axis.png；run 20261005T145146298993Z</a:t>
+                      </a:r>
+                    </a:p>
+                  </a:txBody>
+                  <a:tcPr marL="73152" marR="73152" marT="27432" marB="27432" anchor="ctr">
+                    <a:solidFill>
+                      <a:srgbClr val="FFFFFF"/>
+                    </a:solidFill>
+                  </a:tcPr>
+                </a:tc>
+              </a:tr>
+              <a:tr h="310896">
+                <a:tc>
+                  <a:txBody>
+                    <a:bodyPr wrap="square"/>
+                    <a:lstStyle/>
+                    <a:p>
+                      <a:pPr algn="ctr"/>
+                      <a:r>
+                        <a:rPr sz="1050" b="0" i="0">
+                          <a:solidFill>
+                            <a:srgbClr val="1C1C1E"/>
+                          </a:solidFill>
+                          <a:latin typeface="Calibri"/>
+                          <a:ea typeface="Microsoft JhengHei"/>
+                        </a:rPr>
+                        <a:t>文獻</a:t>
+                      </a:r>
+                    </a:p>
+                  </a:txBody>
+                  <a:tcPr marL="73152" marR="73152" marT="27432" marB="27432" anchor="ctr">
+                    <a:solidFill>
+                      <a:srgbClr val="FFFFFF"/>
+                    </a:solidFill>
+                  </a:tcPr>
+                </a:tc>
+                <a:tc>
+                  <a:txBody>
+                    <a:bodyPr wrap="square"/>
+                    <a:lstStyle/>
+                    <a:p>
+                      <a:pPr algn="l"/>
+                      <a:r>
+                        <a:rPr sz="1050" b="0" i="0">
+                          <a:solidFill>
+                            <a:srgbClr val="1C1C1E"/>
+                          </a:solidFill>
+                          <a:latin typeface="Calibri"/>
+                          <a:ea typeface="Microsoft JhengHei"/>
+                        </a:rPr>
+                        <a:t>—</a:t>
+                      </a:r>
+                    </a:p>
+                  </a:txBody>
+                  <a:tcPr marL="73152" marR="73152" marT="27432" marB="27432" anchor="ctr">
+                    <a:solidFill>
+                      <a:srgbClr val="FFFFFF"/>
+                    </a:solidFill>
+                  </a:tcPr>
+                </a:tc>
+                <a:tc>
+                  <a:txBody>
+                    <a:bodyPr wrap="square"/>
+                    <a:lstStyle/>
+                    <a:p>
+                      <a:pPr algn="l"/>
+                      <a:r>
+                        <a:rPr sz="1050" b="0" i="0">
+                          <a:solidFill>
+                            <a:srgbClr val="1C1C1E"/>
+                          </a:solidFill>
+                          <a:latin typeface="Calibri"/>
+                          <a:ea typeface="Microsoft JhengHei"/>
+                        </a:rPr>
+                        <a:t>arXiv 1505.06405、1901.02321、2409.13167、2507.17071</a:t>
                       </a:r>
                     </a:p>
                   </a:txBody>
@@ -9294,6 +12836,33 @@
                 <a:ea typeface="Microsoft JhengHei"/>
               </a:rPr>
               <a:t>v10.0  runs/20260929T031927475103Z_baseline_ladder_full</a:t>
+            </a:r>
+          </a:p>
+          <a:p>
+            <a:pPr>
+              <a:spcAft>
+                <a:spcPts val="300"/>
+              </a:spcAft>
+            </a:pPr>
+            <a:r>
+              <a:rPr sz="1000" b="0" i="0">
+                <a:solidFill>
+                  <a:srgbClr val="1C1C1E"/>
+                </a:solidFill>
+                <a:latin typeface="Calibri"/>
+                <a:ea typeface="Microsoft JhengHei"/>
+              </a:rPr>
+              <a:t>     </a:t>
+            </a:r>
+            <a:r>
+              <a:rPr sz="1000" b="0" i="0">
+                <a:solidFill>
+                  <a:srgbClr val="66666E"/>
+                </a:solidFill>
+                <a:latin typeface="Calibri"/>
+                <a:ea typeface="Microsoft JhengHei"/>
+              </a:rPr>
+              <a:t>v12.0  runs/20261005T145146298993Z_baseline_ladder_full</a:t>
             </a:r>
           </a:p>
           <a:p>

</xml_diff>